<commit_message>
Add dedicated AI Advisor slide to the deck
Explains the Gemini agent in depth — client-side, grounded on live data,
never invents numbers, streaming, trilingual — with the live grounded-reply
screenshot.

Co-Authored-By: Claude Opus 4.8 (1M context) <noreply@anthropic.com>
</commit_message>
<xml_diff>
--- a/demo/PRAHARI_Orbital_Console.pptx
+++ b/demo/PRAHARI_Orbital_Console.pptx
@@ -18,9 +18,10 @@
     <p:sldId id="266" r:id="rId12"/>
     <p:sldId id="267" r:id="rId13"/>
     <p:sldId id="268" r:id="rId14"/>
+    <p:sldId id="269" r:id="rId15"/>
   </p:sldIdLst>
   <p:notesMasterIdLst>
-    <p:notesMasterId r:id="rId15"/>
+    <p:notesMasterId r:id="rId16"/>
   </p:notesMasterIdLst>
   <p:sldSz cx="12191695" cy="6858000"/>
   <p:notesSz cx="6858000" cy="12191695"/>
@@ -1144,6 +1145,94 @@
             <a:fld id="{F7021451-1387-4CA6-816F-3879F97B5CBC}" type="slidenum">
               <a:rPr lang="en-US"/>
               <a:t>13</a:t>
+            </a:fld>
+            <a:endParaRPr lang="en-US"/>
+          </a:p>
+        </p:txBody>
+      </p:sp>
+    </p:spTree>
+    <p:extLst>
+      <p:ext uri="{BB962C8B-B14F-4D97-AF65-F5344CB8AC3E}">
+        <p14:creationId xmlns:p14="http://schemas.microsoft.com/office/powerpoint/2010/main" val="1024086991"/>
+      </p:ext>
+    </p:extLst>
+  </p:cSld>
+  <p:clrMapOvr>
+    <a:masterClrMapping/>
+  </p:clrMapOvr>
+</p:notes>
+</file>
+
+<file path=ppt/notesSlides/notesSlide14.xml><?xml version="1.0" encoding="utf-8"?>
+<p:notes xmlns:a="http://schemas.openxmlformats.org/drawingml/2006/main" xmlns:r="http://schemas.openxmlformats.org/officeDocument/2006/relationships" xmlns:p="http://schemas.openxmlformats.org/presentationml/2006/main">
+  <p:cSld>
+    <p:spTree>
+      <p:nvGrpSpPr>
+        <p:cNvPr id="1" name=""/>
+        <p:cNvGrpSpPr/>
+        <p:nvPr/>
+      </p:nvGrpSpPr>
+      <p:grpSpPr>
+        <a:xfrm>
+          <a:off x="0" y="0"/>
+          <a:ext cx="0" cy="0"/>
+          <a:chOff x="0" y="0"/>
+          <a:chExt cx="0" cy="0"/>
+        </a:xfrm>
+      </p:grpSpPr>
+      <p:sp>
+        <p:nvSpPr>
+          <p:cNvPr id="2" name="Slide Image Placeholder 1"/>
+          <p:cNvSpPr>
+            <a:spLocks noGrp="1" noRot="1" noChangeAspect="1"/>
+          </p:cNvSpPr>
+          <p:nvPr>
+            <p:ph type="sldImg"/>
+          </p:nvPr>
+        </p:nvSpPr>
+        <p:spPr/>
+      </p:sp>
+      <p:sp>
+        <p:nvSpPr>
+          <p:cNvPr id="3" name="Notes Placeholder 2"/>
+          <p:cNvSpPr>
+            <a:spLocks noGrp="1"/>
+          </p:cNvSpPr>
+          <p:nvPr>
+            <p:ph type="body" idx="1"/>
+          </p:nvPr>
+        </p:nvSpPr>
+        <p:spPr/>
+        <p:txBody>
+          <a:bodyPr/>
+          <a:lstStyle/>
+          <a:p>
+            <a:r>
+              <a:rPr lang="en-US" dirty="0"/>
+              <a:t/>
+            </a:r>
+            <a:endParaRPr lang="en-US" dirty="0"/>
+          </a:p>
+        </p:txBody>
+      </p:sp>
+      <p:sp>
+        <p:nvSpPr>
+          <p:cNvPr id="4" name="Slide Number Placeholder 3"/>
+          <p:cNvSpPr>
+            <a:spLocks noGrp="1"/>
+          </p:cNvSpPr>
+          <p:nvPr>
+            <p:ph type="sldNum" sz="quarter" idx="10"/>
+          </p:nvPr>
+        </p:nvSpPr>
+        <p:spPr/>
+        <p:txBody>
+          <a:bodyPr/>
+          <a:lstStyle/>
+          <a:p>
+            <a:fld id="{F7021451-1387-4CA6-816F-3879F97B5CBC}" type="slidenum">
+              <a:rPr lang="en-US"/>
+              <a:t>14</a:t>
             </a:fld>
             <a:endParaRPr lang="en-US"/>
           </a:p>
@@ -2541,7 +2630,7 @@
                 <a:ea typeface="Calibri" pitchFamily="34" charset="-122"/>
                 <a:cs typeface="Calibri" pitchFamily="34" charset="-120"/>
               </a:rPr>
-              <a:t>HOW IT’S BUILT</a:t>
+              <a:t>ONE PLATFORM · TWO USERS</a:t>
             </a:r>
             <a:endParaRPr lang="en-US" sz="1200" dirty="0"/>
           </a:p>
@@ -2583,7 +2672,7 @@
                 <a:ea typeface="Cambria" pitchFamily="34" charset="-122"/>
                 <a:cs typeface="Cambria" pitchFamily="34" charset="-120"/>
               </a:rPr>
-              <a:t>Frontier data &amp; AI, deployable with no backend</a:t>
+              <a:t>From a control room to a coastal village</a:t>
             </a:r>
             <a:endParaRPr lang="en-US" sz="3400" dirty="0"/>
           </a:p>
@@ -2597,12 +2686,12 @@
         </p:nvSpPr>
         <p:spPr>
           <a:xfrm>
-            <a:off x="457200" y="2011680"/>
-            <a:ext cx="3639312" cy="3566160"/>
+            <a:off x="457200" y="1965960"/>
+            <a:ext cx="5532120" cy="3794760"/>
           </a:xfrm>
           <a:prstGeom prst="roundRect">
             <a:avLst>
-              <a:gd name="adj" fmla="val 3077"/>
+              <a:gd name="adj" fmla="val 2892"/>
             </a:avLst>
           </a:prstGeom>
           <a:solidFill>
@@ -2618,93 +2707,73 @@
       </p:sp>
       <p:sp>
         <p:nvSpPr>
-          <p:cNvPr id="5" name="Shape 3"/>
-          <p:cNvSpPr/>
-          <p:nvPr/>
-        </p:nvSpPr>
-        <p:spPr>
-          <a:xfrm>
-            <a:off x="731520" y="2286000"/>
-            <a:ext cx="310896" cy="310896"/>
-          </a:xfrm>
-          <a:prstGeom prst="ellipse">
-            <a:avLst/>
-          </a:prstGeom>
-          <a:solidFill>
-            <a:srgbClr val="38BDF8"/>
-          </a:solidFill>
-          <a:ln/>
-        </p:spPr>
-      </p:sp>
-      <p:sp>
-        <p:nvSpPr>
-          <p:cNvPr id="6" name="Text 4"/>
-          <p:cNvSpPr txBox="1"/>
-          <p:nvPr/>
-        </p:nvSpPr>
-        <p:spPr>
-          <a:xfrm>
-            <a:off x="1170432" y="2249424"/>
-            <a:ext cx="2834640" cy="457200"/>
-          </a:xfrm>
-          <a:prstGeom prst="rect">
-            <a:avLst/>
-          </a:prstGeom>
-          <a:noFill/>
-          <a:ln/>
-        </p:spPr>
-        <p:txBody>
-          <a:bodyPr wrap="square" lIns="0" tIns="0" rIns="0" bIns="0" rtlCol="0" anchor="ctr"/>
-          <a:lstStyle/>
-          <a:p>
-            <a:pPr indent="0" marL="0">
-              <a:buNone/>
-            </a:pPr>
-            <a:r>
-              <a:rPr lang="en-US" sz="1550" b="1" dirty="0">
-                <a:solidFill>
-                  <a:srgbClr val="FFFFFF"/>
+          <p:cNvPr id="5" name="Text 3"/>
+          <p:cNvSpPr txBox="1"/>
+          <p:nvPr/>
+        </p:nvSpPr>
+        <p:spPr>
+          <a:xfrm>
+            <a:off x="731520" y="2194560"/>
+            <a:ext cx="5029200" cy="457200"/>
+          </a:xfrm>
+          <a:prstGeom prst="rect">
+            <a:avLst/>
+          </a:prstGeom>
+          <a:noFill/>
+          <a:ln/>
+        </p:spPr>
+        <p:txBody>
+          <a:bodyPr wrap="square" lIns="0" tIns="0" rIns="0" bIns="0" rtlCol="0" anchor="ctr"/>
+          <a:lstStyle/>
+          <a:p>
+            <a:pPr indent="0" marL="0">
+              <a:buNone/>
+            </a:pPr>
+            <a:r>
+              <a:rPr lang="en-US" sz="1900" b="1" dirty="0">
+                <a:solidFill>
+                  <a:srgbClr val="38BDF8"/>
                 </a:solidFill>
                 <a:latin typeface="Cambria" pitchFamily="34" charset="0"/>
                 <a:ea typeface="Cambria" pitchFamily="34" charset="-122"/>
                 <a:cs typeface="Cambria" pitchFamily="34" charset="-120"/>
               </a:rPr>
-              <a:t>🌍 Rendering</a:t>
-            </a:r>
-            <a:endParaRPr lang="en-US" sz="1550" dirty="0"/>
-          </a:p>
-        </p:txBody>
-      </p:sp>
-      <p:sp>
-        <p:nvSpPr>
-          <p:cNvPr id="7" name="Text 5"/>
-          <p:cNvSpPr txBox="1"/>
-          <p:nvPr/>
-        </p:nvSpPr>
-        <p:spPr>
-          <a:xfrm>
-            <a:off x="749808" y="2880360"/>
-            <a:ext cx="3200400" cy="2560320"/>
-          </a:xfrm>
-          <a:prstGeom prst="rect">
-            <a:avLst/>
-          </a:prstGeom>
-          <a:noFill/>
-          <a:ln/>
-        </p:spPr>
-        <p:txBody>
-          <a:bodyPr wrap="square" lIns="0" tIns="0" rIns="0" bIns="0" rtlCol="0" anchor="ctr"/>
-          <a:lstStyle/>
-          <a:p>
-            <a:pPr marL="152400" indent="-152400">
+              <a:t>🛰  Disaster-management officer</a:t>
+            </a:r>
+            <a:endParaRPr lang="en-US" sz="1900" dirty="0"/>
+          </a:p>
+        </p:txBody>
+      </p:sp>
+      <p:sp>
+        <p:nvSpPr>
+          <p:cNvPr id="6" name="Text 4"/>
+          <p:cNvSpPr txBox="1"/>
+          <p:nvPr/>
+        </p:nvSpPr>
+        <p:spPr>
+          <a:xfrm>
+            <a:off x="777240" y="2788920"/>
+            <a:ext cx="4937760" cy="2834640"/>
+          </a:xfrm>
+          <a:prstGeom prst="rect">
+            <a:avLst/>
+          </a:prstGeom>
+          <a:noFill/>
+          <a:ln/>
+        </p:spPr>
+        <p:txBody>
+          <a:bodyPr wrap="square" lIns="0" tIns="0" rIns="0" bIns="0" rtlCol="0" anchor="ctr"/>
+          <a:lstStyle/>
+          <a:p>
+            <a:pPr marL="177800" indent="-177800">
               <a:spcAft>
-                <a:spcPts val="900"/>
+                <a:spcPts val="1200"/>
               </a:spcAft>
               <a:buSzPct val="100000"/>
               <a:buChar char="•"/>
             </a:pPr>
             <a:r>
-              <a:rPr lang="en-US" sz="1250" dirty="0">
+              <a:rPr lang="en-US" sz="1350" dirty="0">
                 <a:solidFill>
                   <a:srgbClr val="C7D6EC"/>
                 </a:solidFill>
@@ -2712,20 +2781,20 @@
                 <a:ea typeface="Calibri" pitchFamily="34" charset="-122"/>
                 <a:cs typeface="Calibri" pitchFamily="34" charset="-120"/>
               </a:rPr>
-              <a:t>MapLibre GL JS v5 adaptive globe</a:t>
-            </a:r>
-            <a:endParaRPr lang="en-US" sz="1250" dirty="0"/>
-          </a:p>
-          <a:p>
-            <a:pPr marL="152400" indent="-152400">
+              <a:t>Orbital view of the approaching storm</a:t>
+            </a:r>
+            <a:endParaRPr lang="en-US" sz="1350" dirty="0"/>
+          </a:p>
+          <a:p>
+            <a:pPr marL="177800" indent="-177800">
               <a:spcAft>
-                <a:spcPts val="900"/>
+                <a:spcPts val="1200"/>
               </a:spcAft>
               <a:buSzPct val="100000"/>
               <a:buChar char="•"/>
             </a:pPr>
             <a:r>
-              <a:rPr lang="en-US" sz="1250" dirty="0">
+              <a:rPr lang="en-US" sz="1350" dirty="0">
                 <a:solidFill>
                   <a:srgbClr val="C7D6EC"/>
                 </a:solidFill>
@@ -2733,20 +2802,20 @@
                 <a:ea typeface="Calibri" pitchFamily="34" charset="-122"/>
                 <a:cs typeface="Calibri" pitchFamily="34" charset="-120"/>
               </a:rPr>
-              <a:t>Three.js orbital 3D Earth</a:t>
-            </a:r>
-            <a:endParaRPr lang="en-US" sz="1250" dirty="0"/>
-          </a:p>
-          <a:p>
-            <a:pPr marL="152400" indent="-152400">
+              <a:t>Scrub the best-track to anticipate landfall</a:t>
+            </a:r>
+            <a:endParaRPr lang="en-US" sz="1350" dirty="0"/>
+          </a:p>
+          <a:p>
+            <a:pPr marL="177800" indent="-177800">
               <a:spcAft>
-                <a:spcPts val="900"/>
+                <a:spcPts val="1200"/>
               </a:spcAft>
               <a:buSzPct val="100000"/>
               <a:buChar char="•"/>
             </a:pPr>
             <a:r>
-              <a:rPr lang="en-US" sz="1250" dirty="0">
+              <a:rPr lang="en-US" sz="1350" dirty="0">
                 <a:solidFill>
                   <a:srgbClr val="C7D6EC"/>
                 </a:solidFill>
@@ -2754,26 +2823,47 @@
                 <a:ea typeface="Calibri" pitchFamily="34" charset="-122"/>
                 <a:cs typeface="Calibri" pitchFamily="34" charset="-120"/>
               </a:rPr>
-              <a:t>Runs entirely in the browser</a:t>
-            </a:r>
-            <a:endParaRPr lang="en-US" sz="1250" dirty="0"/>
-          </a:p>
-        </p:txBody>
-      </p:sp>
-      <p:sp>
-        <p:nvSpPr>
-          <p:cNvPr id="8" name="Shape 6"/>
+              <a:t>Rank wards; inspect shelters &amp; severed roads</a:t>
+            </a:r>
+            <a:endParaRPr lang="en-US" sz="1350" dirty="0"/>
+          </a:p>
+          <a:p>
+            <a:pPr marL="177800" indent="-177800">
+              <a:spcAft>
+                <a:spcPts val="1200"/>
+              </a:spcAft>
+              <a:buSzPct val="100000"/>
+              <a:buChar char="•"/>
+            </a:pPr>
+            <a:r>
+              <a:rPr lang="en-US" sz="1350" dirty="0">
+                <a:solidFill>
+                  <a:srgbClr val="C7D6EC"/>
+                </a:solidFill>
+                <a:latin typeface="Calibri" pitchFamily="34" charset="0"/>
+                <a:ea typeface="Calibri" pitchFamily="34" charset="-122"/>
+                <a:cs typeface="Calibri" pitchFamily="34" charset="-120"/>
+              </a:rPr>
+              <a:t>Ask the AI advisor — in English</a:t>
+            </a:r>
+            <a:endParaRPr lang="en-US" sz="1350" dirty="0"/>
+          </a:p>
+        </p:txBody>
+      </p:sp>
+      <p:sp>
+        <p:nvSpPr>
+          <p:cNvPr id="7" name="Shape 5"/>
           <p:cNvSpPr/>
           <p:nvPr/>
         </p:nvSpPr>
         <p:spPr>
           <a:xfrm>
-            <a:off x="4224528" y="2011680"/>
-            <a:ext cx="3639312" cy="3566160"/>
+            <a:off x="6199632" y="1965960"/>
+            <a:ext cx="5532120" cy="3794760"/>
           </a:xfrm>
           <a:prstGeom prst="roundRect">
             <a:avLst>
-              <a:gd name="adj" fmla="val 3077"/>
+              <a:gd name="adj" fmla="val 2892"/>
             </a:avLst>
           </a:prstGeom>
           <a:solidFill>
@@ -2789,93 +2879,73 @@
       </p:sp>
       <p:sp>
         <p:nvSpPr>
-          <p:cNvPr id="9" name="Shape 7"/>
-          <p:cNvSpPr/>
-          <p:nvPr/>
-        </p:nvSpPr>
-        <p:spPr>
-          <a:xfrm>
-            <a:off x="4498848" y="2286000"/>
-            <a:ext cx="310896" cy="310896"/>
-          </a:xfrm>
-          <a:prstGeom prst="ellipse">
-            <a:avLst/>
-          </a:prstGeom>
-          <a:solidFill>
-            <a:srgbClr val="34D399"/>
-          </a:solidFill>
-          <a:ln/>
-        </p:spPr>
-      </p:sp>
-      <p:sp>
-        <p:nvSpPr>
-          <p:cNvPr id="10" name="Text 8"/>
-          <p:cNvSpPr txBox="1"/>
-          <p:nvPr/>
-        </p:nvSpPr>
-        <p:spPr>
-          <a:xfrm>
-            <a:off x="4937760" y="2249424"/>
-            <a:ext cx="2834640" cy="457200"/>
-          </a:xfrm>
-          <a:prstGeom prst="rect">
-            <a:avLst/>
-          </a:prstGeom>
-          <a:noFill/>
-          <a:ln/>
-        </p:spPr>
-        <p:txBody>
-          <a:bodyPr wrap="square" lIns="0" tIns="0" rIns="0" bIns="0" rtlCol="0" anchor="ctr"/>
-          <a:lstStyle/>
-          <a:p>
-            <a:pPr indent="0" marL="0">
-              <a:buNone/>
-            </a:pPr>
-            <a:r>
-              <a:rPr lang="en-US" sz="1550" b="1" dirty="0">
-                <a:solidFill>
-                  <a:srgbClr val="FFFFFF"/>
+          <p:cNvPr id="8" name="Text 6"/>
+          <p:cNvSpPr txBox="1"/>
+          <p:nvPr/>
+        </p:nvSpPr>
+        <p:spPr>
+          <a:xfrm>
+            <a:off x="6473952" y="2194560"/>
+            <a:ext cx="5029200" cy="457200"/>
+          </a:xfrm>
+          <a:prstGeom prst="rect">
+            <a:avLst/>
+          </a:prstGeom>
+          <a:noFill/>
+          <a:ln/>
+        </p:spPr>
+        <p:txBody>
+          <a:bodyPr wrap="square" lIns="0" tIns="0" rIns="0" bIns="0" rtlCol="0" anchor="ctr"/>
+          <a:lstStyle/>
+          <a:p>
+            <a:pPr indent="0" marL="0">
+              <a:buNone/>
+            </a:pPr>
+            <a:r>
+              <a:rPr lang="en-US" sz="1900" b="1" dirty="0">
+                <a:solidFill>
+                  <a:srgbClr val="34D399"/>
                 </a:solidFill>
                 <a:latin typeface="Cambria" pitchFamily="34" charset="0"/>
                 <a:ea typeface="Cambria" pitchFamily="34" charset="-122"/>
                 <a:cs typeface="Cambria" pitchFamily="34" charset="-120"/>
               </a:rPr>
-              <a:t>🛰 Data &amp; AI</a:t>
-            </a:r>
-            <a:endParaRPr lang="en-US" sz="1550" dirty="0"/>
-          </a:p>
-        </p:txBody>
-      </p:sp>
-      <p:sp>
-        <p:nvSpPr>
-          <p:cNvPr id="11" name="Text 9"/>
-          <p:cNvSpPr txBox="1"/>
-          <p:nvPr/>
-        </p:nvSpPr>
-        <p:spPr>
-          <a:xfrm>
-            <a:off x="4517136" y="2880360"/>
-            <a:ext cx="3200400" cy="2560320"/>
-          </a:xfrm>
-          <a:prstGeom prst="rect">
-            <a:avLst/>
-          </a:prstGeom>
-          <a:noFill/>
-          <a:ln/>
-        </p:spPr>
-        <p:txBody>
-          <a:bodyPr wrap="square" lIns="0" tIns="0" rIns="0" bIns="0" rtlCol="0" anchor="ctr"/>
-          <a:lstStyle/>
-          <a:p>
-            <a:pPr marL="152400" indent="-152400">
+              <a:t>🌾  Farmer / citizen</a:t>
+            </a:r>
+            <a:endParaRPr lang="en-US" sz="1900" dirty="0"/>
+          </a:p>
+        </p:txBody>
+      </p:sp>
+      <p:sp>
+        <p:nvSpPr>
+          <p:cNvPr id="9" name="Text 7"/>
+          <p:cNvSpPr txBox="1"/>
+          <p:nvPr/>
+        </p:nvSpPr>
+        <p:spPr>
+          <a:xfrm>
+            <a:off x="6519672" y="2788920"/>
+            <a:ext cx="4937760" cy="2834640"/>
+          </a:xfrm>
+          <a:prstGeom prst="rect">
+            <a:avLst/>
+          </a:prstGeom>
+          <a:noFill/>
+          <a:ln/>
+        </p:spPr>
+        <p:txBody>
+          <a:bodyPr wrap="square" lIns="0" tIns="0" rIns="0" bIns="0" rtlCol="0" anchor="ctr"/>
+          <a:lstStyle/>
+          <a:p>
+            <a:pPr marL="177800" indent="-177800">
               <a:spcAft>
-                <a:spcPts val="900"/>
+                <a:spcPts val="1200"/>
               </a:spcAft>
               <a:buSzPct val="100000"/>
               <a:buChar char="•"/>
             </a:pPr>
             <a:r>
-              <a:rPr lang="en-US" sz="1250" dirty="0">
+              <a:rPr lang="en-US" sz="1350" dirty="0">
                 <a:solidFill>
                   <a:srgbClr val="C7D6EC"/>
                 </a:solidFill>
@@ -2883,20 +2953,20 @@
                 <a:ea typeface="Calibri" pitchFamily="34" charset="-122"/>
                 <a:cs typeface="Calibri" pitchFamily="34" charset="-120"/>
               </a:rPr>
-              <a:t>Google Earth Engine (SAR, DEM, WorldPop)</a:t>
-            </a:r>
-            <a:endParaRPr lang="en-US" sz="1250" dirty="0"/>
-          </a:p>
-          <a:p>
-            <a:pPr marL="152400" indent="-152400">
+              <a:t>Today’s weather for their town — in Odia</a:t>
+            </a:r>
+            <a:endParaRPr lang="en-US" sz="1350" dirty="0"/>
+          </a:p>
+          <a:p>
+            <a:pPr marL="177800" indent="-177800">
               <a:spcAft>
-                <a:spcPts val="900"/>
+                <a:spcPts val="1200"/>
               </a:spcAft>
               <a:buSzPct val="100000"/>
               <a:buChar char="•"/>
             </a:pPr>
             <a:r>
-              <a:rPr lang="en-US" sz="1250" dirty="0">
+              <a:rPr lang="en-US" sz="1350" dirty="0">
                 <a:solidFill>
                   <a:srgbClr val="C7D6EC"/>
                 </a:solidFill>
@@ -2904,20 +2974,20 @@
                 <a:ea typeface="Calibri" pitchFamily="34" charset="-122"/>
                 <a:cs typeface="Calibri" pitchFamily="34" charset="-120"/>
               </a:rPr>
-              <a:t>Gemini Flash advisor, grounded</a:t>
-            </a:r>
-            <a:endParaRPr lang="en-US" sz="1250" dirty="0"/>
-          </a:p>
-          <a:p>
-            <a:pPr marL="152400" indent="-152400">
+              <a:t>One tap shows the cyclone bearing down</a:t>
+            </a:r>
+            <a:endParaRPr lang="en-US" sz="1350" dirty="0"/>
+          </a:p>
+          <a:p>
+            <a:pPr marL="177800" indent="-177800">
               <a:spcAft>
-                <a:spcPts val="900"/>
+                <a:spcPts val="1200"/>
               </a:spcAft>
               <a:buSzPct val="100000"/>
               <a:buChar char="•"/>
             </a:pPr>
             <a:r>
-              <a:rPr lang="en-US" sz="1250" dirty="0">
+              <a:rPr lang="en-US" sz="1350" dirty="0">
                 <a:solidFill>
                   <a:srgbClr val="C7D6EC"/>
                 </a:solidFill>
@@ -2925,128 +2995,20 @@
                 <a:ea typeface="Calibri" pitchFamily="34" charset="-122"/>
                 <a:cs typeface="Calibri" pitchFamily="34" charset="-120"/>
               </a:rPr>
-              <a:t>Open-Meteo + RainViewer live weather</a:t>
-            </a:r>
-            <a:endParaRPr lang="en-US" sz="1250" dirty="0"/>
-          </a:p>
-        </p:txBody>
-      </p:sp>
-      <p:sp>
-        <p:nvSpPr>
-          <p:cNvPr id="12" name="Shape 10"/>
-          <p:cNvSpPr/>
-          <p:nvPr/>
-        </p:nvSpPr>
-        <p:spPr>
-          <a:xfrm>
-            <a:off x="7991856" y="2011680"/>
-            <a:ext cx="3639312" cy="3566160"/>
-          </a:xfrm>
-          <a:prstGeom prst="roundRect">
-            <a:avLst>
-              <a:gd name="adj" fmla="val 3077"/>
-            </a:avLst>
-          </a:prstGeom>
-          <a:solidFill>
-            <a:srgbClr val="13294B"/>
-          </a:solidFill>
-          <a:ln w="12700">
-            <a:solidFill>
-              <a:srgbClr val="27466F"/>
-            </a:solidFill>
-            <a:prstDash val="solid"/>
-          </a:ln>
-        </p:spPr>
-      </p:sp>
-      <p:sp>
-        <p:nvSpPr>
-          <p:cNvPr id="13" name="Shape 11"/>
-          <p:cNvSpPr/>
-          <p:nvPr/>
-        </p:nvSpPr>
-        <p:spPr>
-          <a:xfrm>
-            <a:off x="8266176" y="2286000"/>
-            <a:ext cx="310896" cy="310896"/>
-          </a:xfrm>
-          <a:prstGeom prst="ellipse">
-            <a:avLst/>
-          </a:prstGeom>
-          <a:solidFill>
-            <a:srgbClr val="FBBF24"/>
-          </a:solidFill>
-          <a:ln/>
-        </p:spPr>
-      </p:sp>
-      <p:sp>
-        <p:nvSpPr>
-          <p:cNvPr id="14" name="Text 12"/>
-          <p:cNvSpPr txBox="1"/>
-          <p:nvPr/>
-        </p:nvSpPr>
-        <p:spPr>
-          <a:xfrm>
-            <a:off x="8705088" y="2249424"/>
-            <a:ext cx="2834640" cy="457200"/>
-          </a:xfrm>
-          <a:prstGeom prst="rect">
-            <a:avLst/>
-          </a:prstGeom>
-          <a:noFill/>
-          <a:ln/>
-        </p:spPr>
-        <p:txBody>
-          <a:bodyPr wrap="square" lIns="0" tIns="0" rIns="0" bIns="0" rtlCol="0" anchor="ctr"/>
-          <a:lstStyle/>
-          <a:p>
-            <a:pPr indent="0" marL="0">
-              <a:buNone/>
-            </a:pPr>
-            <a:r>
-              <a:rPr lang="en-US" sz="1550" b="1" dirty="0">
-                <a:solidFill>
-                  <a:srgbClr val="FFFFFF"/>
-                </a:solidFill>
-                <a:latin typeface="Cambria" pitchFamily="34" charset="0"/>
-                <a:ea typeface="Cambria" pitchFamily="34" charset="-122"/>
-                <a:cs typeface="Cambria" pitchFamily="34" charset="-120"/>
-              </a:rPr>
-              <a:t>⚡ Deploy</a:t>
-            </a:r>
-            <a:endParaRPr lang="en-US" sz="1550" dirty="0"/>
-          </a:p>
-        </p:txBody>
-      </p:sp>
-      <p:sp>
-        <p:nvSpPr>
-          <p:cNvPr id="15" name="Text 13"/>
-          <p:cNvSpPr txBox="1"/>
-          <p:nvPr/>
-        </p:nvSpPr>
-        <p:spPr>
-          <a:xfrm>
-            <a:off x="8284464" y="2880360"/>
-            <a:ext cx="3200400" cy="2560320"/>
-          </a:xfrm>
-          <a:prstGeom prst="rect">
-            <a:avLst/>
-          </a:prstGeom>
-          <a:noFill/>
-          <a:ln/>
-        </p:spPr>
-        <p:txBody>
-          <a:bodyPr wrap="square" lIns="0" tIns="0" rIns="0" bIns="0" rtlCol="0" anchor="ctr"/>
-          <a:lstStyle/>
-          <a:p>
-            <a:pPr marL="152400" indent="-152400">
+              <a:t>Nearest shelter and the safe route</a:t>
+            </a:r>
+            <a:endParaRPr lang="en-US" sz="1350" dirty="0"/>
+          </a:p>
+          <a:p>
+            <a:pPr marL="177800" indent="-177800">
               <a:spcAft>
-                <a:spcPts val="900"/>
+                <a:spcPts val="1200"/>
               </a:spcAft>
               <a:buSzPct val="100000"/>
               <a:buChar char="•"/>
             </a:pPr>
             <a:r>
-              <a:rPr lang="en-US" sz="1250" dirty="0">
+              <a:rPr lang="en-US" sz="1350" dirty="0">
                 <a:solidFill>
                   <a:srgbClr val="C7D6EC"/>
                 </a:solidFill>
@@ -3054,96 +3016,54 @@
                 <a:ea typeface="Calibri" pitchFamily="34" charset="-122"/>
                 <a:cs typeface="Calibri" pitchFamily="34" charset="-120"/>
               </a:rPr>
-              <a:t>Pure static HTML/CSS/JS</a:t>
+              <a:t>Official advisory + AI answers, in Odia</a:t>
+            </a:r>
+            <a:endParaRPr lang="en-US" sz="1350" dirty="0"/>
+          </a:p>
+        </p:txBody>
+      </p:sp>
+      <p:sp>
+        <p:nvSpPr>
+          <p:cNvPr id="10" name="Text 8"/>
+          <p:cNvSpPr txBox="1"/>
+          <p:nvPr/>
+        </p:nvSpPr>
+        <p:spPr>
+          <a:xfrm>
+            <a:off x="457200" y="5943600"/>
+            <a:ext cx="11247120" cy="365760"/>
+          </a:xfrm>
+          <a:prstGeom prst="rect">
+            <a:avLst/>
+          </a:prstGeom>
+          <a:noFill/>
+          <a:ln/>
+        </p:spPr>
+        <p:txBody>
+          <a:bodyPr wrap="square" lIns="0" tIns="0" rIns="0" bIns="0" rtlCol="0" anchor="ctr"/>
+          <a:lstStyle/>
+          <a:p>
+            <a:pPr algn="ctr" indent="0" marL="0">
+              <a:buNone/>
+            </a:pPr>
+            <a:r>
+              <a:rPr lang="en-US" sz="1250" i="1" dirty="0">
+                <a:solidFill>
+                  <a:srgbClr val="93A5C0"/>
+                </a:solidFill>
+                <a:latin typeface="Calibri" pitchFamily="34" charset="0"/>
+                <a:ea typeface="Calibri" pitchFamily="34" charset="-122"/>
+                <a:cs typeface="Calibri" pitchFamily="34" charset="-120"/>
+              </a:rPr>
+              <a:t>Same fused hazard-and-exposure data — served to the responder who plans, and the citizen who acts.</a:t>
             </a:r>
             <a:endParaRPr lang="en-US" sz="1250" dirty="0"/>
           </a:p>
-          <a:p>
-            <a:pPr marL="152400" indent="-152400">
-              <a:spcAft>
-                <a:spcPts val="900"/>
-              </a:spcAft>
-              <a:buSzPct val="100000"/>
-              <a:buChar char="•"/>
-            </a:pPr>
-            <a:r>
-              <a:rPr lang="en-US" sz="1250" dirty="0">
-                <a:solidFill>
-                  <a:srgbClr val="C7D6EC"/>
-                </a:solidFill>
-                <a:latin typeface="Calibri" pitchFamily="34" charset="0"/>
-                <a:ea typeface="Calibri" pitchFamily="34" charset="-122"/>
-                <a:cs typeface="Calibri" pitchFamily="34" charset="-120"/>
-              </a:rPr>
-              <a:t>Any CDN, GitHub Pages, or field laptop</a:t>
-            </a:r>
-            <a:endParaRPr lang="en-US" sz="1250" dirty="0"/>
-          </a:p>
-          <a:p>
-            <a:pPr marL="152400" indent="-152400">
-              <a:spcAft>
-                <a:spcPts val="900"/>
-              </a:spcAft>
-              <a:buSzPct val="100000"/>
-              <a:buChar char="•"/>
-            </a:pPr>
-            <a:r>
-              <a:rPr lang="en-US" sz="1250" dirty="0">
-                <a:solidFill>
-                  <a:srgbClr val="C7D6EC"/>
-                </a:solidFill>
-                <a:latin typeface="Calibri" pitchFamily="34" charset="0"/>
-                <a:ea typeface="Calibri" pitchFamily="34" charset="-122"/>
-                <a:cs typeface="Calibri" pitchFamily="34" charset="-120"/>
-              </a:rPr>
-              <a:t>GEE tiles via optional Cloud Run proxy</a:t>
-            </a:r>
-            <a:endParaRPr lang="en-US" sz="1250" dirty="0"/>
-          </a:p>
-        </p:txBody>
-      </p:sp>
-      <p:sp>
-        <p:nvSpPr>
-          <p:cNvPr id="16" name="Text 14"/>
-          <p:cNvSpPr txBox="1"/>
-          <p:nvPr/>
-        </p:nvSpPr>
-        <p:spPr>
-          <a:xfrm>
-            <a:off x="457200" y="5742432"/>
-            <a:ext cx="11247120" cy="457200"/>
-          </a:xfrm>
-          <a:prstGeom prst="rect">
-            <a:avLst/>
-          </a:prstGeom>
-          <a:noFill/>
-          <a:ln/>
-        </p:spPr>
-        <p:txBody>
-          <a:bodyPr wrap="square" lIns="0" tIns="0" rIns="0" bIns="0" rtlCol="0" anchor="ctr"/>
-          <a:lstStyle/>
-          <a:p>
-            <a:pPr indent="0" marL="0">
-              <a:buNone/>
-            </a:pPr>
-            <a:r>
-              <a:rPr lang="en-US" sz="1200" i="1" dirty="0">
-                <a:solidFill>
-                  <a:srgbClr val="93A5C0"/>
-                </a:solidFill>
-                <a:latin typeface="Calibri" pitchFamily="34" charset="0"/>
-                <a:ea typeface="Calibri" pitchFamily="34" charset="-122"/>
-                <a:cs typeface="Calibri" pitchFamily="34" charset="-120"/>
-              </a:rPr>
-              <a:t>No servers to run means judges and field teams can open the live link and use it immediately.</a:t>
-            </a:r>
-            <a:endParaRPr lang="en-US" sz="1200" dirty="0"/>
-          </a:p>
-        </p:txBody>
-      </p:sp>
-      <p:sp>
-        <p:nvSpPr>
-          <p:cNvPr id="17" name="Text 15"/>
+        </p:txBody>
+      </p:sp>
+      <p:sp>
+        <p:nvSpPr>
+          <p:cNvPr id="11" name="Text 9"/>
           <p:cNvSpPr txBox="1"/>
           <p:nvPr/>
         </p:nvSpPr>
@@ -3196,7 +3116,7 @@
       </p:sp>
       <p:sp>
         <p:nvSpPr>
-          <p:cNvPr id="18" name="Text 16"/>
+          <p:cNvPr id="12" name="Text 10"/>
           <p:cNvSpPr txBox="1"/>
           <p:nvPr/>
         </p:nvSpPr>
@@ -3292,13 +3212,13 @@
             <a:r>
               <a:rPr lang="en-US" sz="1200" b="1" spc="300" kern="0" dirty="0">
                 <a:solidFill>
-                  <a:srgbClr val="FBBF24"/>
-                </a:solidFill>
-                <a:latin typeface="Calibri" pitchFamily="34" charset="0"/>
-                <a:ea typeface="Calibri" pitchFamily="34" charset="-122"/>
-                <a:cs typeface="Calibri" pitchFamily="34" charset="-120"/>
-              </a:rPr>
-              <a:t>WHAT’S NEXT</a:t>
+                  <a:srgbClr val="38BDF8"/>
+                </a:solidFill>
+                <a:latin typeface="Calibri" pitchFamily="34" charset="0"/>
+                <a:ea typeface="Calibri" pitchFamily="34" charset="-122"/>
+                <a:cs typeface="Calibri" pitchFamily="34" charset="-120"/>
+              </a:rPr>
+              <a:t>HOW IT’S BUILT</a:t>
             </a:r>
             <a:endParaRPr lang="en-US" sz="1200" dirty="0"/>
           </a:p>
@@ -3340,7 +3260,7 @@
                 <a:ea typeface="Cambria" pitchFamily="34" charset="-122"/>
                 <a:cs typeface="Cambria" pitchFamily="34" charset="-120"/>
               </a:rPr>
-              <a:t>From hackathon prototype to coastline-scale</a:t>
+              <a:t>Frontier data &amp; AI, deployable with no backend</a:t>
             </a:r>
             <a:endParaRPr lang="en-US" sz="3400" dirty="0"/>
           </a:p>
@@ -3354,12 +3274,12 @@
         </p:nvSpPr>
         <p:spPr>
           <a:xfrm>
-            <a:off x="457200" y="1965960"/>
-            <a:ext cx="5440680" cy="1737360"/>
+            <a:off x="457200" y="2011680"/>
+            <a:ext cx="3639312" cy="3566160"/>
           </a:xfrm>
           <a:prstGeom prst="roundRect">
             <a:avLst>
-              <a:gd name="adj" fmla="val 6316"/>
+              <a:gd name="adj" fmla="val 3077"/>
             </a:avLst>
           </a:prstGeom>
           <a:solidFill>
@@ -3381,8 +3301,8 @@
         </p:nvSpPr>
         <p:spPr>
           <a:xfrm>
-            <a:off x="713232" y="2221992"/>
-            <a:ext cx="146304" cy="146304"/>
+            <a:off x="731520" y="2286000"/>
+            <a:ext cx="310896" cy="310896"/>
           </a:xfrm>
           <a:prstGeom prst="ellipse">
             <a:avLst/>
@@ -3401,24 +3321,24 @@
         </p:nvSpPr>
         <p:spPr>
           <a:xfrm>
-            <a:off x="969264" y="2112264"/>
-            <a:ext cx="4663440" cy="457200"/>
-          </a:xfrm>
-          <a:prstGeom prst="rect">
-            <a:avLst/>
-          </a:prstGeom>
-          <a:noFill/>
-          <a:ln/>
-        </p:spPr>
-        <p:txBody>
-          <a:bodyPr wrap="square" lIns="0" tIns="0" rIns="0" bIns="0" rtlCol="0" anchor="ctr"/>
-          <a:lstStyle/>
-          <a:p>
-            <a:pPr indent="0" marL="0">
-              <a:buNone/>
-            </a:pPr>
-            <a:r>
-              <a:rPr lang="en-US" sz="1600" b="1" dirty="0">
+            <a:off x="1170432" y="2249424"/>
+            <a:ext cx="2834640" cy="457200"/>
+          </a:xfrm>
+          <a:prstGeom prst="rect">
+            <a:avLst/>
+          </a:prstGeom>
+          <a:noFill/>
+          <a:ln/>
+        </p:spPr>
+        <p:txBody>
+          <a:bodyPr wrap="square" lIns="0" tIns="0" rIns="0" bIns="0" rtlCol="0" anchor="ctr"/>
+          <a:lstStyle/>
+          <a:p>
+            <a:pPr indent="0" marL="0">
+              <a:buNone/>
+            </a:pPr>
+            <a:r>
+              <a:rPr lang="en-US" sz="1550" b="1" dirty="0">
                 <a:solidFill>
                   <a:srgbClr val="FFFFFF"/>
                 </a:solidFill>
@@ -3426,9 +3346,9 @@
                 <a:ea typeface="Cambria" pitchFamily="34" charset="-122"/>
                 <a:cs typeface="Cambria" pitchFamily="34" charset="-120"/>
               </a:rPr>
-              <a:t>Live GEE tiles by default</a:t>
-            </a:r>
-            <a:endParaRPr lang="en-US" sz="1600" dirty="0"/>
+              <a:t>🌍 Rendering</a:t>
+            </a:r>
+            <a:endParaRPr lang="en-US" sz="1550" dirty="0"/>
           </a:p>
         </p:txBody>
       </p:sp>
@@ -3440,24 +3360,25 @@
         </p:nvSpPr>
         <p:spPr>
           <a:xfrm>
-            <a:off x="731520" y="2624328"/>
-            <a:ext cx="4937760" cy="914400"/>
-          </a:xfrm>
-          <a:prstGeom prst="rect">
-            <a:avLst/>
-          </a:prstGeom>
-          <a:noFill/>
-          <a:ln/>
-        </p:spPr>
-        <p:txBody>
-          <a:bodyPr wrap="square" lIns="0" tIns="0" rIns="0" bIns="0" rtlCol="0" anchor="ctr"/>
-          <a:lstStyle/>
-          <a:p>
-            <a:pPr indent="0" marL="0">
-              <a:lnSpc>
-                <a:spcPct val="105000"/>
-              </a:lnSpc>
-              <a:buNone/>
+            <a:off x="749808" y="2880360"/>
+            <a:ext cx="3200400" cy="2560320"/>
+          </a:xfrm>
+          <a:prstGeom prst="rect">
+            <a:avLst/>
+          </a:prstGeom>
+          <a:noFill/>
+          <a:ln/>
+        </p:spPr>
+        <p:txBody>
+          <a:bodyPr wrap="square" lIns="0" tIns="0" rIns="0" bIns="0" rtlCol="0" anchor="ctr"/>
+          <a:lstStyle/>
+          <a:p>
+            <a:pPr marL="152400" indent="-152400">
+              <a:spcAft>
+                <a:spcPts val="900"/>
+              </a:spcAft>
+              <a:buSzPct val="100000"/>
+              <a:buChar char="•"/>
             </a:pPr>
             <a:r>
               <a:rPr lang="en-US" sz="1250" dirty="0">
@@ -3468,7 +3389,49 @@
                 <a:ea typeface="Calibri" pitchFamily="34" charset="-122"/>
                 <a:cs typeface="Calibri" pitchFamily="34" charset="-120"/>
               </a:rPr>
-              <a:t>Ship the Cloud Run tile proxy so SAR flood &amp; DEM surge stream in without setup.</a:t>
+              <a:t>MapLibre GL JS v5 adaptive globe</a:t>
+            </a:r>
+            <a:endParaRPr lang="en-US" sz="1250" dirty="0"/>
+          </a:p>
+          <a:p>
+            <a:pPr marL="152400" indent="-152400">
+              <a:spcAft>
+                <a:spcPts val="900"/>
+              </a:spcAft>
+              <a:buSzPct val="100000"/>
+              <a:buChar char="•"/>
+            </a:pPr>
+            <a:r>
+              <a:rPr lang="en-US" sz="1250" dirty="0">
+                <a:solidFill>
+                  <a:srgbClr val="C7D6EC"/>
+                </a:solidFill>
+                <a:latin typeface="Calibri" pitchFamily="34" charset="0"/>
+                <a:ea typeface="Calibri" pitchFamily="34" charset="-122"/>
+                <a:cs typeface="Calibri" pitchFamily="34" charset="-120"/>
+              </a:rPr>
+              <a:t>Three.js orbital 3D Earth</a:t>
+            </a:r>
+            <a:endParaRPr lang="en-US" sz="1250" dirty="0"/>
+          </a:p>
+          <a:p>
+            <a:pPr marL="152400" indent="-152400">
+              <a:spcAft>
+                <a:spcPts val="900"/>
+              </a:spcAft>
+              <a:buSzPct val="100000"/>
+              <a:buChar char="•"/>
+            </a:pPr>
+            <a:r>
+              <a:rPr lang="en-US" sz="1250" dirty="0">
+                <a:solidFill>
+                  <a:srgbClr val="C7D6EC"/>
+                </a:solidFill>
+                <a:latin typeface="Calibri" pitchFamily="34" charset="0"/>
+                <a:ea typeface="Calibri" pitchFamily="34" charset="-122"/>
+                <a:cs typeface="Calibri" pitchFamily="34" charset="-120"/>
+              </a:rPr>
+              <a:t>Runs entirely in the browser</a:t>
             </a:r>
             <a:endParaRPr lang="en-US" sz="1250" dirty="0"/>
           </a:p>
@@ -3482,12 +3445,12 @@
         </p:nvSpPr>
         <p:spPr>
           <a:xfrm>
-            <a:off x="6126480" y="1965960"/>
-            <a:ext cx="5440680" cy="1737360"/>
+            <a:off x="4224528" y="2011680"/>
+            <a:ext cx="3639312" cy="3566160"/>
           </a:xfrm>
           <a:prstGeom prst="roundRect">
             <a:avLst>
-              <a:gd name="adj" fmla="val 6316"/>
+              <a:gd name="adj" fmla="val 3077"/>
             </a:avLst>
           </a:prstGeom>
           <a:solidFill>
@@ -3509,14 +3472,14 @@
         </p:nvSpPr>
         <p:spPr>
           <a:xfrm>
-            <a:off x="6382512" y="2221992"/>
-            <a:ext cx="146304" cy="146304"/>
+            <a:off x="4498848" y="2286000"/>
+            <a:ext cx="310896" cy="310896"/>
           </a:xfrm>
           <a:prstGeom prst="ellipse">
             <a:avLst/>
           </a:prstGeom>
           <a:solidFill>
-            <a:srgbClr val="FBBF24"/>
+            <a:srgbClr val="34D399"/>
           </a:solidFill>
           <a:ln/>
         </p:spPr>
@@ -3529,24 +3492,24 @@
         </p:nvSpPr>
         <p:spPr>
           <a:xfrm>
-            <a:off x="6638544" y="2112264"/>
-            <a:ext cx="4663440" cy="457200"/>
-          </a:xfrm>
-          <a:prstGeom prst="rect">
-            <a:avLst/>
-          </a:prstGeom>
-          <a:noFill/>
-          <a:ln/>
-        </p:spPr>
-        <p:txBody>
-          <a:bodyPr wrap="square" lIns="0" tIns="0" rIns="0" bIns="0" rtlCol="0" anchor="ctr"/>
-          <a:lstStyle/>
-          <a:p>
-            <a:pPr indent="0" marL="0">
-              <a:buNone/>
-            </a:pPr>
-            <a:r>
-              <a:rPr lang="en-US" sz="1600" b="1" dirty="0">
+            <a:off x="4937760" y="2249424"/>
+            <a:ext cx="2834640" cy="457200"/>
+          </a:xfrm>
+          <a:prstGeom prst="rect">
+            <a:avLst/>
+          </a:prstGeom>
+          <a:noFill/>
+          <a:ln/>
+        </p:spPr>
+        <p:txBody>
+          <a:bodyPr wrap="square" lIns="0" tIns="0" rIns="0" bIns="0" rtlCol="0" anchor="ctr"/>
+          <a:lstStyle/>
+          <a:p>
+            <a:pPr indent="0" marL="0">
+              <a:buNone/>
+            </a:pPr>
+            <a:r>
+              <a:rPr lang="en-US" sz="1550" b="1" dirty="0">
                 <a:solidFill>
                   <a:srgbClr val="FFFFFF"/>
                 </a:solidFill>
@@ -3554,9 +3517,9 @@
                 <a:ea typeface="Cambria" pitchFamily="34" charset="-122"/>
                 <a:cs typeface="Cambria" pitchFamily="34" charset="-120"/>
               </a:rPr>
-              <a:t>More coastlines</a:t>
-            </a:r>
-            <a:endParaRPr lang="en-US" sz="1600" dirty="0"/>
+              <a:t>🛰 Data &amp; AI</a:t>
+            </a:r>
+            <a:endParaRPr lang="en-US" sz="1550" dirty="0"/>
           </a:p>
         </p:txBody>
       </p:sp>
@@ -3568,24 +3531,25 @@
         </p:nvSpPr>
         <p:spPr>
           <a:xfrm>
-            <a:off x="6400800" y="2624328"/>
-            <a:ext cx="4937760" cy="914400"/>
-          </a:xfrm>
-          <a:prstGeom prst="rect">
-            <a:avLst/>
-          </a:prstGeom>
-          <a:noFill/>
-          <a:ln/>
-        </p:spPr>
-        <p:txBody>
-          <a:bodyPr wrap="square" lIns="0" tIns="0" rIns="0" bIns="0" rtlCol="0" anchor="ctr"/>
-          <a:lstStyle/>
-          <a:p>
-            <a:pPr indent="0" marL="0">
-              <a:lnSpc>
-                <a:spcPct val="105000"/>
-              </a:lnSpc>
-              <a:buNone/>
+            <a:off x="4517136" y="2880360"/>
+            <a:ext cx="3200400" cy="2560320"/>
+          </a:xfrm>
+          <a:prstGeom prst="rect">
+            <a:avLst/>
+          </a:prstGeom>
+          <a:noFill/>
+          <a:ln/>
+        </p:spPr>
+        <p:txBody>
+          <a:bodyPr wrap="square" lIns="0" tIns="0" rIns="0" bIns="0" rtlCol="0" anchor="ctr"/>
+          <a:lstStyle/>
+          <a:p>
+            <a:pPr marL="152400" indent="-152400">
+              <a:spcAft>
+                <a:spcPts val="900"/>
+              </a:spcAft>
+              <a:buSzPct val="100000"/>
+              <a:buChar char="•"/>
             </a:pPr>
             <a:r>
               <a:rPr lang="en-US" sz="1250" dirty="0">
@@ -3596,7 +3560,49 @@
                 <a:ea typeface="Calibri" pitchFamily="34" charset="-122"/>
                 <a:cs typeface="Calibri" pitchFamily="34" charset="-120"/>
               </a:rPr>
-              <a:t>Onboard new districts by pointing the pipeline at fresh AOIs — Andhra, West Bengal, Tamil Nadu.</a:t>
+              <a:t>Google Earth Engine (SAR, DEM, WorldPop)</a:t>
+            </a:r>
+            <a:endParaRPr lang="en-US" sz="1250" dirty="0"/>
+          </a:p>
+          <a:p>
+            <a:pPr marL="152400" indent="-152400">
+              <a:spcAft>
+                <a:spcPts val="900"/>
+              </a:spcAft>
+              <a:buSzPct val="100000"/>
+              <a:buChar char="•"/>
+            </a:pPr>
+            <a:r>
+              <a:rPr lang="en-US" sz="1250" dirty="0">
+                <a:solidFill>
+                  <a:srgbClr val="C7D6EC"/>
+                </a:solidFill>
+                <a:latin typeface="Calibri" pitchFamily="34" charset="0"/>
+                <a:ea typeface="Calibri" pitchFamily="34" charset="-122"/>
+                <a:cs typeface="Calibri" pitchFamily="34" charset="-120"/>
+              </a:rPr>
+              <a:t>Gemini Flash advisor, grounded</a:t>
+            </a:r>
+            <a:endParaRPr lang="en-US" sz="1250" dirty="0"/>
+          </a:p>
+          <a:p>
+            <a:pPr marL="152400" indent="-152400">
+              <a:spcAft>
+                <a:spcPts val="900"/>
+              </a:spcAft>
+              <a:buSzPct val="100000"/>
+              <a:buChar char="•"/>
+            </a:pPr>
+            <a:r>
+              <a:rPr lang="en-US" sz="1250" dirty="0">
+                <a:solidFill>
+                  <a:srgbClr val="C7D6EC"/>
+                </a:solidFill>
+                <a:latin typeface="Calibri" pitchFamily="34" charset="0"/>
+                <a:ea typeface="Calibri" pitchFamily="34" charset="-122"/>
+                <a:cs typeface="Calibri" pitchFamily="34" charset="-120"/>
+              </a:rPr>
+              <a:t>Open-Meteo + RainViewer live weather</a:t>
             </a:r>
             <a:endParaRPr lang="en-US" sz="1250" dirty="0"/>
           </a:p>
@@ -3610,12 +3616,12 @@
         </p:nvSpPr>
         <p:spPr>
           <a:xfrm>
-            <a:off x="457200" y="3840480"/>
-            <a:ext cx="5440680" cy="1737360"/>
+            <a:off x="7991856" y="2011680"/>
+            <a:ext cx="3639312" cy="3566160"/>
           </a:xfrm>
           <a:prstGeom prst="roundRect">
             <a:avLst>
-              <a:gd name="adj" fmla="val 6316"/>
+              <a:gd name="adj" fmla="val 3077"/>
             </a:avLst>
           </a:prstGeom>
           <a:solidFill>
@@ -3637,14 +3643,14 @@
         </p:nvSpPr>
         <p:spPr>
           <a:xfrm>
-            <a:off x="713232" y="4096512"/>
-            <a:ext cx="146304" cy="146304"/>
+            <a:off x="8266176" y="2286000"/>
+            <a:ext cx="310896" cy="310896"/>
           </a:xfrm>
           <a:prstGeom prst="ellipse">
             <a:avLst/>
           </a:prstGeom>
           <a:solidFill>
-            <a:srgbClr val="34D399"/>
+            <a:srgbClr val="FBBF24"/>
           </a:solidFill>
           <a:ln/>
         </p:spPr>
@@ -3657,24 +3663,24 @@
         </p:nvSpPr>
         <p:spPr>
           <a:xfrm>
-            <a:off x="969264" y="3986784"/>
-            <a:ext cx="4663440" cy="457200"/>
-          </a:xfrm>
-          <a:prstGeom prst="rect">
-            <a:avLst/>
-          </a:prstGeom>
-          <a:noFill/>
-          <a:ln/>
-        </p:spPr>
-        <p:txBody>
-          <a:bodyPr wrap="square" lIns="0" tIns="0" rIns="0" bIns="0" rtlCol="0" anchor="ctr"/>
-          <a:lstStyle/>
-          <a:p>
-            <a:pPr indent="0" marL="0">
-              <a:buNone/>
-            </a:pPr>
-            <a:r>
-              <a:rPr lang="en-US" sz="1600" b="1" dirty="0">
+            <a:off x="8705088" y="2249424"/>
+            <a:ext cx="2834640" cy="457200"/>
+          </a:xfrm>
+          <a:prstGeom prst="rect">
+            <a:avLst/>
+          </a:prstGeom>
+          <a:noFill/>
+          <a:ln/>
+        </p:spPr>
+        <p:txBody>
+          <a:bodyPr wrap="square" lIns="0" tIns="0" rIns="0" bIns="0" rtlCol="0" anchor="ctr"/>
+          <a:lstStyle/>
+          <a:p>
+            <a:pPr indent="0" marL="0">
+              <a:buNone/>
+            </a:pPr>
+            <a:r>
+              <a:rPr lang="en-US" sz="1550" b="1" dirty="0">
                 <a:solidFill>
                   <a:srgbClr val="FFFFFF"/>
                 </a:solidFill>
@@ -3682,9 +3688,9 @@
                 <a:ea typeface="Cambria" pitchFamily="34" charset="-122"/>
                 <a:cs typeface="Cambria" pitchFamily="34" charset="-120"/>
               </a:rPr>
-              <a:t>Automated dispatch</a:t>
-            </a:r>
-            <a:endParaRPr lang="en-US" sz="1600" dirty="0"/>
+              <a:t>⚡ Deploy</a:t>
+            </a:r>
+            <a:endParaRPr lang="en-US" sz="1550" dirty="0"/>
           </a:p>
         </p:txBody>
       </p:sp>
@@ -3696,24 +3702,25 @@
         </p:nvSpPr>
         <p:spPr>
           <a:xfrm>
-            <a:off x="731520" y="4498848"/>
-            <a:ext cx="4937760" cy="914400"/>
-          </a:xfrm>
-          <a:prstGeom prst="rect">
-            <a:avLst/>
-          </a:prstGeom>
-          <a:noFill/>
-          <a:ln/>
-        </p:spPr>
-        <p:txBody>
-          <a:bodyPr wrap="square" lIns="0" tIns="0" rIns="0" bIns="0" rtlCol="0" anchor="ctr"/>
-          <a:lstStyle/>
-          <a:p>
-            <a:pPr indent="0" marL="0">
-              <a:lnSpc>
-                <a:spcPct val="105000"/>
-              </a:lnSpc>
-              <a:buNone/>
+            <a:off x="8284464" y="2880360"/>
+            <a:ext cx="3200400" cy="2560320"/>
+          </a:xfrm>
+          <a:prstGeom prst="rect">
+            <a:avLst/>
+          </a:prstGeom>
+          <a:noFill/>
+          <a:ln/>
+        </p:spPr>
+        <p:txBody>
+          <a:bodyPr wrap="square" lIns="0" tIns="0" rIns="0" bIns="0" rtlCol="0" anchor="ctr"/>
+          <a:lstStyle/>
+          <a:p>
+            <a:pPr marL="152400" indent="-152400">
+              <a:spcAft>
+                <a:spcPts val="900"/>
+              </a:spcAft>
+              <a:buSzPct val="100000"/>
+              <a:buChar char="•"/>
             </a:pPr>
             <a:r>
               <a:rPr lang="en-US" sz="1250" dirty="0">
@@ -3724,124 +3731,17 @@
                 <a:ea typeface="Calibri" pitchFamily="34" charset="-122"/>
                 <a:cs typeface="Calibri" pitchFamily="34" charset="-120"/>
               </a:rPr>
-              <a:t>Push advisories to SMS / IVR gateways for municipal &amp; disaster-management authorities.</a:t>
+              <a:t>Pure static HTML/CSS/JS</a:t>
             </a:r>
             <a:endParaRPr lang="en-US" sz="1250" dirty="0"/>
           </a:p>
-        </p:txBody>
-      </p:sp>
-      <p:sp>
-        <p:nvSpPr>
-          <p:cNvPr id="16" name="Shape 14"/>
-          <p:cNvSpPr/>
-          <p:nvPr/>
-        </p:nvSpPr>
-        <p:spPr>
-          <a:xfrm>
-            <a:off x="6126480" y="3840480"/>
-            <a:ext cx="5440680" cy="1737360"/>
-          </a:xfrm>
-          <a:prstGeom prst="roundRect">
-            <a:avLst>
-              <a:gd name="adj" fmla="val 6316"/>
-            </a:avLst>
-          </a:prstGeom>
-          <a:solidFill>
-            <a:srgbClr val="13294B"/>
-          </a:solidFill>
-          <a:ln w="12700">
-            <a:solidFill>
-              <a:srgbClr val="27466F"/>
-            </a:solidFill>
-            <a:prstDash val="solid"/>
-          </a:ln>
-        </p:spPr>
-      </p:sp>
-      <p:sp>
-        <p:nvSpPr>
-          <p:cNvPr id="17" name="Shape 15"/>
-          <p:cNvSpPr/>
-          <p:nvPr/>
-        </p:nvSpPr>
-        <p:spPr>
-          <a:xfrm>
-            <a:off x="6382512" y="4096512"/>
-            <a:ext cx="146304" cy="146304"/>
-          </a:xfrm>
-          <a:prstGeom prst="ellipse">
-            <a:avLst/>
-          </a:prstGeom>
-          <a:solidFill>
-            <a:srgbClr val="FB7185"/>
-          </a:solidFill>
-          <a:ln/>
-        </p:spPr>
-      </p:sp>
-      <p:sp>
-        <p:nvSpPr>
-          <p:cNvPr id="18" name="Text 16"/>
-          <p:cNvSpPr txBox="1"/>
-          <p:nvPr/>
-        </p:nvSpPr>
-        <p:spPr>
-          <a:xfrm>
-            <a:off x="6638544" y="3986784"/>
-            <a:ext cx="4663440" cy="457200"/>
-          </a:xfrm>
-          <a:prstGeom prst="rect">
-            <a:avLst/>
-          </a:prstGeom>
-          <a:noFill/>
-          <a:ln/>
-        </p:spPr>
-        <p:txBody>
-          <a:bodyPr wrap="square" lIns="0" tIns="0" rIns="0" bIns="0" rtlCol="0" anchor="ctr"/>
-          <a:lstStyle/>
-          <a:p>
-            <a:pPr indent="0" marL="0">
-              <a:buNone/>
-            </a:pPr>
-            <a:r>
-              <a:rPr lang="en-US" sz="1600" b="1" dirty="0">
-                <a:solidFill>
-                  <a:srgbClr val="FFFFFF"/>
-                </a:solidFill>
-                <a:latin typeface="Cambria" pitchFamily="34" charset="0"/>
-                <a:ea typeface="Cambria" pitchFamily="34" charset="-122"/>
-                <a:cs typeface="Cambria" pitchFamily="34" charset="-120"/>
-              </a:rPr>
-              <a:t>Model validation</a:t>
-            </a:r>
-            <a:endParaRPr lang="en-US" sz="1600" dirty="0"/>
-          </a:p>
-        </p:txBody>
-      </p:sp>
-      <p:sp>
-        <p:nvSpPr>
-          <p:cNvPr id="19" name="Text 17"/>
-          <p:cNvSpPr txBox="1"/>
-          <p:nvPr/>
-        </p:nvSpPr>
-        <p:spPr>
-          <a:xfrm>
-            <a:off x="6400800" y="4498848"/>
-            <a:ext cx="4937760" cy="914400"/>
-          </a:xfrm>
-          <a:prstGeom prst="rect">
-            <a:avLst/>
-          </a:prstGeom>
-          <a:noFill/>
-          <a:ln/>
-        </p:spPr>
-        <p:txBody>
-          <a:bodyPr wrap="square" lIns="0" tIns="0" rIns="0" bIns="0" rtlCol="0" anchor="ctr"/>
-          <a:lstStyle/>
-          <a:p>
-            <a:pPr indent="0" marL="0">
-              <a:lnSpc>
-                <a:spcPct val="105000"/>
-              </a:lnSpc>
-              <a:buNone/>
+          <a:p>
+            <a:pPr marL="152400" indent="-152400">
+              <a:spcAft>
+                <a:spcPts val="900"/>
+              </a:spcAft>
+              <a:buSzPct val="100000"/>
+              <a:buChar char="•"/>
             </a:pPr>
             <a:r>
               <a:rPr lang="en-US" sz="1250" dirty="0">
@@ -3852,15 +3752,75 @@
                 <a:ea typeface="Calibri" pitchFamily="34" charset="-122"/>
                 <a:cs typeface="Calibri" pitchFamily="34" charset="-120"/>
               </a:rPr>
-              <a:t>Continuously score modelled surge &amp; flood against Sentinel-1 SAR after each event.</a:t>
+              <a:t>Any CDN, GitHub Pages, or field laptop</a:t>
             </a:r>
             <a:endParaRPr lang="en-US" sz="1250" dirty="0"/>
           </a:p>
-        </p:txBody>
-      </p:sp>
-      <p:sp>
-        <p:nvSpPr>
-          <p:cNvPr id="20" name="Text 18"/>
+          <a:p>
+            <a:pPr marL="152400" indent="-152400">
+              <a:spcAft>
+                <a:spcPts val="900"/>
+              </a:spcAft>
+              <a:buSzPct val="100000"/>
+              <a:buChar char="•"/>
+            </a:pPr>
+            <a:r>
+              <a:rPr lang="en-US" sz="1250" dirty="0">
+                <a:solidFill>
+                  <a:srgbClr val="C7D6EC"/>
+                </a:solidFill>
+                <a:latin typeface="Calibri" pitchFamily="34" charset="0"/>
+                <a:ea typeface="Calibri" pitchFamily="34" charset="-122"/>
+                <a:cs typeface="Calibri" pitchFamily="34" charset="-120"/>
+              </a:rPr>
+              <a:t>GEE tiles via optional Cloud Run proxy</a:t>
+            </a:r>
+            <a:endParaRPr lang="en-US" sz="1250" dirty="0"/>
+          </a:p>
+        </p:txBody>
+      </p:sp>
+      <p:sp>
+        <p:nvSpPr>
+          <p:cNvPr id="16" name="Text 14"/>
+          <p:cNvSpPr txBox="1"/>
+          <p:nvPr/>
+        </p:nvSpPr>
+        <p:spPr>
+          <a:xfrm>
+            <a:off x="457200" y="5742432"/>
+            <a:ext cx="11247120" cy="457200"/>
+          </a:xfrm>
+          <a:prstGeom prst="rect">
+            <a:avLst/>
+          </a:prstGeom>
+          <a:noFill/>
+          <a:ln/>
+        </p:spPr>
+        <p:txBody>
+          <a:bodyPr wrap="square" lIns="0" tIns="0" rIns="0" bIns="0" rtlCol="0" anchor="ctr"/>
+          <a:lstStyle/>
+          <a:p>
+            <a:pPr indent="0" marL="0">
+              <a:buNone/>
+            </a:pPr>
+            <a:r>
+              <a:rPr lang="en-US" sz="1200" i="1" dirty="0">
+                <a:solidFill>
+                  <a:srgbClr val="93A5C0"/>
+                </a:solidFill>
+                <a:latin typeface="Calibri" pitchFamily="34" charset="0"/>
+                <a:ea typeface="Calibri" pitchFamily="34" charset="-122"/>
+                <a:cs typeface="Calibri" pitchFamily="34" charset="-120"/>
+              </a:rPr>
+              <a:t>No servers to run means judges and field teams can open the live link and use it immediately.</a:t>
+            </a:r>
+            <a:endParaRPr lang="en-US" sz="1200" dirty="0"/>
+          </a:p>
+        </p:txBody>
+      </p:sp>
+      <p:sp>
+        <p:nvSpPr>
+          <p:cNvPr id="17" name="Text 15"/>
           <p:cNvSpPr txBox="1"/>
           <p:nvPr/>
         </p:nvSpPr>
@@ -3913,7 +3873,7 @@
       </p:sp>
       <p:sp>
         <p:nvSpPr>
-          <p:cNvPr id="21" name="Text 19"/>
+          <p:cNvPr id="18" name="Text 16"/>
           <p:cNvSpPr txBox="1"/>
           <p:nvPr/>
         </p:nvSpPr>
@@ -3961,6 +3921,723 @@
 <file path=ppt/slides/slide12.xml><?xml version="1.0" encoding="utf-8"?>
 <p:sld xmlns:a="http://schemas.openxmlformats.org/drawingml/2006/main" xmlns:r="http://schemas.openxmlformats.org/officeDocument/2006/relationships" xmlns:p="http://schemas.openxmlformats.org/presentationml/2006/main">
   <p:cSld name="Slide 12">
+    <p:bg>
+      <p:bgPr>
+        <a:solidFill>
+          <a:srgbClr val="0A1B33"/>
+        </a:solidFill>
+      </p:bgPr>
+    </p:bg>
+    <p:spTree>
+      <p:nvGrpSpPr>
+        <p:cNvPr id="1" name=""/>
+        <p:cNvGrpSpPr/>
+        <p:nvPr/>
+      </p:nvGrpSpPr>
+      <p:grpSpPr>
+        <a:xfrm>
+          <a:off x="0" y="0"/>
+          <a:ext cx="0" cy="0"/>
+          <a:chOff x="0" y="0"/>
+          <a:chExt cx="0" cy="0"/>
+        </a:xfrm>
+      </p:grpSpPr>
+      <p:sp>
+        <p:nvSpPr>
+          <p:cNvPr id="2" name="Text 0"/>
+          <p:cNvSpPr txBox="1"/>
+          <p:nvPr/>
+        </p:nvSpPr>
+        <p:spPr>
+          <a:xfrm>
+            <a:off x="457200" y="457200"/>
+            <a:ext cx="10972800" cy="320040"/>
+          </a:xfrm>
+          <a:prstGeom prst="rect">
+            <a:avLst/>
+          </a:prstGeom>
+          <a:noFill/>
+          <a:ln/>
+        </p:spPr>
+        <p:txBody>
+          <a:bodyPr wrap="square" lIns="0" tIns="0" rIns="0" bIns="0" rtlCol="0" anchor="ctr"/>
+          <a:lstStyle/>
+          <a:p>
+            <a:pPr indent="0" marL="0">
+              <a:buNone/>
+            </a:pPr>
+            <a:r>
+              <a:rPr lang="en-US" sz="1200" b="1" spc="300" kern="0" dirty="0">
+                <a:solidFill>
+                  <a:srgbClr val="FBBF24"/>
+                </a:solidFill>
+                <a:latin typeface="Calibri" pitchFamily="34" charset="0"/>
+                <a:ea typeface="Calibri" pitchFamily="34" charset="-122"/>
+                <a:cs typeface="Calibri" pitchFamily="34" charset="-120"/>
+              </a:rPr>
+              <a:t>WHAT’S NEXT</a:t>
+            </a:r>
+            <a:endParaRPr lang="en-US" sz="1200" dirty="0"/>
+          </a:p>
+        </p:txBody>
+      </p:sp>
+      <p:sp>
+        <p:nvSpPr>
+          <p:cNvPr id="3" name="Text 1"/>
+          <p:cNvSpPr txBox="1"/>
+          <p:nvPr/>
+        </p:nvSpPr>
+        <p:spPr>
+          <a:xfrm>
+            <a:off x="457200" y="786384"/>
+            <a:ext cx="11247120" cy="914400"/>
+          </a:xfrm>
+          <a:prstGeom prst="rect">
+            <a:avLst/>
+          </a:prstGeom>
+          <a:noFill/>
+          <a:ln/>
+        </p:spPr>
+        <p:txBody>
+          <a:bodyPr wrap="square" lIns="0" tIns="0" rIns="0" bIns="0" rtlCol="0" anchor="ctr"/>
+          <a:lstStyle/>
+          <a:p>
+            <a:pPr indent="0" marL="0">
+              <a:lnSpc>
+                <a:spcPct val="98000"/>
+              </a:lnSpc>
+              <a:buNone/>
+            </a:pPr>
+            <a:r>
+              <a:rPr lang="en-US" sz="3400" b="1" dirty="0">
+                <a:solidFill>
+                  <a:srgbClr val="FFFFFF"/>
+                </a:solidFill>
+                <a:latin typeface="Cambria" pitchFamily="34" charset="0"/>
+                <a:ea typeface="Cambria" pitchFamily="34" charset="-122"/>
+                <a:cs typeface="Cambria" pitchFamily="34" charset="-120"/>
+              </a:rPr>
+              <a:t>From hackathon prototype to coastline-scale</a:t>
+            </a:r>
+            <a:endParaRPr lang="en-US" sz="3400" dirty="0"/>
+          </a:p>
+        </p:txBody>
+      </p:sp>
+      <p:sp>
+        <p:nvSpPr>
+          <p:cNvPr id="4" name="Shape 2"/>
+          <p:cNvSpPr/>
+          <p:nvPr/>
+        </p:nvSpPr>
+        <p:spPr>
+          <a:xfrm>
+            <a:off x="457200" y="1965960"/>
+            <a:ext cx="5440680" cy="1737360"/>
+          </a:xfrm>
+          <a:prstGeom prst="roundRect">
+            <a:avLst>
+              <a:gd name="adj" fmla="val 6316"/>
+            </a:avLst>
+          </a:prstGeom>
+          <a:solidFill>
+            <a:srgbClr val="13294B"/>
+          </a:solidFill>
+          <a:ln w="12700">
+            <a:solidFill>
+              <a:srgbClr val="27466F"/>
+            </a:solidFill>
+            <a:prstDash val="solid"/>
+          </a:ln>
+        </p:spPr>
+      </p:sp>
+      <p:sp>
+        <p:nvSpPr>
+          <p:cNvPr id="5" name="Shape 3"/>
+          <p:cNvSpPr/>
+          <p:nvPr/>
+        </p:nvSpPr>
+        <p:spPr>
+          <a:xfrm>
+            <a:off x="713232" y="2221992"/>
+            <a:ext cx="146304" cy="146304"/>
+          </a:xfrm>
+          <a:prstGeom prst="ellipse">
+            <a:avLst/>
+          </a:prstGeom>
+          <a:solidFill>
+            <a:srgbClr val="38BDF8"/>
+          </a:solidFill>
+          <a:ln/>
+        </p:spPr>
+      </p:sp>
+      <p:sp>
+        <p:nvSpPr>
+          <p:cNvPr id="6" name="Text 4"/>
+          <p:cNvSpPr txBox="1"/>
+          <p:nvPr/>
+        </p:nvSpPr>
+        <p:spPr>
+          <a:xfrm>
+            <a:off x="969264" y="2112264"/>
+            <a:ext cx="4663440" cy="457200"/>
+          </a:xfrm>
+          <a:prstGeom prst="rect">
+            <a:avLst/>
+          </a:prstGeom>
+          <a:noFill/>
+          <a:ln/>
+        </p:spPr>
+        <p:txBody>
+          <a:bodyPr wrap="square" lIns="0" tIns="0" rIns="0" bIns="0" rtlCol="0" anchor="ctr"/>
+          <a:lstStyle/>
+          <a:p>
+            <a:pPr indent="0" marL="0">
+              <a:buNone/>
+            </a:pPr>
+            <a:r>
+              <a:rPr lang="en-US" sz="1600" b="1" dirty="0">
+                <a:solidFill>
+                  <a:srgbClr val="FFFFFF"/>
+                </a:solidFill>
+                <a:latin typeface="Cambria" pitchFamily="34" charset="0"/>
+                <a:ea typeface="Cambria" pitchFamily="34" charset="-122"/>
+                <a:cs typeface="Cambria" pitchFamily="34" charset="-120"/>
+              </a:rPr>
+              <a:t>Live GEE tiles by default</a:t>
+            </a:r>
+            <a:endParaRPr lang="en-US" sz="1600" dirty="0"/>
+          </a:p>
+        </p:txBody>
+      </p:sp>
+      <p:sp>
+        <p:nvSpPr>
+          <p:cNvPr id="7" name="Text 5"/>
+          <p:cNvSpPr txBox="1"/>
+          <p:nvPr/>
+        </p:nvSpPr>
+        <p:spPr>
+          <a:xfrm>
+            <a:off x="731520" y="2624328"/>
+            <a:ext cx="4937760" cy="914400"/>
+          </a:xfrm>
+          <a:prstGeom prst="rect">
+            <a:avLst/>
+          </a:prstGeom>
+          <a:noFill/>
+          <a:ln/>
+        </p:spPr>
+        <p:txBody>
+          <a:bodyPr wrap="square" lIns="0" tIns="0" rIns="0" bIns="0" rtlCol="0" anchor="ctr"/>
+          <a:lstStyle/>
+          <a:p>
+            <a:pPr indent="0" marL="0">
+              <a:lnSpc>
+                <a:spcPct val="105000"/>
+              </a:lnSpc>
+              <a:buNone/>
+            </a:pPr>
+            <a:r>
+              <a:rPr lang="en-US" sz="1250" dirty="0">
+                <a:solidFill>
+                  <a:srgbClr val="C7D6EC"/>
+                </a:solidFill>
+                <a:latin typeface="Calibri" pitchFamily="34" charset="0"/>
+                <a:ea typeface="Calibri" pitchFamily="34" charset="-122"/>
+                <a:cs typeface="Calibri" pitchFamily="34" charset="-120"/>
+              </a:rPr>
+              <a:t>Ship the Cloud Run tile proxy so SAR flood &amp; DEM surge stream in without setup.</a:t>
+            </a:r>
+            <a:endParaRPr lang="en-US" sz="1250" dirty="0"/>
+          </a:p>
+        </p:txBody>
+      </p:sp>
+      <p:sp>
+        <p:nvSpPr>
+          <p:cNvPr id="8" name="Shape 6"/>
+          <p:cNvSpPr/>
+          <p:nvPr/>
+        </p:nvSpPr>
+        <p:spPr>
+          <a:xfrm>
+            <a:off x="6126480" y="1965960"/>
+            <a:ext cx="5440680" cy="1737360"/>
+          </a:xfrm>
+          <a:prstGeom prst="roundRect">
+            <a:avLst>
+              <a:gd name="adj" fmla="val 6316"/>
+            </a:avLst>
+          </a:prstGeom>
+          <a:solidFill>
+            <a:srgbClr val="13294B"/>
+          </a:solidFill>
+          <a:ln w="12700">
+            <a:solidFill>
+              <a:srgbClr val="27466F"/>
+            </a:solidFill>
+            <a:prstDash val="solid"/>
+          </a:ln>
+        </p:spPr>
+      </p:sp>
+      <p:sp>
+        <p:nvSpPr>
+          <p:cNvPr id="9" name="Shape 7"/>
+          <p:cNvSpPr/>
+          <p:nvPr/>
+        </p:nvSpPr>
+        <p:spPr>
+          <a:xfrm>
+            <a:off x="6382512" y="2221992"/>
+            <a:ext cx="146304" cy="146304"/>
+          </a:xfrm>
+          <a:prstGeom prst="ellipse">
+            <a:avLst/>
+          </a:prstGeom>
+          <a:solidFill>
+            <a:srgbClr val="FBBF24"/>
+          </a:solidFill>
+          <a:ln/>
+        </p:spPr>
+      </p:sp>
+      <p:sp>
+        <p:nvSpPr>
+          <p:cNvPr id="10" name="Text 8"/>
+          <p:cNvSpPr txBox="1"/>
+          <p:nvPr/>
+        </p:nvSpPr>
+        <p:spPr>
+          <a:xfrm>
+            <a:off x="6638544" y="2112264"/>
+            <a:ext cx="4663440" cy="457200"/>
+          </a:xfrm>
+          <a:prstGeom prst="rect">
+            <a:avLst/>
+          </a:prstGeom>
+          <a:noFill/>
+          <a:ln/>
+        </p:spPr>
+        <p:txBody>
+          <a:bodyPr wrap="square" lIns="0" tIns="0" rIns="0" bIns="0" rtlCol="0" anchor="ctr"/>
+          <a:lstStyle/>
+          <a:p>
+            <a:pPr indent="0" marL="0">
+              <a:buNone/>
+            </a:pPr>
+            <a:r>
+              <a:rPr lang="en-US" sz="1600" b="1" dirty="0">
+                <a:solidFill>
+                  <a:srgbClr val="FFFFFF"/>
+                </a:solidFill>
+                <a:latin typeface="Cambria" pitchFamily="34" charset="0"/>
+                <a:ea typeface="Cambria" pitchFamily="34" charset="-122"/>
+                <a:cs typeface="Cambria" pitchFamily="34" charset="-120"/>
+              </a:rPr>
+              <a:t>More coastlines</a:t>
+            </a:r>
+            <a:endParaRPr lang="en-US" sz="1600" dirty="0"/>
+          </a:p>
+        </p:txBody>
+      </p:sp>
+      <p:sp>
+        <p:nvSpPr>
+          <p:cNvPr id="11" name="Text 9"/>
+          <p:cNvSpPr txBox="1"/>
+          <p:nvPr/>
+        </p:nvSpPr>
+        <p:spPr>
+          <a:xfrm>
+            <a:off x="6400800" y="2624328"/>
+            <a:ext cx="4937760" cy="914400"/>
+          </a:xfrm>
+          <a:prstGeom prst="rect">
+            <a:avLst/>
+          </a:prstGeom>
+          <a:noFill/>
+          <a:ln/>
+        </p:spPr>
+        <p:txBody>
+          <a:bodyPr wrap="square" lIns="0" tIns="0" rIns="0" bIns="0" rtlCol="0" anchor="ctr"/>
+          <a:lstStyle/>
+          <a:p>
+            <a:pPr indent="0" marL="0">
+              <a:lnSpc>
+                <a:spcPct val="105000"/>
+              </a:lnSpc>
+              <a:buNone/>
+            </a:pPr>
+            <a:r>
+              <a:rPr lang="en-US" sz="1250" dirty="0">
+                <a:solidFill>
+                  <a:srgbClr val="C7D6EC"/>
+                </a:solidFill>
+                <a:latin typeface="Calibri" pitchFamily="34" charset="0"/>
+                <a:ea typeface="Calibri" pitchFamily="34" charset="-122"/>
+                <a:cs typeface="Calibri" pitchFamily="34" charset="-120"/>
+              </a:rPr>
+              <a:t>Onboard new districts by pointing the pipeline at fresh AOIs — Andhra, West Bengal, Tamil Nadu.</a:t>
+            </a:r>
+            <a:endParaRPr lang="en-US" sz="1250" dirty="0"/>
+          </a:p>
+        </p:txBody>
+      </p:sp>
+      <p:sp>
+        <p:nvSpPr>
+          <p:cNvPr id="12" name="Shape 10"/>
+          <p:cNvSpPr/>
+          <p:nvPr/>
+        </p:nvSpPr>
+        <p:spPr>
+          <a:xfrm>
+            <a:off x="457200" y="3840480"/>
+            <a:ext cx="5440680" cy="1737360"/>
+          </a:xfrm>
+          <a:prstGeom prst="roundRect">
+            <a:avLst>
+              <a:gd name="adj" fmla="val 6316"/>
+            </a:avLst>
+          </a:prstGeom>
+          <a:solidFill>
+            <a:srgbClr val="13294B"/>
+          </a:solidFill>
+          <a:ln w="12700">
+            <a:solidFill>
+              <a:srgbClr val="27466F"/>
+            </a:solidFill>
+            <a:prstDash val="solid"/>
+          </a:ln>
+        </p:spPr>
+      </p:sp>
+      <p:sp>
+        <p:nvSpPr>
+          <p:cNvPr id="13" name="Shape 11"/>
+          <p:cNvSpPr/>
+          <p:nvPr/>
+        </p:nvSpPr>
+        <p:spPr>
+          <a:xfrm>
+            <a:off x="713232" y="4096512"/>
+            <a:ext cx="146304" cy="146304"/>
+          </a:xfrm>
+          <a:prstGeom prst="ellipse">
+            <a:avLst/>
+          </a:prstGeom>
+          <a:solidFill>
+            <a:srgbClr val="34D399"/>
+          </a:solidFill>
+          <a:ln/>
+        </p:spPr>
+      </p:sp>
+      <p:sp>
+        <p:nvSpPr>
+          <p:cNvPr id="14" name="Text 12"/>
+          <p:cNvSpPr txBox="1"/>
+          <p:nvPr/>
+        </p:nvSpPr>
+        <p:spPr>
+          <a:xfrm>
+            <a:off x="969264" y="3986784"/>
+            <a:ext cx="4663440" cy="457200"/>
+          </a:xfrm>
+          <a:prstGeom prst="rect">
+            <a:avLst/>
+          </a:prstGeom>
+          <a:noFill/>
+          <a:ln/>
+        </p:spPr>
+        <p:txBody>
+          <a:bodyPr wrap="square" lIns="0" tIns="0" rIns="0" bIns="0" rtlCol="0" anchor="ctr"/>
+          <a:lstStyle/>
+          <a:p>
+            <a:pPr indent="0" marL="0">
+              <a:buNone/>
+            </a:pPr>
+            <a:r>
+              <a:rPr lang="en-US" sz="1600" b="1" dirty="0">
+                <a:solidFill>
+                  <a:srgbClr val="FFFFFF"/>
+                </a:solidFill>
+                <a:latin typeface="Cambria" pitchFamily="34" charset="0"/>
+                <a:ea typeface="Cambria" pitchFamily="34" charset="-122"/>
+                <a:cs typeface="Cambria" pitchFamily="34" charset="-120"/>
+              </a:rPr>
+              <a:t>Automated dispatch</a:t>
+            </a:r>
+            <a:endParaRPr lang="en-US" sz="1600" dirty="0"/>
+          </a:p>
+        </p:txBody>
+      </p:sp>
+      <p:sp>
+        <p:nvSpPr>
+          <p:cNvPr id="15" name="Text 13"/>
+          <p:cNvSpPr txBox="1"/>
+          <p:nvPr/>
+        </p:nvSpPr>
+        <p:spPr>
+          <a:xfrm>
+            <a:off x="731520" y="4498848"/>
+            <a:ext cx="4937760" cy="914400"/>
+          </a:xfrm>
+          <a:prstGeom prst="rect">
+            <a:avLst/>
+          </a:prstGeom>
+          <a:noFill/>
+          <a:ln/>
+        </p:spPr>
+        <p:txBody>
+          <a:bodyPr wrap="square" lIns="0" tIns="0" rIns="0" bIns="0" rtlCol="0" anchor="ctr"/>
+          <a:lstStyle/>
+          <a:p>
+            <a:pPr indent="0" marL="0">
+              <a:lnSpc>
+                <a:spcPct val="105000"/>
+              </a:lnSpc>
+              <a:buNone/>
+            </a:pPr>
+            <a:r>
+              <a:rPr lang="en-US" sz="1250" dirty="0">
+                <a:solidFill>
+                  <a:srgbClr val="C7D6EC"/>
+                </a:solidFill>
+                <a:latin typeface="Calibri" pitchFamily="34" charset="0"/>
+                <a:ea typeface="Calibri" pitchFamily="34" charset="-122"/>
+                <a:cs typeface="Calibri" pitchFamily="34" charset="-120"/>
+              </a:rPr>
+              <a:t>Push advisories to SMS / IVR gateways for municipal &amp; disaster-management authorities.</a:t>
+            </a:r>
+            <a:endParaRPr lang="en-US" sz="1250" dirty="0"/>
+          </a:p>
+        </p:txBody>
+      </p:sp>
+      <p:sp>
+        <p:nvSpPr>
+          <p:cNvPr id="16" name="Shape 14"/>
+          <p:cNvSpPr/>
+          <p:nvPr/>
+        </p:nvSpPr>
+        <p:spPr>
+          <a:xfrm>
+            <a:off x="6126480" y="3840480"/>
+            <a:ext cx="5440680" cy="1737360"/>
+          </a:xfrm>
+          <a:prstGeom prst="roundRect">
+            <a:avLst>
+              <a:gd name="adj" fmla="val 6316"/>
+            </a:avLst>
+          </a:prstGeom>
+          <a:solidFill>
+            <a:srgbClr val="13294B"/>
+          </a:solidFill>
+          <a:ln w="12700">
+            <a:solidFill>
+              <a:srgbClr val="27466F"/>
+            </a:solidFill>
+            <a:prstDash val="solid"/>
+          </a:ln>
+        </p:spPr>
+      </p:sp>
+      <p:sp>
+        <p:nvSpPr>
+          <p:cNvPr id="17" name="Shape 15"/>
+          <p:cNvSpPr/>
+          <p:nvPr/>
+        </p:nvSpPr>
+        <p:spPr>
+          <a:xfrm>
+            <a:off x="6382512" y="4096512"/>
+            <a:ext cx="146304" cy="146304"/>
+          </a:xfrm>
+          <a:prstGeom prst="ellipse">
+            <a:avLst/>
+          </a:prstGeom>
+          <a:solidFill>
+            <a:srgbClr val="FB7185"/>
+          </a:solidFill>
+          <a:ln/>
+        </p:spPr>
+      </p:sp>
+      <p:sp>
+        <p:nvSpPr>
+          <p:cNvPr id="18" name="Text 16"/>
+          <p:cNvSpPr txBox="1"/>
+          <p:nvPr/>
+        </p:nvSpPr>
+        <p:spPr>
+          <a:xfrm>
+            <a:off x="6638544" y="3986784"/>
+            <a:ext cx="4663440" cy="457200"/>
+          </a:xfrm>
+          <a:prstGeom prst="rect">
+            <a:avLst/>
+          </a:prstGeom>
+          <a:noFill/>
+          <a:ln/>
+        </p:spPr>
+        <p:txBody>
+          <a:bodyPr wrap="square" lIns="0" tIns="0" rIns="0" bIns="0" rtlCol="0" anchor="ctr"/>
+          <a:lstStyle/>
+          <a:p>
+            <a:pPr indent="0" marL="0">
+              <a:buNone/>
+            </a:pPr>
+            <a:r>
+              <a:rPr lang="en-US" sz="1600" b="1" dirty="0">
+                <a:solidFill>
+                  <a:srgbClr val="FFFFFF"/>
+                </a:solidFill>
+                <a:latin typeface="Cambria" pitchFamily="34" charset="0"/>
+                <a:ea typeface="Cambria" pitchFamily="34" charset="-122"/>
+                <a:cs typeface="Cambria" pitchFamily="34" charset="-120"/>
+              </a:rPr>
+              <a:t>Model validation</a:t>
+            </a:r>
+            <a:endParaRPr lang="en-US" sz="1600" dirty="0"/>
+          </a:p>
+        </p:txBody>
+      </p:sp>
+      <p:sp>
+        <p:nvSpPr>
+          <p:cNvPr id="19" name="Text 17"/>
+          <p:cNvSpPr txBox="1"/>
+          <p:nvPr/>
+        </p:nvSpPr>
+        <p:spPr>
+          <a:xfrm>
+            <a:off x="6400800" y="4498848"/>
+            <a:ext cx="4937760" cy="914400"/>
+          </a:xfrm>
+          <a:prstGeom prst="rect">
+            <a:avLst/>
+          </a:prstGeom>
+          <a:noFill/>
+          <a:ln/>
+        </p:spPr>
+        <p:txBody>
+          <a:bodyPr wrap="square" lIns="0" tIns="0" rIns="0" bIns="0" rtlCol="0" anchor="ctr"/>
+          <a:lstStyle/>
+          <a:p>
+            <a:pPr indent="0" marL="0">
+              <a:lnSpc>
+                <a:spcPct val="105000"/>
+              </a:lnSpc>
+              <a:buNone/>
+            </a:pPr>
+            <a:r>
+              <a:rPr lang="en-US" sz="1250" dirty="0">
+                <a:solidFill>
+                  <a:srgbClr val="C7D6EC"/>
+                </a:solidFill>
+                <a:latin typeface="Calibri" pitchFamily="34" charset="0"/>
+                <a:ea typeface="Calibri" pitchFamily="34" charset="-122"/>
+                <a:cs typeface="Calibri" pitchFamily="34" charset="-120"/>
+              </a:rPr>
+              <a:t>Continuously score modelled surge &amp; flood against Sentinel-1 SAR after each event.</a:t>
+            </a:r>
+            <a:endParaRPr lang="en-US" sz="1250" dirty="0"/>
+          </a:p>
+        </p:txBody>
+      </p:sp>
+      <p:sp>
+        <p:nvSpPr>
+          <p:cNvPr id="20" name="Text 18"/>
+          <p:cNvSpPr txBox="1"/>
+          <p:nvPr/>
+        </p:nvSpPr>
+        <p:spPr>
+          <a:xfrm>
+            <a:off x="457200" y="6455664"/>
+            <a:ext cx="8229600" cy="274320"/>
+          </a:xfrm>
+          <a:prstGeom prst="rect">
+            <a:avLst/>
+          </a:prstGeom>
+          <a:noFill/>
+          <a:ln/>
+        </p:spPr>
+        <p:txBody>
+          <a:bodyPr wrap="square" lIns="0" tIns="0" rIns="0" bIns="0" rtlCol="0" anchor="ctr"/>
+          <a:lstStyle/>
+          <a:p>
+            <a:pPr algn="l" indent="0" marL="0">
+              <a:buNone/>
+            </a:pPr>
+            <a:r>
+              <a:rPr lang="en-US" sz="900" b="1" dirty="0">
+                <a:solidFill>
+                  <a:srgbClr val="93A5C0"/>
+                </a:solidFill>
+                <a:latin typeface="Calibri" pitchFamily="34" charset="0"/>
+                <a:ea typeface="Calibri" pitchFamily="34" charset="-122"/>
+                <a:cs typeface="Calibri" pitchFamily="34" charset="-120"/>
+              </a:rPr>
+              <a:t>PRAHARI Orbital Console</a:t>
+            </a:r>
+            <a:pPr algn="l" indent="0" marL="0">
+              <a:buNone/>
+            </a:pPr>
+            <a:r>
+              <a:rPr lang="en-US" sz="900" dirty="0">
+                <a:solidFill>
+                  <a:srgbClr val="5C7092"/>
+                </a:solidFill>
+                <a:latin typeface="Calibri" pitchFamily="34" charset="0"/>
+                <a:ea typeface="Calibri" pitchFamily="34" charset="-122"/>
+                <a:cs typeface="Calibri" pitchFamily="34" charset="-120"/>
+              </a:rPr>
+              <a:t>   ·   Hackathon Submission</a:t>
+            </a:r>
+            <a:endParaRPr lang="en-US" sz="900" dirty="0"/>
+          </a:p>
+        </p:txBody>
+      </p:sp>
+      <p:sp>
+        <p:nvSpPr>
+          <p:cNvPr id="21" name="Text 19"/>
+          <p:cNvSpPr txBox="1"/>
+          <p:nvPr/>
+        </p:nvSpPr>
+        <p:spPr>
+          <a:xfrm>
+            <a:off x="11155680" y="6455664"/>
+            <a:ext cx="640080" cy="274320"/>
+          </a:xfrm>
+          <a:prstGeom prst="rect">
+            <a:avLst/>
+          </a:prstGeom>
+          <a:noFill/>
+          <a:ln/>
+        </p:spPr>
+        <p:txBody>
+          <a:bodyPr wrap="square" lIns="0" tIns="0" rIns="0" bIns="0" rtlCol="0" anchor="ctr"/>
+          <a:lstStyle/>
+          <a:p>
+            <a:pPr algn="r" indent="0" marL="0">
+              <a:buNone/>
+            </a:pPr>
+            <a:r>
+              <a:rPr lang="en-US" sz="900" dirty="0">
+                <a:solidFill>
+                  <a:srgbClr val="5C7092"/>
+                </a:solidFill>
+                <a:latin typeface="Calibri" pitchFamily="34" charset="0"/>
+                <a:ea typeface="Calibri" pitchFamily="34" charset="-122"/>
+                <a:cs typeface="Calibri" pitchFamily="34" charset="-120"/>
+              </a:rPr>
+              <a:t>12</a:t>
+            </a:r>
+            <a:endParaRPr lang="en-US" sz="900" dirty="0"/>
+          </a:p>
+        </p:txBody>
+      </p:sp>
+    </p:spTree>
+  </p:cSld>
+  <p:clrMapOvr>
+    <a:masterClrMapping/>
+  </p:clrMapOvr>
+</p:sld>
+</file>
+
+<file path=ppt/slides/slide13.xml><?xml version="1.0" encoding="utf-8"?>
+<p:sld xmlns:a="http://schemas.openxmlformats.org/drawingml/2006/main" xmlns:r="http://schemas.openxmlformats.org/officeDocument/2006/relationships" xmlns:p="http://schemas.openxmlformats.org/presentationml/2006/main">
+  <p:cSld name="Slide 13">
     <p:bg>
       <p:bgPr>
         <a:solidFill>
@@ -4268,9 +4945,9 @@
 </p:sld>
 </file>
 
-<file path=ppt/slides/slide13.xml><?xml version="1.0" encoding="utf-8"?>
+<file path=ppt/slides/slide14.xml><?xml version="1.0" encoding="utf-8"?>
 <p:sld xmlns:a="http://schemas.openxmlformats.org/drawingml/2006/main" xmlns:r="http://schemas.openxmlformats.org/officeDocument/2006/relationships" xmlns:p="http://schemas.openxmlformats.org/presentationml/2006/main">
-  <p:cSld name="Slide 13">
+  <p:cSld name="Slide 14">
     <p:bg>
       <p:bgPr>
         <a:solidFill>
@@ -4945,7 +5622,7 @@
                 <a:ea typeface="Calibri" pitchFamily="34" charset="-122"/>
                 <a:cs typeface="Calibri" pitchFamily="34" charset="-120"/>
               </a:rPr>
-              <a:t>12</a:t>
+              <a:t>13</a:t>
             </a:r>
             <a:endParaRPr lang="en-US" sz="900" dirty="0"/>
           </a:p>
@@ -9563,13 +10240,13 @@
             <a:r>
               <a:rPr lang="en-US" sz="1200" b="1" spc="300" kern="0" dirty="0">
                 <a:solidFill>
-                  <a:srgbClr val="FBBF24"/>
-                </a:solidFill>
-                <a:latin typeface="Calibri" pitchFamily="34" charset="0"/>
-                <a:ea typeface="Calibri" pitchFamily="34" charset="-122"/>
-                <a:cs typeface="Calibri" pitchFamily="34" charset="-120"/>
-              </a:rPr>
-              <a:t>ZERO MOCKUPS · REAL FIXTURES</a:t>
+                  <a:srgbClr val="34D399"/>
+                </a:solidFill>
+                <a:latin typeface="Calibri" pitchFamily="34" charset="0"/>
+                <a:ea typeface="Calibri" pitchFamily="34" charset="-122"/>
+                <a:cs typeface="Calibri" pitchFamily="34" charset="-120"/>
+              </a:rPr>
+              <a:t>THE AI ADVISOR</a:t>
             </a:r>
             <a:endParaRPr lang="en-US" sz="1200" dirty="0"/>
           </a:p>
@@ -9611,7 +10288,7 @@
                 <a:ea typeface="Cambria" pitchFamily="34" charset="-122"/>
                 <a:cs typeface="Cambria" pitchFamily="34" charset="-120"/>
               </a:rPr>
-              <a:t>Built on actual Cyclone Fani data</a:t>
+              <a:t>Ask your data — Gemini answers, grounded</a:t>
             </a:r>
             <a:endParaRPr lang="en-US" sz="3400" dirty="0"/>
           </a:p>
@@ -9625,23 +10302,16 @@
         </p:nvSpPr>
         <p:spPr>
           <a:xfrm>
-            <a:off x="457200" y="1965960"/>
-            <a:ext cx="3566160" cy="1737360"/>
-          </a:xfrm>
-          <a:prstGeom prst="roundRect">
-            <a:avLst>
-              <a:gd name="adj" fmla="val 6316"/>
-            </a:avLst>
+            <a:off x="457200" y="2011680"/>
+            <a:ext cx="164592" cy="164592"/>
+          </a:xfrm>
+          <a:prstGeom prst="ellipse">
+            <a:avLst/>
           </a:prstGeom>
           <a:solidFill>
-            <a:srgbClr val="13294B"/>
+            <a:srgbClr val="34D399"/>
           </a:solidFill>
-          <a:ln w="12700">
-            <a:solidFill>
-              <a:srgbClr val="27466F"/>
-            </a:solidFill>
-            <a:prstDash val="solid"/>
-          </a:ln>
+          <a:ln/>
         </p:spPr>
       </p:sp>
       <p:sp>
@@ -9652,34 +10322,34 @@
         </p:nvSpPr>
         <p:spPr>
           <a:xfrm>
-            <a:off x="685800" y="2148840"/>
-            <a:ext cx="3108960" cy="777240"/>
-          </a:xfrm>
-          <a:prstGeom prst="rect">
-            <a:avLst/>
-          </a:prstGeom>
-          <a:noFill/>
-          <a:ln/>
-        </p:spPr>
-        <p:txBody>
-          <a:bodyPr wrap="square" lIns="0" tIns="0" rIns="0" bIns="0" rtlCol="0" anchor="ctr"/>
-          <a:lstStyle/>
-          <a:p>
-            <a:pPr indent="0" marL="0">
-              <a:buNone/>
-            </a:pPr>
-            <a:r>
-              <a:rPr lang="en-US" sz="3400" b="1" dirty="0">
-                <a:solidFill>
-                  <a:srgbClr val="38BDF8"/>
-                </a:solidFill>
-                <a:latin typeface="Cambria" pitchFamily="34" charset="0"/>
-                <a:ea typeface="Cambria" pitchFamily="34" charset="-122"/>
-                <a:cs typeface="Cambria" pitchFamily="34" charset="-120"/>
-              </a:rPr>
-              <a:t>13</a:t>
-            </a:r>
-            <a:endParaRPr lang="en-US" sz="3400" dirty="0"/>
+            <a:off x="749808" y="1892808"/>
+            <a:ext cx="5029200" cy="365760"/>
+          </a:xfrm>
+          <a:prstGeom prst="rect">
+            <a:avLst/>
+          </a:prstGeom>
+          <a:noFill/>
+          <a:ln/>
+        </p:spPr>
+        <p:txBody>
+          <a:bodyPr wrap="square" lIns="0" tIns="0" rIns="0" bIns="0" rtlCol="0" anchor="ctr"/>
+          <a:lstStyle/>
+          <a:p>
+            <a:pPr indent="0" marL="0">
+              <a:buNone/>
+            </a:pPr>
+            <a:r>
+              <a:rPr lang="en-US" sz="1400" b="1" dirty="0">
+                <a:solidFill>
+                  <a:srgbClr val="FFFFFF"/>
+                </a:solidFill>
+                <a:latin typeface="Calibri" pitchFamily="34" charset="0"/>
+                <a:ea typeface="Calibri" pitchFamily="34" charset="-122"/>
+                <a:cs typeface="Calibri" pitchFamily="34" charset="-120"/>
+              </a:rPr>
+              <a:t>Gemini Flash, in the browser</a:t>
+            </a:r>
+            <a:endParaRPr lang="en-US" sz="1400" dirty="0"/>
           </a:p>
         </p:txBody>
       </p:sp>
@@ -9691,8 +10361,8 @@
         </p:nvSpPr>
         <p:spPr>
           <a:xfrm>
-            <a:off x="685800" y="2898648"/>
-            <a:ext cx="3108960" cy="731520"/>
+            <a:off x="749808" y="2240280"/>
+            <a:ext cx="5029200" cy="548640"/>
           </a:xfrm>
           <a:prstGeom prst="rect">
             <a:avLst/>
@@ -9706,12 +10376,12 @@
           <a:p>
             <a:pPr indent="0" marL="0">
               <a:lnSpc>
-                <a:spcPct val="100000"/>
+                <a:spcPct val="102000"/>
               </a:lnSpc>
               <a:buNone/>
             </a:pPr>
             <a:r>
-              <a:rPr lang="en-US" sz="1250" dirty="0">
+              <a:rPr lang="en-US" sz="1200" dirty="0">
                 <a:solidFill>
                   <a:srgbClr val="C7D6EC"/>
                 </a:solidFill>
@@ -9719,9 +10389,9 @@
                 <a:ea typeface="Calibri" pitchFamily="34" charset="-122"/>
                 <a:cs typeface="Calibri" pitchFamily="34" charset="-120"/>
               </a:rPr>
-              <a:t>IMD/JTWC best-track waypoints, T-48h → landfall</a:t>
-            </a:r>
-            <a:endParaRPr lang="en-US" sz="1250" dirty="0"/>
+              <a:t>Client-side — no backend, no server round-trip. Your API key stays in your browser.</a:t>
+            </a:r>
+            <a:endParaRPr lang="en-US" sz="1200" dirty="0"/>
           </a:p>
         </p:txBody>
       </p:sp>
@@ -9733,23 +10403,16 @@
         </p:nvSpPr>
         <p:spPr>
           <a:xfrm>
-            <a:off x="4160520" y="1965960"/>
-            <a:ext cx="3566160" cy="1737360"/>
-          </a:xfrm>
-          <a:prstGeom prst="roundRect">
-            <a:avLst>
-              <a:gd name="adj" fmla="val 6316"/>
-            </a:avLst>
+            <a:off x="457200" y="2871216"/>
+            <a:ext cx="164592" cy="164592"/>
+          </a:xfrm>
+          <a:prstGeom prst="ellipse">
+            <a:avLst/>
           </a:prstGeom>
           <a:solidFill>
-            <a:srgbClr val="13294B"/>
+            <a:srgbClr val="34D399"/>
           </a:solidFill>
-          <a:ln w="12700">
-            <a:solidFill>
-              <a:srgbClr val="27466F"/>
-            </a:solidFill>
-            <a:prstDash val="solid"/>
-          </a:ln>
+          <a:ln/>
         </p:spPr>
       </p:sp>
       <p:sp>
@@ -9760,34 +10423,34 @@
         </p:nvSpPr>
         <p:spPr>
           <a:xfrm>
-            <a:off x="4389120" y="2148840"/>
-            <a:ext cx="3108960" cy="777240"/>
-          </a:xfrm>
-          <a:prstGeom prst="rect">
-            <a:avLst/>
-          </a:prstGeom>
-          <a:noFill/>
-          <a:ln/>
-        </p:spPr>
-        <p:txBody>
-          <a:bodyPr wrap="square" lIns="0" tIns="0" rIns="0" bIns="0" rtlCol="0" anchor="ctr"/>
-          <a:lstStyle/>
-          <a:p>
-            <a:pPr indent="0" marL="0">
-              <a:buNone/>
-            </a:pPr>
-            <a:r>
-              <a:rPr lang="en-US" sz="3400" b="1" dirty="0">
-                <a:solidFill>
-                  <a:srgbClr val="FBBF24"/>
-                </a:solidFill>
-                <a:latin typeface="Cambria" pitchFamily="34" charset="0"/>
-                <a:ea typeface="Cambria" pitchFamily="34" charset="-122"/>
-                <a:cs typeface="Cambria" pitchFamily="34" charset="-120"/>
-              </a:rPr>
-              <a:t>5</a:t>
-            </a:r>
-            <a:endParaRPr lang="en-US" sz="3400" dirty="0"/>
+            <a:off x="749808" y="2752344"/>
+            <a:ext cx="5029200" cy="365760"/>
+          </a:xfrm>
+          <a:prstGeom prst="rect">
+            <a:avLst/>
+          </a:prstGeom>
+          <a:noFill/>
+          <a:ln/>
+        </p:spPr>
+        <p:txBody>
+          <a:bodyPr wrap="square" lIns="0" tIns="0" rIns="0" bIns="0" rtlCol="0" anchor="ctr"/>
+          <a:lstStyle/>
+          <a:p>
+            <a:pPr indent="0" marL="0">
+              <a:buNone/>
+            </a:pPr>
+            <a:r>
+              <a:rPr lang="en-US" sz="1400" b="1" dirty="0">
+                <a:solidFill>
+                  <a:srgbClr val="FFFFFF"/>
+                </a:solidFill>
+                <a:latin typeface="Calibri" pitchFamily="34" charset="0"/>
+                <a:ea typeface="Calibri" pitchFamily="34" charset="-122"/>
+                <a:cs typeface="Calibri" pitchFamily="34" charset="-120"/>
+              </a:rPr>
+              <a:t>Grounded on the live data</a:t>
+            </a:r>
+            <a:endParaRPr lang="en-US" sz="1400" dirty="0"/>
           </a:p>
         </p:txBody>
       </p:sp>
@@ -9799,8 +10462,8 @@
         </p:nvSpPr>
         <p:spPr>
           <a:xfrm>
-            <a:off x="4389120" y="2898648"/>
-            <a:ext cx="3108960" cy="731520"/>
+            <a:off x="749808" y="3099816"/>
+            <a:ext cx="5029200" cy="548640"/>
           </a:xfrm>
           <a:prstGeom prst="rect">
             <a:avLst/>
@@ -9814,12 +10477,12 @@
           <a:p>
             <a:pPr indent="0" marL="0">
               <a:lnSpc>
-                <a:spcPct val="100000"/>
+                <a:spcPct val="102000"/>
               </a:lnSpc>
               <a:buNone/>
             </a:pPr>
             <a:r>
-              <a:rPr lang="en-US" sz="1250" dirty="0">
+              <a:rPr lang="en-US" sz="1200" dirty="0">
                 <a:solidFill>
                   <a:srgbClr val="C7D6EC"/>
                 </a:solidFill>
@@ -9827,9 +10490,9 @@
                 <a:ea typeface="Calibri" pitchFamily="34" charset="-122"/>
                 <a:cs typeface="Calibri" pitchFamily="34" charset="-120"/>
               </a:rPr>
-              <a:t>Puri wards scored 33.6–92.4 / 100 with SHAP drivers</a:t>
-            </a:r>
-            <a:endParaRPr lang="en-US" sz="1250" dirty="0"/>
+              <a:t>Reads the wards, surge depths, shelters and routes on screen — and answers only from them.</a:t>
+            </a:r>
+            <a:endParaRPr lang="en-US" sz="1200" dirty="0"/>
           </a:p>
         </p:txBody>
       </p:sp>
@@ -9841,23 +10504,16 @@
         </p:nvSpPr>
         <p:spPr>
           <a:xfrm>
-            <a:off x="457200" y="3840480"/>
-            <a:ext cx="3566160" cy="1737360"/>
-          </a:xfrm>
-          <a:prstGeom prst="roundRect">
-            <a:avLst>
-              <a:gd name="adj" fmla="val 6316"/>
-            </a:avLst>
+            <a:off x="457200" y="3730752"/>
+            <a:ext cx="164592" cy="164592"/>
+          </a:xfrm>
+          <a:prstGeom prst="ellipse">
+            <a:avLst/>
           </a:prstGeom>
           <a:solidFill>
-            <a:srgbClr val="13294B"/>
+            <a:srgbClr val="34D399"/>
           </a:solidFill>
-          <a:ln w="12700">
-            <a:solidFill>
-              <a:srgbClr val="27466F"/>
-            </a:solidFill>
-            <a:prstDash val="solid"/>
-          </a:ln>
+          <a:ln/>
         </p:spPr>
       </p:sp>
       <p:sp>
@@ -9868,34 +10524,34 @@
         </p:nvSpPr>
         <p:spPr>
           <a:xfrm>
-            <a:off x="685800" y="4023360"/>
-            <a:ext cx="3108960" cy="777240"/>
-          </a:xfrm>
-          <a:prstGeom prst="rect">
-            <a:avLst/>
-          </a:prstGeom>
-          <a:noFill/>
-          <a:ln/>
-        </p:spPr>
-        <p:txBody>
-          <a:bodyPr wrap="square" lIns="0" tIns="0" rIns="0" bIns="0" rtlCol="0" anchor="ctr"/>
-          <a:lstStyle/>
-          <a:p>
-            <a:pPr indent="0" marL="0">
-              <a:buNone/>
-            </a:pPr>
-            <a:r>
-              <a:rPr lang="en-US" sz="3400" b="1" dirty="0">
-                <a:solidFill>
-                  <a:srgbClr val="FB7185"/>
-                </a:solidFill>
-                <a:latin typeface="Cambria" pitchFamily="34" charset="0"/>
-                <a:ea typeface="Cambria" pitchFamily="34" charset="-122"/>
-                <a:cs typeface="Cambria" pitchFamily="34" charset="-120"/>
-              </a:rPr>
-              <a:t>3.8 m</a:t>
-            </a:r>
-            <a:endParaRPr lang="en-US" sz="3400" dirty="0"/>
+            <a:off x="749808" y="3611880"/>
+            <a:ext cx="5029200" cy="365760"/>
+          </a:xfrm>
+          <a:prstGeom prst="rect">
+            <a:avLst/>
+          </a:prstGeom>
+          <a:noFill/>
+          <a:ln/>
+        </p:spPr>
+        <p:txBody>
+          <a:bodyPr wrap="square" lIns="0" tIns="0" rIns="0" bIns="0" rtlCol="0" anchor="ctr"/>
+          <a:lstStyle/>
+          <a:p>
+            <a:pPr indent="0" marL="0">
+              <a:buNone/>
+            </a:pPr>
+            <a:r>
+              <a:rPr lang="en-US" sz="1400" b="1" dirty="0">
+                <a:solidFill>
+                  <a:srgbClr val="FFFFFF"/>
+                </a:solidFill>
+                <a:latin typeface="Calibri" pitchFamily="34" charset="0"/>
+                <a:ea typeface="Calibri" pitchFamily="34" charset="-122"/>
+                <a:cs typeface="Calibri" pitchFamily="34" charset="-120"/>
+              </a:rPr>
+              <a:t>Never invents numbers</a:t>
+            </a:r>
+            <a:endParaRPr lang="en-US" sz="1400" dirty="0"/>
           </a:p>
         </p:txBody>
       </p:sp>
@@ -9907,8 +10563,8 @@
         </p:nvSpPr>
         <p:spPr>
           <a:xfrm>
-            <a:off x="685800" y="4773168"/>
-            <a:ext cx="3108960" cy="731520"/>
+            <a:off x="749808" y="3959352"/>
+            <a:ext cx="5029200" cy="548640"/>
           </a:xfrm>
           <a:prstGeom prst="rect">
             <a:avLst/>
@@ -9922,12 +10578,12 @@
           <a:p>
             <a:pPr indent="0" marL="0">
               <a:lnSpc>
-                <a:spcPct val="100000"/>
+                <a:spcPct val="102000"/>
               </a:lnSpc>
               <a:buNone/>
             </a:pPr>
             <a:r>
-              <a:rPr lang="en-US" sz="1250" dirty="0">
+              <a:rPr lang="en-US" sz="1200" dirty="0">
                 <a:solidFill>
                   <a:srgbClr val="C7D6EC"/>
                 </a:solidFill>
@@ -9935,9 +10591,9 @@
                 <a:ea typeface="Calibri" pitchFamily="34" charset="-122"/>
                 <a:cs typeface="Calibri" pitchFamily="34" charset="-120"/>
               </a:rPr>
-              <a:t>Peak storm surge (Holland parametric model)</a:t>
-            </a:r>
-            <a:endParaRPr lang="en-US" sz="1250" dirty="0"/>
+              <a:t>Cites real ward IDs, vulnerability scores and shelter status; says so when data is missing.</a:t>
+            </a:r>
+            <a:endParaRPr lang="en-US" sz="1200" dirty="0"/>
           </a:p>
         </p:txBody>
       </p:sp>
@@ -9949,23 +10605,16 @@
         </p:nvSpPr>
         <p:spPr>
           <a:xfrm>
-            <a:off x="4160520" y="3840480"/>
-            <a:ext cx="3566160" cy="1737360"/>
-          </a:xfrm>
-          <a:prstGeom prst="roundRect">
-            <a:avLst>
-              <a:gd name="adj" fmla="val 6316"/>
-            </a:avLst>
+            <a:off x="457200" y="4590288"/>
+            <a:ext cx="164592" cy="164592"/>
+          </a:xfrm>
+          <a:prstGeom prst="ellipse">
+            <a:avLst/>
           </a:prstGeom>
           <a:solidFill>
-            <a:srgbClr val="13294B"/>
+            <a:srgbClr val="34D399"/>
           </a:solidFill>
-          <a:ln w="12700">
-            <a:solidFill>
-              <a:srgbClr val="27466F"/>
-            </a:solidFill>
-            <a:prstDash val="solid"/>
-          </a:ln>
+          <a:ln/>
         </p:spPr>
       </p:sp>
       <p:sp>
@@ -9976,34 +10625,34 @@
         </p:nvSpPr>
         <p:spPr>
           <a:xfrm>
-            <a:off x="4389120" y="4023360"/>
-            <a:ext cx="3108960" cy="777240"/>
-          </a:xfrm>
-          <a:prstGeom prst="rect">
-            <a:avLst/>
-          </a:prstGeom>
-          <a:noFill/>
-          <a:ln/>
-        </p:spPr>
-        <p:txBody>
-          <a:bodyPr wrap="square" lIns="0" tIns="0" rIns="0" bIns="0" rtlCol="0" anchor="ctr"/>
-          <a:lstStyle/>
-          <a:p>
-            <a:pPr indent="0" marL="0">
-              <a:buNone/>
-            </a:pPr>
-            <a:r>
-              <a:rPr lang="en-US" sz="3400" b="1" dirty="0">
-                <a:solidFill>
-                  <a:srgbClr val="34D399"/>
-                </a:solidFill>
-                <a:latin typeface="Cambria" pitchFamily="34" charset="0"/>
-                <a:ea typeface="Cambria" pitchFamily="34" charset="-122"/>
-                <a:cs typeface="Cambria" pitchFamily="34" charset="-120"/>
-              </a:rPr>
-              <a:t>71%</a:t>
-            </a:r>
-            <a:endParaRPr lang="en-US" sz="3400" dirty="0"/>
+            <a:off x="749808" y="4471416"/>
+            <a:ext cx="5029200" cy="365760"/>
+          </a:xfrm>
+          <a:prstGeom prst="rect">
+            <a:avLst/>
+          </a:prstGeom>
+          <a:noFill/>
+          <a:ln/>
+        </p:spPr>
+        <p:txBody>
+          <a:bodyPr wrap="square" lIns="0" tIns="0" rIns="0" bIns="0" rtlCol="0" anchor="ctr"/>
+          <a:lstStyle/>
+          <a:p>
+            <a:pPr indent="0" marL="0">
+              <a:buNone/>
+            </a:pPr>
+            <a:r>
+              <a:rPr lang="en-US" sz="1400" b="1" dirty="0">
+                <a:solidFill>
+                  <a:srgbClr val="FFFFFF"/>
+                </a:solidFill>
+                <a:latin typeface="Calibri" pitchFamily="34" charset="0"/>
+                <a:ea typeface="Calibri" pitchFamily="34" charset="-122"/>
+                <a:cs typeface="Calibri" pitchFamily="34" charset="-120"/>
+              </a:rPr>
+              <a:t>Streaming &amp; low-latency</a:t>
+            </a:r>
+            <a:endParaRPr lang="en-US" sz="1400" dirty="0"/>
           </a:p>
         </p:txBody>
       </p:sp>
@@ -10015,8 +10664,8 @@
         </p:nvSpPr>
         <p:spPr>
           <a:xfrm>
-            <a:off x="4389120" y="4773168"/>
-            <a:ext cx="3108960" cy="731520"/>
+            <a:off x="749808" y="4818888"/>
+            <a:ext cx="5029200" cy="548640"/>
           </a:xfrm>
           <a:prstGeom prst="rect">
             <a:avLst/>
@@ -10030,12 +10679,12 @@
           <a:p>
             <a:pPr indent="0" marL="0">
               <a:lnSpc>
-                <a:spcPct val="100000"/>
+                <a:spcPct val="102000"/>
               </a:lnSpc>
               <a:buNone/>
             </a:pPr>
             <a:r>
-              <a:rPr lang="en-US" sz="1250" dirty="0">
+              <a:rPr lang="en-US" sz="1200" dirty="0">
                 <a:solidFill>
                   <a:srgbClr val="C7D6EC"/>
                 </a:solidFill>
@@ -10043,15 +10692,116 @@
                 <a:ea typeface="Calibri" pitchFamily="34" charset="-122"/>
                 <a:cs typeface="Calibri" pitchFamily="34" charset="-120"/>
               </a:rPr>
-              <a:t>IoU vs. Sentinel-1 SAR flood ground-truth</a:t>
-            </a:r>
-            <a:endParaRPr lang="en-US" sz="1250" dirty="0"/>
+              <a:t>Minimal-thinking responses stream in — fast enough for a live operations room.</a:t>
+            </a:r>
+            <a:endParaRPr lang="en-US" sz="1200" dirty="0"/>
+          </a:p>
+        </p:txBody>
+      </p:sp>
+      <p:sp>
+        <p:nvSpPr>
+          <p:cNvPr id="16" name="Shape 14"/>
+          <p:cNvSpPr/>
+          <p:nvPr/>
+        </p:nvSpPr>
+        <p:spPr>
+          <a:xfrm>
+            <a:off x="457200" y="5449824"/>
+            <a:ext cx="164592" cy="164592"/>
+          </a:xfrm>
+          <a:prstGeom prst="ellipse">
+            <a:avLst/>
+          </a:prstGeom>
+          <a:solidFill>
+            <a:srgbClr val="34D399"/>
+          </a:solidFill>
+          <a:ln/>
+        </p:spPr>
+      </p:sp>
+      <p:sp>
+        <p:nvSpPr>
+          <p:cNvPr id="17" name="Text 15"/>
+          <p:cNvSpPr txBox="1"/>
+          <p:nvPr/>
+        </p:nvSpPr>
+        <p:spPr>
+          <a:xfrm>
+            <a:off x="749808" y="5330952"/>
+            <a:ext cx="5029200" cy="365760"/>
+          </a:xfrm>
+          <a:prstGeom prst="rect">
+            <a:avLst/>
+          </a:prstGeom>
+          <a:noFill/>
+          <a:ln/>
+        </p:spPr>
+        <p:txBody>
+          <a:bodyPr wrap="square" lIns="0" tIns="0" rIns="0" bIns="0" rtlCol="0" anchor="ctr"/>
+          <a:lstStyle/>
+          <a:p>
+            <a:pPr indent="0" marL="0">
+              <a:buNone/>
+            </a:pPr>
+            <a:r>
+              <a:rPr lang="en-US" sz="1400" b="1" dirty="0">
+                <a:solidFill>
+                  <a:srgbClr val="FFFFFF"/>
+                </a:solidFill>
+                <a:latin typeface="Calibri" pitchFamily="34" charset="0"/>
+                <a:ea typeface="Calibri" pitchFamily="34" charset="-122"/>
+                <a:cs typeface="Calibri" pitchFamily="34" charset="-120"/>
+              </a:rPr>
+              <a:t>Trilingual advisories</a:t>
+            </a:r>
+            <a:endParaRPr lang="en-US" sz="1400" dirty="0"/>
+          </a:p>
+        </p:txBody>
+      </p:sp>
+      <p:sp>
+        <p:nvSpPr>
+          <p:cNvPr id="18" name="Text 16"/>
+          <p:cNvSpPr txBox="1"/>
+          <p:nvPr/>
+        </p:nvSpPr>
+        <p:spPr>
+          <a:xfrm>
+            <a:off x="749808" y="5678424"/>
+            <a:ext cx="5029200" cy="548640"/>
+          </a:xfrm>
+          <a:prstGeom prst="rect">
+            <a:avLst/>
+          </a:prstGeom>
+          <a:noFill/>
+          <a:ln/>
+        </p:spPr>
+        <p:txBody>
+          <a:bodyPr wrap="square" lIns="0" tIns="0" rIns="0" bIns="0" rtlCol="0" anchor="ctr"/>
+          <a:lstStyle/>
+          <a:p>
+            <a:pPr indent="0" marL="0">
+              <a:lnSpc>
+                <a:spcPct val="102000"/>
+              </a:lnSpc>
+              <a:buNone/>
+            </a:pPr>
+            <a:r>
+              <a:rPr lang="en-US" sz="1200" dirty="0">
+                <a:solidFill>
+                  <a:srgbClr val="C7D6EC"/>
+                </a:solidFill>
+                <a:latin typeface="Calibri" pitchFamily="34" charset="0"/>
+                <a:ea typeface="Calibri" pitchFamily="34" charset="-122"/>
+                <a:cs typeface="Calibri" pitchFamily="34" charset="-120"/>
+              </a:rPr>
+              <a:t>Answers and drafts official early-warning advisories in Odia, Hindi or English.</a:t>
+            </a:r>
+            <a:endParaRPr lang="en-US" sz="1200" dirty="0"/>
           </a:p>
         </p:txBody>
       </p:sp>
       <p:pic>
         <p:nvPicPr>
-          <p:cNvPr id="16" name="Image 0" descr="C:/Users/ABHISH~1.AGA/AppData/Local/Temp/claude/c--Users-abhishek-q-agarwal-Downloads-h2s/81d2d1cd-3a2c-4b7e-9761-45a2bd863e24/scratchpad/img/s_fani_puri.jpg">    </p:cNvPr>
+          <p:cNvPr id="19" name="Image 0" descr="C:/Users/ABHISH~1.AGA/AppData/Local/Temp/claude/c--Users-abhishek-q-agarwal-Downloads-h2s/81d2d1cd-3a2c-4b7e-9761-45a2bd863e24/scratchpad/img/s_app_advisor.jpg">    </p:cNvPr>
           <p:cNvPicPr>
             <a:picLocks noChangeAspect="1"/>
           </p:cNvPicPr>
@@ -10064,8 +10814,8 @@
         </p:blipFill>
         <p:spPr>
           <a:xfrm>
-            <a:off x="8001000" y="1965960"/>
-            <a:ext cx="3730752" cy="3611880"/>
+            <a:off x="6217920" y="1965960"/>
+            <a:ext cx="5513832" cy="3099816"/>
           </a:xfrm>
           <a:prstGeom prst="rect">
             <a:avLst/>
@@ -10074,14 +10824,14 @@
       </p:pic>
       <p:sp>
         <p:nvSpPr>
-          <p:cNvPr id="17" name="Text 14"/>
-          <p:cNvSpPr txBox="1"/>
-          <p:nvPr/>
-        </p:nvSpPr>
-        <p:spPr>
-          <a:xfrm>
-            <a:off x="8001000" y="5596128"/>
-            <a:ext cx="3730752" cy="256032"/>
+          <p:cNvPr id="20" name="Text 17"/>
+          <p:cNvSpPr txBox="1"/>
+          <p:nvPr/>
+        </p:nvSpPr>
+        <p:spPr>
+          <a:xfrm>
+            <a:off x="6217920" y="5138928"/>
+            <a:ext cx="5513832" cy="365760"/>
           </a:xfrm>
           <a:prstGeom prst="rect">
             <a:avLst/>
@@ -10097,62 +10847,23 @@
               <a:buNone/>
             </a:pPr>
             <a:r>
-              <a:rPr lang="en-US" sz="850" dirty="0">
-                <a:solidFill>
-                  <a:srgbClr val="E8EEF7"/>
-                </a:solidFill>
-                <a:latin typeface="Calibri" pitchFamily="34" charset="0"/>
-                <a:ea typeface="Calibri" pitchFamily="34" charset="-122"/>
-                <a:cs typeface="Calibri" pitchFamily="34" charset="-120"/>
-              </a:rPr>
-              <a:t>MODIS · Fani landfall, Puri · 3 May 2019 · NASA</a:t>
-            </a:r>
-            <a:endParaRPr lang="en-US" sz="850" dirty="0"/>
-          </a:p>
-        </p:txBody>
-      </p:sp>
-      <p:sp>
-        <p:nvSpPr>
-          <p:cNvPr id="18" name="Text 15"/>
-          <p:cNvSpPr txBox="1"/>
-          <p:nvPr/>
-        </p:nvSpPr>
-        <p:spPr>
-          <a:xfrm>
-            <a:off x="457200" y="6163056"/>
-            <a:ext cx="11247120" cy="256032"/>
-          </a:xfrm>
-          <a:prstGeom prst="rect">
-            <a:avLst/>
-          </a:prstGeom>
-          <a:noFill/>
-          <a:ln/>
-        </p:spPr>
-        <p:txBody>
-          <a:bodyPr wrap="square" lIns="0" tIns="0" rIns="0" bIns="0" rtlCol="0" anchor="ctr"/>
-          <a:lstStyle/>
-          <a:p>
-            <a:pPr algn="l" indent="0" marL="0">
-              <a:buNone/>
-            </a:pPr>
-            <a:r>
-              <a:rPr lang="en-US" sz="850" i="1" dirty="0">
-                <a:solidFill>
-                  <a:srgbClr val="6B7F9E"/>
-                </a:solidFill>
-                <a:latin typeface="Calibri" pitchFamily="34" charset="0"/>
-                <a:ea typeface="Calibri" pitchFamily="34" charset="-122"/>
-                <a:cs typeface="Calibri" pitchFamily="34" charset="-120"/>
-              </a:rPr>
-              <a:t>IMD best-track &amp; OSDMA reports; surge, ponding &amp; shelter status from the PRAHARI hazard pipeline; upgradable to live GEE layers.</a:t>
-            </a:r>
-            <a:endParaRPr lang="en-US" sz="850" dirty="0"/>
-          </a:p>
-        </p:txBody>
-      </p:sp>
-      <p:sp>
-        <p:nvSpPr>
-          <p:cNvPr id="19" name="Text 16"/>
+              <a:rPr lang="en-US" sz="1050" i="1" dirty="0">
+                <a:solidFill>
+                  <a:srgbClr val="93A5C0"/>
+                </a:solidFill>
+                <a:latin typeface="Calibri" pitchFamily="34" charset="0"/>
+                <a:ea typeface="Calibri" pitchFamily="34" charset="-122"/>
+                <a:cs typeface="Calibri" pitchFamily="34" charset="-120"/>
+              </a:rPr>
+              <a:t>Live answer — grounded in the real Puri ward data (English shown; also Odia / Hindi)</a:t>
+            </a:r>
+            <a:endParaRPr lang="en-US" sz="1050" dirty="0"/>
+          </a:p>
+        </p:txBody>
+      </p:sp>
+      <p:sp>
+        <p:nvSpPr>
+          <p:cNvPr id="21" name="Text 18"/>
           <p:cNvSpPr txBox="1"/>
           <p:nvPr/>
         </p:nvSpPr>
@@ -10205,7 +10916,7 @@
       </p:sp>
       <p:sp>
         <p:nvSpPr>
-          <p:cNvPr id="20" name="Text 17"/>
+          <p:cNvPr id="22" name="Text 19"/>
           <p:cNvSpPr txBox="1"/>
           <p:nvPr/>
         </p:nvSpPr>
@@ -10301,13 +11012,13 @@
             <a:r>
               <a:rPr lang="en-US" sz="1200" b="1" spc="300" kern="0" dirty="0">
                 <a:solidFill>
-                  <a:srgbClr val="34D399"/>
-                </a:solidFill>
-                <a:latin typeface="Calibri" pitchFamily="34" charset="0"/>
-                <a:ea typeface="Calibri" pitchFamily="34" charset="-122"/>
-                <a:cs typeface="Calibri" pitchFamily="34" charset="-120"/>
-              </a:rPr>
-              <a:t>WHY IT MATTERS</a:t>
+                  <a:srgbClr val="FBBF24"/>
+                </a:solidFill>
+                <a:latin typeface="Calibri" pitchFamily="34" charset="0"/>
+                <a:ea typeface="Calibri" pitchFamily="34" charset="-122"/>
+                <a:cs typeface="Calibri" pitchFamily="34" charset="-120"/>
+              </a:rPr>
+              <a:t>ZERO MOCKUPS · REAL FIXTURES</a:t>
             </a:r>
             <a:endParaRPr lang="en-US" sz="1200" dirty="0"/>
           </a:p>
@@ -10349,46 +11060,30 @@
                 <a:ea typeface="Cambria" pitchFamily="34" charset="-122"/>
                 <a:cs typeface="Cambria" pitchFamily="34" charset="-120"/>
               </a:rPr>
-              <a:t>Early warning saves lives — the frontier is assets</a:t>
+              <a:t>Built on actual Cyclone Fani data</a:t>
             </a:r>
             <a:endParaRPr lang="en-US" sz="3400" dirty="0"/>
           </a:p>
         </p:txBody>
       </p:sp>
-      <p:graphicFrame>
-        <p:nvGraphicFramePr>
-          <p:cNvPr id="4" name="Chart 0" descr=""/>
-          <p:cNvGraphicFramePr/>
-          <p:nvPr/>
-        </p:nvGraphicFramePr>
-        <p:xfrm>
-          <a:off x="457200" y="2011680"/>
-          <a:ext cx="5943600" cy="3657600"/>
-        </p:xfrm>
-        <a:graphic xmlns:a="http://schemas.openxmlformats.org/drawingml/2006/main">
-          <a:graphicData uri="http://schemas.openxmlformats.org/drawingml/2006/chart">
-            <c:chart xmlns:c="http://schemas.openxmlformats.org/drawingml/2006/chart" r:id="rId1"/>
-          </a:graphicData>
-        </a:graphic>
-      </p:graphicFrame>
-      <p:sp>
-        <p:nvSpPr>
-          <p:cNvPr id="5" name="Shape 2"/>
+      <p:sp>
+        <p:nvSpPr>
+          <p:cNvPr id="4" name="Shape 2"/>
           <p:cNvSpPr/>
           <p:nvPr/>
         </p:nvSpPr>
         <p:spPr>
           <a:xfrm>
-            <a:off x="6675120" y="2011680"/>
-            <a:ext cx="5056632" cy="3657600"/>
+            <a:off x="457200" y="1965960"/>
+            <a:ext cx="3566160" cy="1737360"/>
           </a:xfrm>
           <a:prstGeom prst="roundRect">
             <a:avLst>
-              <a:gd name="adj" fmla="val 3000"/>
+              <a:gd name="adj" fmla="val 6316"/>
             </a:avLst>
           </a:prstGeom>
           <a:solidFill>
-            <a:srgbClr val="0F2140"/>
+            <a:srgbClr val="13294B"/>
           </a:solidFill>
           <a:ln w="12700">
             <a:solidFill>
@@ -10400,104 +11095,283 @@
       </p:sp>
       <p:sp>
         <p:nvSpPr>
-          <p:cNvPr id="6" name="Text 3"/>
-          <p:cNvSpPr txBox="1"/>
-          <p:nvPr/>
-        </p:nvSpPr>
-        <p:spPr>
-          <a:xfrm>
-            <a:off x="6949440" y="2194560"/>
-            <a:ext cx="4572000" cy="365760"/>
-          </a:xfrm>
-          <a:prstGeom prst="rect">
-            <a:avLst/>
-          </a:prstGeom>
-          <a:noFill/>
-          <a:ln/>
-        </p:spPr>
-        <p:txBody>
-          <a:bodyPr wrap="square" lIns="0" tIns="0" rIns="0" bIns="0" rtlCol="0" anchor="ctr"/>
-          <a:lstStyle/>
-          <a:p>
-            <a:pPr indent="0" marL="0">
-              <a:buNone/>
-            </a:pPr>
-            <a:r>
-              <a:rPr lang="en-US" sz="1600" b="1" dirty="0">
-                <a:solidFill>
-                  <a:srgbClr val="FFFFFF"/>
+          <p:cNvPr id="5" name="Text 3"/>
+          <p:cNvSpPr txBox="1"/>
+          <p:nvPr/>
+        </p:nvSpPr>
+        <p:spPr>
+          <a:xfrm>
+            <a:off x="685800" y="2148840"/>
+            <a:ext cx="3108960" cy="777240"/>
+          </a:xfrm>
+          <a:prstGeom prst="rect">
+            <a:avLst/>
+          </a:prstGeom>
+          <a:noFill/>
+          <a:ln/>
+        </p:spPr>
+        <p:txBody>
+          <a:bodyPr wrap="square" lIns="0" tIns="0" rIns="0" bIns="0" rtlCol="0" anchor="ctr"/>
+          <a:lstStyle/>
+          <a:p>
+            <a:pPr indent="0" marL="0">
+              <a:buNone/>
+            </a:pPr>
+            <a:r>
+              <a:rPr lang="en-US" sz="3400" b="1" dirty="0">
+                <a:solidFill>
+                  <a:srgbClr val="38BDF8"/>
                 </a:solidFill>
                 <a:latin typeface="Cambria" pitchFamily="34" charset="0"/>
                 <a:ea typeface="Cambria" pitchFamily="34" charset="-122"/>
                 <a:cs typeface="Cambria" pitchFamily="34" charset="-120"/>
               </a:rPr>
-              <a:t>Who benefits</a:t>
-            </a:r>
-            <a:endParaRPr lang="en-US" sz="1600" dirty="0"/>
-          </a:p>
-        </p:txBody>
-      </p:sp>
-      <p:sp>
-        <p:nvSpPr>
-          <p:cNvPr id="7" name="Shape 4"/>
+              <a:t>13</a:t>
+            </a:r>
+            <a:endParaRPr lang="en-US" sz="3400" dirty="0"/>
+          </a:p>
+        </p:txBody>
+      </p:sp>
+      <p:sp>
+        <p:nvSpPr>
+          <p:cNvPr id="6" name="Text 4"/>
+          <p:cNvSpPr txBox="1"/>
+          <p:nvPr/>
+        </p:nvSpPr>
+        <p:spPr>
+          <a:xfrm>
+            <a:off x="685800" y="2898648"/>
+            <a:ext cx="3108960" cy="731520"/>
+          </a:xfrm>
+          <a:prstGeom prst="rect">
+            <a:avLst/>
+          </a:prstGeom>
+          <a:noFill/>
+          <a:ln/>
+        </p:spPr>
+        <p:txBody>
+          <a:bodyPr wrap="square" lIns="0" tIns="0" rIns="0" bIns="0" rtlCol="0" anchor="ctr"/>
+          <a:lstStyle/>
+          <a:p>
+            <a:pPr indent="0" marL="0">
+              <a:lnSpc>
+                <a:spcPct val="100000"/>
+              </a:lnSpc>
+              <a:buNone/>
+            </a:pPr>
+            <a:r>
+              <a:rPr lang="en-US" sz="1250" dirty="0">
+                <a:solidFill>
+                  <a:srgbClr val="C7D6EC"/>
+                </a:solidFill>
+                <a:latin typeface="Calibri" pitchFamily="34" charset="0"/>
+                <a:ea typeface="Calibri" pitchFamily="34" charset="-122"/>
+                <a:cs typeface="Calibri" pitchFamily="34" charset="-120"/>
+              </a:rPr>
+              <a:t>IMD/JTWC best-track waypoints, T-48h → landfall</a:t>
+            </a:r>
+            <a:endParaRPr lang="en-US" sz="1250" dirty="0"/>
+          </a:p>
+        </p:txBody>
+      </p:sp>
+      <p:sp>
+        <p:nvSpPr>
+          <p:cNvPr id="7" name="Shape 5"/>
           <p:cNvSpPr/>
           <p:nvPr/>
         </p:nvSpPr>
         <p:spPr>
           <a:xfrm>
-            <a:off x="6949440" y="2743200"/>
-            <a:ext cx="137160" cy="137160"/>
-          </a:xfrm>
-          <a:prstGeom prst="ellipse">
-            <a:avLst/>
+            <a:off x="4160520" y="1965960"/>
+            <a:ext cx="3566160" cy="1737360"/>
+          </a:xfrm>
+          <a:prstGeom prst="roundRect">
+            <a:avLst>
+              <a:gd name="adj" fmla="val 6316"/>
+            </a:avLst>
           </a:prstGeom>
           <a:solidFill>
-            <a:srgbClr val="38BDF8"/>
+            <a:srgbClr val="13294B"/>
           </a:solidFill>
-          <a:ln/>
-        </p:spPr>
-      </p:sp>
-      <p:sp>
-        <p:nvSpPr>
-          <p:cNvPr id="8" name="Text 5"/>
-          <p:cNvSpPr txBox="1"/>
-          <p:nvPr/>
-        </p:nvSpPr>
-        <p:spPr>
-          <a:xfrm>
-            <a:off x="7178040" y="2624328"/>
-            <a:ext cx="4389120" cy="822960"/>
-          </a:xfrm>
-          <a:prstGeom prst="rect">
-            <a:avLst/>
-          </a:prstGeom>
-          <a:noFill/>
-          <a:ln/>
-        </p:spPr>
-        <p:txBody>
-          <a:bodyPr wrap="square" lIns="0" tIns="0" rIns="0" bIns="0" rtlCol="0" anchor="t"/>
+          <a:ln w="12700">
+            <a:solidFill>
+              <a:srgbClr val="27466F"/>
+            </a:solidFill>
+            <a:prstDash val="solid"/>
+          </a:ln>
+        </p:spPr>
+      </p:sp>
+      <p:sp>
+        <p:nvSpPr>
+          <p:cNvPr id="8" name="Text 6"/>
+          <p:cNvSpPr txBox="1"/>
+          <p:nvPr/>
+        </p:nvSpPr>
+        <p:spPr>
+          <a:xfrm>
+            <a:off x="4389120" y="2148840"/>
+            <a:ext cx="3108960" cy="777240"/>
+          </a:xfrm>
+          <a:prstGeom prst="rect">
+            <a:avLst/>
+          </a:prstGeom>
+          <a:noFill/>
+          <a:ln/>
+        </p:spPr>
+        <p:txBody>
+          <a:bodyPr wrap="square" lIns="0" tIns="0" rIns="0" bIns="0" rtlCol="0" anchor="ctr"/>
+          <a:lstStyle/>
+          <a:p>
+            <a:pPr indent="0" marL="0">
+              <a:buNone/>
+            </a:pPr>
+            <a:r>
+              <a:rPr lang="en-US" sz="3400" b="1" dirty="0">
+                <a:solidFill>
+                  <a:srgbClr val="FBBF24"/>
+                </a:solidFill>
+                <a:latin typeface="Cambria" pitchFamily="34" charset="0"/>
+                <a:ea typeface="Cambria" pitchFamily="34" charset="-122"/>
+                <a:cs typeface="Cambria" pitchFamily="34" charset="-120"/>
+              </a:rPr>
+              <a:t>5</a:t>
+            </a:r>
+            <a:endParaRPr lang="en-US" sz="3400" dirty="0"/>
+          </a:p>
+        </p:txBody>
+      </p:sp>
+      <p:sp>
+        <p:nvSpPr>
+          <p:cNvPr id="9" name="Text 7"/>
+          <p:cNvSpPr txBox="1"/>
+          <p:nvPr/>
+        </p:nvSpPr>
+        <p:spPr>
+          <a:xfrm>
+            <a:off x="4389120" y="2898648"/>
+            <a:ext cx="3108960" cy="731520"/>
+          </a:xfrm>
+          <a:prstGeom prst="rect">
+            <a:avLst/>
+          </a:prstGeom>
+          <a:noFill/>
+          <a:ln/>
+        </p:spPr>
+        <p:txBody>
+          <a:bodyPr wrap="square" lIns="0" tIns="0" rIns="0" bIns="0" rtlCol="0" anchor="ctr"/>
           <a:lstStyle/>
           <a:p>
             <a:pPr indent="0" marL="0">
               <a:lnSpc>
-                <a:spcPct val="105000"/>
+                <a:spcPct val="100000"/>
               </a:lnSpc>
               <a:buNone/>
             </a:pPr>
             <a:r>
-              <a:rPr lang="en-US" sz="1250" b="1" dirty="0">
-                <a:solidFill>
-                  <a:srgbClr val="FFFFFF"/>
-                </a:solidFill>
-                <a:latin typeface="Calibri" pitchFamily="34" charset="0"/>
-                <a:ea typeface="Calibri" pitchFamily="34" charset="-122"/>
-                <a:cs typeface="Calibri" pitchFamily="34" charset="-120"/>
-              </a:rPr>
-              <a:t>Responders </a:t>
-            </a:r>
+              <a:rPr lang="en-US" sz="1250" dirty="0">
+                <a:solidFill>
+                  <a:srgbClr val="C7D6EC"/>
+                </a:solidFill>
+                <a:latin typeface="Calibri" pitchFamily="34" charset="0"/>
+                <a:ea typeface="Calibri" pitchFamily="34" charset="-122"/>
+                <a:cs typeface="Calibri" pitchFamily="34" charset="-120"/>
+              </a:rPr>
+              <a:t>Puri wards scored 33.6–92.4 / 100 with SHAP drivers</a:t>
+            </a:r>
+            <a:endParaRPr lang="en-US" sz="1250" dirty="0"/>
+          </a:p>
+        </p:txBody>
+      </p:sp>
+      <p:sp>
+        <p:nvSpPr>
+          <p:cNvPr id="10" name="Shape 8"/>
+          <p:cNvSpPr/>
+          <p:nvPr/>
+        </p:nvSpPr>
+        <p:spPr>
+          <a:xfrm>
+            <a:off x="457200" y="3840480"/>
+            <a:ext cx="3566160" cy="1737360"/>
+          </a:xfrm>
+          <a:prstGeom prst="roundRect">
+            <a:avLst>
+              <a:gd name="adj" fmla="val 6316"/>
+            </a:avLst>
+          </a:prstGeom>
+          <a:solidFill>
+            <a:srgbClr val="13294B"/>
+          </a:solidFill>
+          <a:ln w="12700">
+            <a:solidFill>
+              <a:srgbClr val="27466F"/>
+            </a:solidFill>
+            <a:prstDash val="solid"/>
+          </a:ln>
+        </p:spPr>
+      </p:sp>
+      <p:sp>
+        <p:nvSpPr>
+          <p:cNvPr id="11" name="Text 9"/>
+          <p:cNvSpPr txBox="1"/>
+          <p:nvPr/>
+        </p:nvSpPr>
+        <p:spPr>
+          <a:xfrm>
+            <a:off x="685800" y="4023360"/>
+            <a:ext cx="3108960" cy="777240"/>
+          </a:xfrm>
+          <a:prstGeom prst="rect">
+            <a:avLst/>
+          </a:prstGeom>
+          <a:noFill/>
+          <a:ln/>
+        </p:spPr>
+        <p:txBody>
+          <a:bodyPr wrap="square" lIns="0" tIns="0" rIns="0" bIns="0" rtlCol="0" anchor="ctr"/>
+          <a:lstStyle/>
+          <a:p>
+            <a:pPr indent="0" marL="0">
+              <a:buNone/>
+            </a:pPr>
+            <a:r>
+              <a:rPr lang="en-US" sz="3400" b="1" dirty="0">
+                <a:solidFill>
+                  <a:srgbClr val="FB7185"/>
+                </a:solidFill>
+                <a:latin typeface="Cambria" pitchFamily="34" charset="0"/>
+                <a:ea typeface="Cambria" pitchFamily="34" charset="-122"/>
+                <a:cs typeface="Cambria" pitchFamily="34" charset="-120"/>
+              </a:rPr>
+              <a:t>3.8 m</a:t>
+            </a:r>
+            <a:endParaRPr lang="en-US" sz="3400" dirty="0"/>
+          </a:p>
+        </p:txBody>
+      </p:sp>
+      <p:sp>
+        <p:nvSpPr>
+          <p:cNvPr id="12" name="Text 10"/>
+          <p:cNvSpPr txBox="1"/>
+          <p:nvPr/>
+        </p:nvSpPr>
+        <p:spPr>
+          <a:xfrm>
+            <a:off x="685800" y="4773168"/>
+            <a:ext cx="3108960" cy="731520"/>
+          </a:xfrm>
+          <a:prstGeom prst="rect">
+            <a:avLst/>
+          </a:prstGeom>
+          <a:noFill/>
+          <a:ln/>
+        </p:spPr>
+        <p:txBody>
+          <a:bodyPr wrap="square" lIns="0" tIns="0" rIns="0" bIns="0" rtlCol="0" anchor="ctr"/>
+          <a:lstStyle/>
+          <a:p>
             <a:pPr indent="0" marL="0">
               <a:lnSpc>
-                <a:spcPct val="105000"/>
+                <a:spcPct val="100000"/>
               </a:lnSpc>
               <a:buNone/>
             </a:pPr>
@@ -10510,7 +11384,7 @@
                 <a:ea typeface="Calibri" pitchFamily="34" charset="-122"/>
                 <a:cs typeface="Calibri" pitchFamily="34" charset="-120"/>
               </a:rPr>
-              <a:t>see which shelters are reachable and which roads are severed — before deploying.</a:t>
+              <a:t>Peak storm surge (Holland parametric model)</a:t>
             </a:r>
             <a:endParaRPr lang="en-US" sz="1250" dirty="0"/>
           </a:p>
@@ -10518,69 +11392,98 @@
       </p:sp>
       <p:sp>
         <p:nvSpPr>
-          <p:cNvPr id="9" name="Shape 6"/>
+          <p:cNvPr id="13" name="Shape 11"/>
           <p:cNvSpPr/>
           <p:nvPr/>
         </p:nvSpPr>
         <p:spPr>
           <a:xfrm>
-            <a:off x="6949440" y="3675888"/>
-            <a:ext cx="137160" cy="137160"/>
-          </a:xfrm>
-          <a:prstGeom prst="ellipse">
-            <a:avLst/>
+            <a:off x="4160520" y="3840480"/>
+            <a:ext cx="3566160" cy="1737360"/>
+          </a:xfrm>
+          <a:prstGeom prst="roundRect">
+            <a:avLst>
+              <a:gd name="adj" fmla="val 6316"/>
+            </a:avLst>
           </a:prstGeom>
           <a:solidFill>
-            <a:srgbClr val="FBBF24"/>
+            <a:srgbClr val="13294B"/>
           </a:solidFill>
-          <a:ln/>
-        </p:spPr>
-      </p:sp>
-      <p:sp>
-        <p:nvSpPr>
-          <p:cNvPr id="10" name="Text 7"/>
-          <p:cNvSpPr txBox="1"/>
-          <p:nvPr/>
-        </p:nvSpPr>
-        <p:spPr>
-          <a:xfrm>
-            <a:off x="7178040" y="3557016"/>
-            <a:ext cx="4389120" cy="822960"/>
-          </a:xfrm>
-          <a:prstGeom prst="rect">
-            <a:avLst/>
-          </a:prstGeom>
-          <a:noFill/>
-          <a:ln/>
-        </p:spPr>
-        <p:txBody>
-          <a:bodyPr wrap="square" lIns="0" tIns="0" rIns="0" bIns="0" rtlCol="0" anchor="t"/>
+          <a:ln w="12700">
+            <a:solidFill>
+              <a:srgbClr val="27466F"/>
+            </a:solidFill>
+            <a:prstDash val="solid"/>
+          </a:ln>
+        </p:spPr>
+      </p:sp>
+      <p:sp>
+        <p:nvSpPr>
+          <p:cNvPr id="14" name="Text 12"/>
+          <p:cNvSpPr txBox="1"/>
+          <p:nvPr/>
+        </p:nvSpPr>
+        <p:spPr>
+          <a:xfrm>
+            <a:off x="4389120" y="4023360"/>
+            <a:ext cx="3108960" cy="777240"/>
+          </a:xfrm>
+          <a:prstGeom prst="rect">
+            <a:avLst/>
+          </a:prstGeom>
+          <a:noFill/>
+          <a:ln/>
+        </p:spPr>
+        <p:txBody>
+          <a:bodyPr wrap="square" lIns="0" tIns="0" rIns="0" bIns="0" rtlCol="0" anchor="ctr"/>
+          <a:lstStyle/>
+          <a:p>
+            <a:pPr indent="0" marL="0">
+              <a:buNone/>
+            </a:pPr>
+            <a:r>
+              <a:rPr lang="en-US" sz="3400" b="1" dirty="0">
+                <a:solidFill>
+                  <a:srgbClr val="34D399"/>
+                </a:solidFill>
+                <a:latin typeface="Cambria" pitchFamily="34" charset="0"/>
+                <a:ea typeface="Cambria" pitchFamily="34" charset="-122"/>
+                <a:cs typeface="Cambria" pitchFamily="34" charset="-120"/>
+              </a:rPr>
+              <a:t>71%</a:t>
+            </a:r>
+            <a:endParaRPr lang="en-US" sz="3400" dirty="0"/>
+          </a:p>
+        </p:txBody>
+      </p:sp>
+      <p:sp>
+        <p:nvSpPr>
+          <p:cNvPr id="15" name="Text 13"/>
+          <p:cNvSpPr txBox="1"/>
+          <p:nvPr/>
+        </p:nvSpPr>
+        <p:spPr>
+          <a:xfrm>
+            <a:off x="4389120" y="4773168"/>
+            <a:ext cx="3108960" cy="731520"/>
+          </a:xfrm>
+          <a:prstGeom prst="rect">
+            <a:avLst/>
+          </a:prstGeom>
+          <a:noFill/>
+          <a:ln/>
+        </p:spPr>
+        <p:txBody>
+          <a:bodyPr wrap="square" lIns="0" tIns="0" rIns="0" bIns="0" rtlCol="0" anchor="ctr"/>
           <a:lstStyle/>
           <a:p>
             <a:pPr indent="0" marL="0">
               <a:lnSpc>
-                <a:spcPct val="105000"/>
+                <a:spcPct val="100000"/>
               </a:lnSpc>
               <a:buNone/>
             </a:pPr>
             <a:r>
-              <a:rPr lang="en-US" sz="1250" b="1" dirty="0">
-                <a:solidFill>
-                  <a:srgbClr val="FFFFFF"/>
-                </a:solidFill>
-                <a:latin typeface="Calibri" pitchFamily="34" charset="0"/>
-                <a:ea typeface="Calibri" pitchFamily="34" charset="-122"/>
-                <a:cs typeface="Calibri" pitchFamily="34" charset="-120"/>
-              </a:rPr>
-              <a:t>Officials </a:t>
-            </a:r>
-            <a:pPr indent="0" marL="0">
-              <a:lnSpc>
-                <a:spcPct val="105000"/>
-              </a:lnSpc>
-              <a:buNone/>
-            </a:pPr>
-            <a:r>
               <a:rPr lang="en-US" sz="1250" dirty="0">
                 <a:solidFill>
                   <a:srgbClr val="C7D6EC"/>
@@ -10589,94 +11492,77 @@
                 <a:ea typeface="Calibri" pitchFamily="34" charset="-122"/>
                 <a:cs typeface="Calibri" pitchFamily="34" charset="-120"/>
               </a:rPr>
-              <a:t>rank wards by real vulnerability &amp; drivers to prioritise evacuation.</a:t>
+              <a:t>IoU vs. Sentinel-1 SAR flood ground-truth</a:t>
             </a:r>
             <a:endParaRPr lang="en-US" sz="1250" dirty="0"/>
           </a:p>
         </p:txBody>
       </p:sp>
-      <p:sp>
-        <p:nvSpPr>
-          <p:cNvPr id="11" name="Shape 8"/>
-          <p:cNvSpPr/>
-          <p:nvPr/>
-        </p:nvSpPr>
-        <p:spPr>
-          <a:xfrm>
-            <a:off x="6949440" y="4608576"/>
-            <a:ext cx="137160" cy="137160"/>
-          </a:xfrm>
-          <a:prstGeom prst="ellipse">
-            <a:avLst/>
-          </a:prstGeom>
-          <a:solidFill>
-            <a:srgbClr val="34D399"/>
-          </a:solidFill>
-          <a:ln/>
-        </p:spPr>
-      </p:sp>
-      <p:sp>
-        <p:nvSpPr>
-          <p:cNvPr id="12" name="Text 9"/>
-          <p:cNvSpPr txBox="1"/>
-          <p:nvPr/>
-        </p:nvSpPr>
-        <p:spPr>
-          <a:xfrm>
-            <a:off x="7178040" y="4489704"/>
-            <a:ext cx="4389120" cy="822960"/>
-          </a:xfrm>
-          <a:prstGeom prst="rect">
-            <a:avLst/>
-          </a:prstGeom>
-          <a:noFill/>
-          <a:ln/>
-        </p:spPr>
-        <p:txBody>
-          <a:bodyPr wrap="square" lIns="0" tIns="0" rIns="0" bIns="0" rtlCol="0" anchor="t"/>
-          <a:lstStyle/>
-          <a:p>
-            <a:pPr indent="0" marL="0">
-              <a:lnSpc>
-                <a:spcPct val="105000"/>
-              </a:lnSpc>
-              <a:buNone/>
-            </a:pPr>
-            <a:r>
-              <a:rPr lang="en-US" sz="1250" b="1" dirty="0">
-                <a:solidFill>
-                  <a:srgbClr val="FFFFFF"/>
-                </a:solidFill>
-                <a:latin typeface="Calibri" pitchFamily="34" charset="0"/>
-                <a:ea typeface="Calibri" pitchFamily="34" charset="-122"/>
-                <a:cs typeface="Calibri" pitchFamily="34" charset="-120"/>
-              </a:rPr>
-              <a:t>Citizens </a:t>
-            </a:r>
-            <a:pPr indent="0" marL="0">
-              <a:lnSpc>
-                <a:spcPct val="105000"/>
-              </a:lnSpc>
-              <a:buNone/>
-            </a:pPr>
-            <a:r>
-              <a:rPr lang="en-US" sz="1250" dirty="0">
-                <a:solidFill>
-                  <a:srgbClr val="C7D6EC"/>
-                </a:solidFill>
-                <a:latin typeface="Calibri" pitchFamily="34" charset="0"/>
-                <a:ea typeface="Calibri" pitchFamily="34" charset="-122"/>
-                <a:cs typeface="Calibri" pitchFamily="34" charset="-120"/>
-              </a:rPr>
-              <a:t>get clear, trilingual, offline-ready advisories for their exact ward.</a:t>
-            </a:r>
-            <a:endParaRPr lang="en-US" sz="1250" dirty="0"/>
-          </a:p>
-        </p:txBody>
-      </p:sp>
-      <p:sp>
-        <p:nvSpPr>
-          <p:cNvPr id="13" name="Text 10"/>
+      <p:pic>
+        <p:nvPicPr>
+          <p:cNvPr id="16" name="Image 0" descr="C:/Users/ABHISH~1.AGA/AppData/Local/Temp/claude/c--Users-abhishek-q-agarwal-Downloads-h2s/81d2d1cd-3a2c-4b7e-9761-45a2bd863e24/scratchpad/img/s_fani_puri.jpg">    </p:cNvPr>
+          <p:cNvPicPr>
+            <a:picLocks noChangeAspect="1"/>
+          </p:cNvPicPr>
+          <p:nvPr/>
+        </p:nvPicPr>
+        <p:blipFill>
+          <a:blip r:embed="rId1"/>
+          <a:srcRect l="0" r="0" t="0" b="0"/>
+          <a:stretch/>
+        </p:blipFill>
+        <p:spPr>
+          <a:xfrm>
+            <a:off x="8001000" y="1965960"/>
+            <a:ext cx="3730752" cy="3611880"/>
+          </a:xfrm>
+          <a:prstGeom prst="rect">
+            <a:avLst/>
+          </a:prstGeom>
+        </p:spPr>
+      </p:pic>
+      <p:sp>
+        <p:nvSpPr>
+          <p:cNvPr id="17" name="Text 14"/>
+          <p:cNvSpPr txBox="1"/>
+          <p:nvPr/>
+        </p:nvSpPr>
+        <p:spPr>
+          <a:xfrm>
+            <a:off x="8001000" y="5596128"/>
+            <a:ext cx="3730752" cy="256032"/>
+          </a:xfrm>
+          <a:prstGeom prst="rect">
+            <a:avLst/>
+          </a:prstGeom>
+          <a:noFill/>
+          <a:ln/>
+        </p:spPr>
+        <p:txBody>
+          <a:bodyPr wrap="square" lIns="0" tIns="0" rIns="0" bIns="0" rtlCol="0" anchor="ctr"/>
+          <a:lstStyle/>
+          <a:p>
+            <a:pPr algn="ctr" indent="0" marL="0">
+              <a:buNone/>
+            </a:pPr>
+            <a:r>
+              <a:rPr lang="en-US" sz="850" dirty="0">
+                <a:solidFill>
+                  <a:srgbClr val="E8EEF7"/>
+                </a:solidFill>
+                <a:latin typeface="Calibri" pitchFamily="34" charset="0"/>
+                <a:ea typeface="Calibri" pitchFamily="34" charset="-122"/>
+                <a:cs typeface="Calibri" pitchFamily="34" charset="-120"/>
+              </a:rPr>
+              <a:t>MODIS · Fani landfall, Puri · 3 May 2019 · NASA</a:t>
+            </a:r>
+            <a:endParaRPr lang="en-US" sz="850" dirty="0"/>
+          </a:p>
+        </p:txBody>
+      </p:sp>
+      <p:sp>
+        <p:nvSpPr>
+          <p:cNvPr id="18" name="Text 15"/>
           <p:cNvSpPr txBox="1"/>
           <p:nvPr/>
         </p:nvSpPr>
@@ -10707,7 +11593,7 @@
                 <a:ea typeface="Calibri" pitchFamily="34" charset="-122"/>
                 <a:cs typeface="Calibri" pitchFamily="34" charset="-120"/>
               </a:rPr>
-              <a:t>Fatality figures are widely reported orders of magnitude: ~10,000 (1999) vs 89 (Fani, 2019).</a:t>
+              <a:t>IMD best-track &amp; OSDMA reports; surge, ponding &amp; shelter status from the PRAHARI hazard pipeline; upgradable to live GEE layers.</a:t>
             </a:r>
             <a:endParaRPr lang="en-US" sz="850" dirty="0"/>
           </a:p>
@@ -10715,7 +11601,7 @@
       </p:sp>
       <p:sp>
         <p:nvSpPr>
-          <p:cNvPr id="14" name="Text 11"/>
+          <p:cNvPr id="19" name="Text 16"/>
           <p:cNvSpPr txBox="1"/>
           <p:nvPr/>
         </p:nvSpPr>
@@ -10768,7 +11654,7 @@
       </p:sp>
       <p:sp>
         <p:nvSpPr>
-          <p:cNvPr id="15" name="Text 12"/>
+          <p:cNvPr id="20" name="Text 17"/>
           <p:cNvSpPr txBox="1"/>
           <p:nvPr/>
         </p:nvSpPr>
@@ -10864,13 +11750,13 @@
             <a:r>
               <a:rPr lang="en-US" sz="1200" b="1" spc="300" kern="0" dirty="0">
                 <a:solidFill>
-                  <a:srgbClr val="38BDF8"/>
-                </a:solidFill>
-                <a:latin typeface="Calibri" pitchFamily="34" charset="0"/>
-                <a:ea typeface="Calibri" pitchFamily="34" charset="-122"/>
-                <a:cs typeface="Calibri" pitchFamily="34" charset="-120"/>
-              </a:rPr>
-              <a:t>ONE PLATFORM · TWO USERS</a:t>
+                  <a:srgbClr val="34D399"/>
+                </a:solidFill>
+                <a:latin typeface="Calibri" pitchFamily="34" charset="0"/>
+                <a:ea typeface="Calibri" pitchFamily="34" charset="-122"/>
+                <a:cs typeface="Calibri" pitchFamily="34" charset="-120"/>
+              </a:rPr>
+              <a:t>WHY IT MATTERS</a:t>
             </a:r>
             <a:endParaRPr lang="en-US" sz="1200" dirty="0"/>
           </a:p>
@@ -10912,30 +11798,46 @@
                 <a:ea typeface="Cambria" pitchFamily="34" charset="-122"/>
                 <a:cs typeface="Cambria" pitchFamily="34" charset="-120"/>
               </a:rPr>
-              <a:t>From a control room to a coastal village</a:t>
+              <a:t>Early warning saves lives — the frontier is assets</a:t>
             </a:r>
             <a:endParaRPr lang="en-US" sz="3400" dirty="0"/>
           </a:p>
         </p:txBody>
       </p:sp>
-      <p:sp>
-        <p:nvSpPr>
-          <p:cNvPr id="4" name="Shape 2"/>
+      <p:graphicFrame>
+        <p:nvGraphicFramePr>
+          <p:cNvPr id="4" name="Chart 0" descr=""/>
+          <p:cNvGraphicFramePr/>
+          <p:nvPr/>
+        </p:nvGraphicFramePr>
+        <p:xfrm>
+          <a:off x="457200" y="2011680"/>
+          <a:ext cx="5943600" cy="3657600"/>
+        </p:xfrm>
+        <a:graphic xmlns:a="http://schemas.openxmlformats.org/drawingml/2006/main">
+          <a:graphicData uri="http://schemas.openxmlformats.org/drawingml/2006/chart">
+            <c:chart xmlns:c="http://schemas.openxmlformats.org/drawingml/2006/chart" r:id="rId1"/>
+          </a:graphicData>
+        </a:graphic>
+      </p:graphicFrame>
+      <p:sp>
+        <p:nvSpPr>
+          <p:cNvPr id="5" name="Shape 2"/>
           <p:cNvSpPr/>
           <p:nvPr/>
         </p:nvSpPr>
         <p:spPr>
           <a:xfrm>
-            <a:off x="457200" y="1965960"/>
-            <a:ext cx="5532120" cy="3794760"/>
+            <a:off x="6675120" y="2011680"/>
+            <a:ext cx="5056632" cy="3657600"/>
           </a:xfrm>
           <a:prstGeom prst="roundRect">
             <a:avLst>
-              <a:gd name="adj" fmla="val 2892"/>
+              <a:gd name="adj" fmla="val 3000"/>
             </a:avLst>
           </a:prstGeom>
           <a:solidFill>
-            <a:srgbClr val="13294B"/>
+            <a:srgbClr val="0F2140"/>
           </a:solidFill>
           <a:ln w="12700">
             <a:solidFill>
@@ -10947,73 +11849,109 @@
       </p:sp>
       <p:sp>
         <p:nvSpPr>
-          <p:cNvPr id="5" name="Text 3"/>
-          <p:cNvSpPr txBox="1"/>
-          <p:nvPr/>
-        </p:nvSpPr>
-        <p:spPr>
-          <a:xfrm>
-            <a:off x="731520" y="2194560"/>
-            <a:ext cx="5029200" cy="457200"/>
-          </a:xfrm>
-          <a:prstGeom prst="rect">
-            <a:avLst/>
-          </a:prstGeom>
-          <a:noFill/>
-          <a:ln/>
-        </p:spPr>
-        <p:txBody>
-          <a:bodyPr wrap="square" lIns="0" tIns="0" rIns="0" bIns="0" rtlCol="0" anchor="ctr"/>
-          <a:lstStyle/>
-          <a:p>
-            <a:pPr indent="0" marL="0">
-              <a:buNone/>
-            </a:pPr>
-            <a:r>
-              <a:rPr lang="en-US" sz="1900" b="1" dirty="0">
-                <a:solidFill>
-                  <a:srgbClr val="38BDF8"/>
+          <p:cNvPr id="6" name="Text 3"/>
+          <p:cNvSpPr txBox="1"/>
+          <p:nvPr/>
+        </p:nvSpPr>
+        <p:spPr>
+          <a:xfrm>
+            <a:off x="6949440" y="2194560"/>
+            <a:ext cx="4572000" cy="365760"/>
+          </a:xfrm>
+          <a:prstGeom prst="rect">
+            <a:avLst/>
+          </a:prstGeom>
+          <a:noFill/>
+          <a:ln/>
+        </p:spPr>
+        <p:txBody>
+          <a:bodyPr wrap="square" lIns="0" tIns="0" rIns="0" bIns="0" rtlCol="0" anchor="ctr"/>
+          <a:lstStyle/>
+          <a:p>
+            <a:pPr indent="0" marL="0">
+              <a:buNone/>
+            </a:pPr>
+            <a:r>
+              <a:rPr lang="en-US" sz="1600" b="1" dirty="0">
+                <a:solidFill>
+                  <a:srgbClr val="FFFFFF"/>
                 </a:solidFill>
                 <a:latin typeface="Cambria" pitchFamily="34" charset="0"/>
                 <a:ea typeface="Cambria" pitchFamily="34" charset="-122"/>
                 <a:cs typeface="Cambria" pitchFamily="34" charset="-120"/>
               </a:rPr>
-              <a:t>🛰  Disaster-management officer</a:t>
-            </a:r>
-            <a:endParaRPr lang="en-US" sz="1900" dirty="0"/>
-          </a:p>
-        </p:txBody>
-      </p:sp>
-      <p:sp>
-        <p:nvSpPr>
-          <p:cNvPr id="6" name="Text 4"/>
-          <p:cNvSpPr txBox="1"/>
-          <p:nvPr/>
-        </p:nvSpPr>
-        <p:spPr>
-          <a:xfrm>
-            <a:off x="777240" y="2788920"/>
-            <a:ext cx="4937760" cy="2834640"/>
-          </a:xfrm>
-          <a:prstGeom prst="rect">
-            <a:avLst/>
-          </a:prstGeom>
-          <a:noFill/>
-          <a:ln/>
-        </p:spPr>
-        <p:txBody>
-          <a:bodyPr wrap="square" lIns="0" tIns="0" rIns="0" bIns="0" rtlCol="0" anchor="ctr"/>
-          <a:lstStyle/>
-          <a:p>
-            <a:pPr marL="177800" indent="-177800">
-              <a:spcAft>
-                <a:spcPts val="1200"/>
-              </a:spcAft>
-              <a:buSzPct val="100000"/>
-              <a:buChar char="•"/>
-            </a:pPr>
-            <a:r>
-              <a:rPr lang="en-US" sz="1350" dirty="0">
+              <a:t>Who benefits</a:t>
+            </a:r>
+            <a:endParaRPr lang="en-US" sz="1600" dirty="0"/>
+          </a:p>
+        </p:txBody>
+      </p:sp>
+      <p:sp>
+        <p:nvSpPr>
+          <p:cNvPr id="7" name="Shape 4"/>
+          <p:cNvSpPr/>
+          <p:nvPr/>
+        </p:nvSpPr>
+        <p:spPr>
+          <a:xfrm>
+            <a:off x="6949440" y="2743200"/>
+            <a:ext cx="137160" cy="137160"/>
+          </a:xfrm>
+          <a:prstGeom prst="ellipse">
+            <a:avLst/>
+          </a:prstGeom>
+          <a:solidFill>
+            <a:srgbClr val="38BDF8"/>
+          </a:solidFill>
+          <a:ln/>
+        </p:spPr>
+      </p:sp>
+      <p:sp>
+        <p:nvSpPr>
+          <p:cNvPr id="8" name="Text 5"/>
+          <p:cNvSpPr txBox="1"/>
+          <p:nvPr/>
+        </p:nvSpPr>
+        <p:spPr>
+          <a:xfrm>
+            <a:off x="7178040" y="2624328"/>
+            <a:ext cx="4389120" cy="822960"/>
+          </a:xfrm>
+          <a:prstGeom prst="rect">
+            <a:avLst/>
+          </a:prstGeom>
+          <a:noFill/>
+          <a:ln/>
+        </p:spPr>
+        <p:txBody>
+          <a:bodyPr wrap="square" lIns="0" tIns="0" rIns="0" bIns="0" rtlCol="0" anchor="t"/>
+          <a:lstStyle/>
+          <a:p>
+            <a:pPr indent="0" marL="0">
+              <a:lnSpc>
+                <a:spcPct val="105000"/>
+              </a:lnSpc>
+              <a:buNone/>
+            </a:pPr>
+            <a:r>
+              <a:rPr lang="en-US" sz="1250" b="1" dirty="0">
+                <a:solidFill>
+                  <a:srgbClr val="FFFFFF"/>
+                </a:solidFill>
+                <a:latin typeface="Calibri" pitchFamily="34" charset="0"/>
+                <a:ea typeface="Calibri" pitchFamily="34" charset="-122"/>
+                <a:cs typeface="Calibri" pitchFamily="34" charset="-120"/>
+              </a:rPr>
+              <a:t>Responders </a:t>
+            </a:r>
+            <a:pPr indent="0" marL="0">
+              <a:lnSpc>
+                <a:spcPct val="105000"/>
+              </a:lnSpc>
+              <a:buNone/>
+            </a:pPr>
+            <a:r>
+              <a:rPr lang="en-US" sz="1250" dirty="0">
                 <a:solidFill>
                   <a:srgbClr val="C7D6EC"/>
                 </a:solidFill>
@@ -11021,20 +11959,78 @@
                 <a:ea typeface="Calibri" pitchFamily="34" charset="-122"/>
                 <a:cs typeface="Calibri" pitchFamily="34" charset="-120"/>
               </a:rPr>
-              <a:t>Orbital view of the approaching storm</a:t>
-            </a:r>
-            <a:endParaRPr lang="en-US" sz="1350" dirty="0"/>
-          </a:p>
-          <a:p>
-            <a:pPr marL="177800" indent="-177800">
-              <a:spcAft>
-                <a:spcPts val="1200"/>
-              </a:spcAft>
-              <a:buSzPct val="100000"/>
-              <a:buChar char="•"/>
-            </a:pPr>
-            <a:r>
-              <a:rPr lang="en-US" sz="1350" dirty="0">
+              <a:t>see which shelters are reachable and which roads are severed — before deploying.</a:t>
+            </a:r>
+            <a:endParaRPr lang="en-US" sz="1250" dirty="0"/>
+          </a:p>
+        </p:txBody>
+      </p:sp>
+      <p:sp>
+        <p:nvSpPr>
+          <p:cNvPr id="9" name="Shape 6"/>
+          <p:cNvSpPr/>
+          <p:nvPr/>
+        </p:nvSpPr>
+        <p:spPr>
+          <a:xfrm>
+            <a:off x="6949440" y="3675888"/>
+            <a:ext cx="137160" cy="137160"/>
+          </a:xfrm>
+          <a:prstGeom prst="ellipse">
+            <a:avLst/>
+          </a:prstGeom>
+          <a:solidFill>
+            <a:srgbClr val="FBBF24"/>
+          </a:solidFill>
+          <a:ln/>
+        </p:spPr>
+      </p:sp>
+      <p:sp>
+        <p:nvSpPr>
+          <p:cNvPr id="10" name="Text 7"/>
+          <p:cNvSpPr txBox="1"/>
+          <p:nvPr/>
+        </p:nvSpPr>
+        <p:spPr>
+          <a:xfrm>
+            <a:off x="7178040" y="3557016"/>
+            <a:ext cx="4389120" cy="822960"/>
+          </a:xfrm>
+          <a:prstGeom prst="rect">
+            <a:avLst/>
+          </a:prstGeom>
+          <a:noFill/>
+          <a:ln/>
+        </p:spPr>
+        <p:txBody>
+          <a:bodyPr wrap="square" lIns="0" tIns="0" rIns="0" bIns="0" rtlCol="0" anchor="t"/>
+          <a:lstStyle/>
+          <a:p>
+            <a:pPr indent="0" marL="0">
+              <a:lnSpc>
+                <a:spcPct val="105000"/>
+              </a:lnSpc>
+              <a:buNone/>
+            </a:pPr>
+            <a:r>
+              <a:rPr lang="en-US" sz="1250" b="1" dirty="0">
+                <a:solidFill>
+                  <a:srgbClr val="FFFFFF"/>
+                </a:solidFill>
+                <a:latin typeface="Calibri" pitchFamily="34" charset="0"/>
+                <a:ea typeface="Calibri" pitchFamily="34" charset="-122"/>
+                <a:cs typeface="Calibri" pitchFamily="34" charset="-120"/>
+              </a:rPr>
+              <a:t>Officials </a:t>
+            </a:r>
+            <a:pPr indent="0" marL="0">
+              <a:lnSpc>
+                <a:spcPct val="105000"/>
+              </a:lnSpc>
+              <a:buNone/>
+            </a:pPr>
+            <a:r>
+              <a:rPr lang="en-US" sz="1250" dirty="0">
                 <a:solidFill>
                   <a:srgbClr val="C7D6EC"/>
                 </a:solidFill>
@@ -11042,20 +12038,78 @@
                 <a:ea typeface="Calibri" pitchFamily="34" charset="-122"/>
                 <a:cs typeface="Calibri" pitchFamily="34" charset="-120"/>
               </a:rPr>
-              <a:t>Scrub the best-track to anticipate landfall</a:t>
-            </a:r>
-            <a:endParaRPr lang="en-US" sz="1350" dirty="0"/>
-          </a:p>
-          <a:p>
-            <a:pPr marL="177800" indent="-177800">
-              <a:spcAft>
-                <a:spcPts val="1200"/>
-              </a:spcAft>
-              <a:buSzPct val="100000"/>
-              <a:buChar char="•"/>
-            </a:pPr>
-            <a:r>
-              <a:rPr lang="en-US" sz="1350" dirty="0">
+              <a:t>rank wards by real vulnerability &amp; drivers to prioritise evacuation.</a:t>
+            </a:r>
+            <a:endParaRPr lang="en-US" sz="1250" dirty="0"/>
+          </a:p>
+        </p:txBody>
+      </p:sp>
+      <p:sp>
+        <p:nvSpPr>
+          <p:cNvPr id="11" name="Shape 8"/>
+          <p:cNvSpPr/>
+          <p:nvPr/>
+        </p:nvSpPr>
+        <p:spPr>
+          <a:xfrm>
+            <a:off x="6949440" y="4608576"/>
+            <a:ext cx="137160" cy="137160"/>
+          </a:xfrm>
+          <a:prstGeom prst="ellipse">
+            <a:avLst/>
+          </a:prstGeom>
+          <a:solidFill>
+            <a:srgbClr val="34D399"/>
+          </a:solidFill>
+          <a:ln/>
+        </p:spPr>
+      </p:sp>
+      <p:sp>
+        <p:nvSpPr>
+          <p:cNvPr id="12" name="Text 9"/>
+          <p:cNvSpPr txBox="1"/>
+          <p:nvPr/>
+        </p:nvSpPr>
+        <p:spPr>
+          <a:xfrm>
+            <a:off x="7178040" y="4489704"/>
+            <a:ext cx="4389120" cy="822960"/>
+          </a:xfrm>
+          <a:prstGeom prst="rect">
+            <a:avLst/>
+          </a:prstGeom>
+          <a:noFill/>
+          <a:ln/>
+        </p:spPr>
+        <p:txBody>
+          <a:bodyPr wrap="square" lIns="0" tIns="0" rIns="0" bIns="0" rtlCol="0" anchor="t"/>
+          <a:lstStyle/>
+          <a:p>
+            <a:pPr indent="0" marL="0">
+              <a:lnSpc>
+                <a:spcPct val="105000"/>
+              </a:lnSpc>
+              <a:buNone/>
+            </a:pPr>
+            <a:r>
+              <a:rPr lang="en-US" sz="1250" b="1" dirty="0">
+                <a:solidFill>
+                  <a:srgbClr val="FFFFFF"/>
+                </a:solidFill>
+                <a:latin typeface="Calibri" pitchFamily="34" charset="0"/>
+                <a:ea typeface="Calibri" pitchFamily="34" charset="-122"/>
+                <a:cs typeface="Calibri" pitchFamily="34" charset="-120"/>
+              </a:rPr>
+              <a:t>Citizens </a:t>
+            </a:r>
+            <a:pPr indent="0" marL="0">
+              <a:lnSpc>
+                <a:spcPct val="105000"/>
+              </a:lnSpc>
+              <a:buNone/>
+            </a:pPr>
+            <a:r>
+              <a:rPr lang="en-US" sz="1250" dirty="0">
                 <a:solidFill>
                   <a:srgbClr val="C7D6EC"/>
                 </a:solidFill>
@@ -11063,239 +12117,7 @@
                 <a:ea typeface="Calibri" pitchFamily="34" charset="-122"/>
                 <a:cs typeface="Calibri" pitchFamily="34" charset="-120"/>
               </a:rPr>
-              <a:t>Rank wards; inspect shelters &amp; severed roads</a:t>
-            </a:r>
-            <a:endParaRPr lang="en-US" sz="1350" dirty="0"/>
-          </a:p>
-          <a:p>
-            <a:pPr marL="177800" indent="-177800">
-              <a:spcAft>
-                <a:spcPts val="1200"/>
-              </a:spcAft>
-              <a:buSzPct val="100000"/>
-              <a:buChar char="•"/>
-            </a:pPr>
-            <a:r>
-              <a:rPr lang="en-US" sz="1350" dirty="0">
-                <a:solidFill>
-                  <a:srgbClr val="C7D6EC"/>
-                </a:solidFill>
-                <a:latin typeface="Calibri" pitchFamily="34" charset="0"/>
-                <a:ea typeface="Calibri" pitchFamily="34" charset="-122"/>
-                <a:cs typeface="Calibri" pitchFamily="34" charset="-120"/>
-              </a:rPr>
-              <a:t>Ask the AI advisor — in English</a:t>
-            </a:r>
-            <a:endParaRPr lang="en-US" sz="1350" dirty="0"/>
-          </a:p>
-        </p:txBody>
-      </p:sp>
-      <p:sp>
-        <p:nvSpPr>
-          <p:cNvPr id="7" name="Shape 5"/>
-          <p:cNvSpPr/>
-          <p:nvPr/>
-        </p:nvSpPr>
-        <p:spPr>
-          <a:xfrm>
-            <a:off x="6199632" y="1965960"/>
-            <a:ext cx="5532120" cy="3794760"/>
-          </a:xfrm>
-          <a:prstGeom prst="roundRect">
-            <a:avLst>
-              <a:gd name="adj" fmla="val 2892"/>
-            </a:avLst>
-          </a:prstGeom>
-          <a:solidFill>
-            <a:srgbClr val="13294B"/>
-          </a:solidFill>
-          <a:ln w="12700">
-            <a:solidFill>
-              <a:srgbClr val="27466F"/>
-            </a:solidFill>
-            <a:prstDash val="solid"/>
-          </a:ln>
-        </p:spPr>
-      </p:sp>
-      <p:sp>
-        <p:nvSpPr>
-          <p:cNvPr id="8" name="Text 6"/>
-          <p:cNvSpPr txBox="1"/>
-          <p:nvPr/>
-        </p:nvSpPr>
-        <p:spPr>
-          <a:xfrm>
-            <a:off x="6473952" y="2194560"/>
-            <a:ext cx="5029200" cy="457200"/>
-          </a:xfrm>
-          <a:prstGeom prst="rect">
-            <a:avLst/>
-          </a:prstGeom>
-          <a:noFill/>
-          <a:ln/>
-        </p:spPr>
-        <p:txBody>
-          <a:bodyPr wrap="square" lIns="0" tIns="0" rIns="0" bIns="0" rtlCol="0" anchor="ctr"/>
-          <a:lstStyle/>
-          <a:p>
-            <a:pPr indent="0" marL="0">
-              <a:buNone/>
-            </a:pPr>
-            <a:r>
-              <a:rPr lang="en-US" sz="1900" b="1" dirty="0">
-                <a:solidFill>
-                  <a:srgbClr val="34D399"/>
-                </a:solidFill>
-                <a:latin typeface="Cambria" pitchFamily="34" charset="0"/>
-                <a:ea typeface="Cambria" pitchFamily="34" charset="-122"/>
-                <a:cs typeface="Cambria" pitchFamily="34" charset="-120"/>
-              </a:rPr>
-              <a:t>🌾  Farmer / citizen</a:t>
-            </a:r>
-            <a:endParaRPr lang="en-US" sz="1900" dirty="0"/>
-          </a:p>
-        </p:txBody>
-      </p:sp>
-      <p:sp>
-        <p:nvSpPr>
-          <p:cNvPr id="9" name="Text 7"/>
-          <p:cNvSpPr txBox="1"/>
-          <p:nvPr/>
-        </p:nvSpPr>
-        <p:spPr>
-          <a:xfrm>
-            <a:off x="6519672" y="2788920"/>
-            <a:ext cx="4937760" cy="2834640"/>
-          </a:xfrm>
-          <a:prstGeom prst="rect">
-            <a:avLst/>
-          </a:prstGeom>
-          <a:noFill/>
-          <a:ln/>
-        </p:spPr>
-        <p:txBody>
-          <a:bodyPr wrap="square" lIns="0" tIns="0" rIns="0" bIns="0" rtlCol="0" anchor="ctr"/>
-          <a:lstStyle/>
-          <a:p>
-            <a:pPr marL="177800" indent="-177800">
-              <a:spcAft>
-                <a:spcPts val="1200"/>
-              </a:spcAft>
-              <a:buSzPct val="100000"/>
-              <a:buChar char="•"/>
-            </a:pPr>
-            <a:r>
-              <a:rPr lang="en-US" sz="1350" dirty="0">
-                <a:solidFill>
-                  <a:srgbClr val="C7D6EC"/>
-                </a:solidFill>
-                <a:latin typeface="Calibri" pitchFamily="34" charset="0"/>
-                <a:ea typeface="Calibri" pitchFamily="34" charset="-122"/>
-                <a:cs typeface="Calibri" pitchFamily="34" charset="-120"/>
-              </a:rPr>
-              <a:t>Today’s weather for their town — in Odia</a:t>
-            </a:r>
-            <a:endParaRPr lang="en-US" sz="1350" dirty="0"/>
-          </a:p>
-          <a:p>
-            <a:pPr marL="177800" indent="-177800">
-              <a:spcAft>
-                <a:spcPts val="1200"/>
-              </a:spcAft>
-              <a:buSzPct val="100000"/>
-              <a:buChar char="•"/>
-            </a:pPr>
-            <a:r>
-              <a:rPr lang="en-US" sz="1350" dirty="0">
-                <a:solidFill>
-                  <a:srgbClr val="C7D6EC"/>
-                </a:solidFill>
-                <a:latin typeface="Calibri" pitchFamily="34" charset="0"/>
-                <a:ea typeface="Calibri" pitchFamily="34" charset="-122"/>
-                <a:cs typeface="Calibri" pitchFamily="34" charset="-120"/>
-              </a:rPr>
-              <a:t>One tap shows the cyclone bearing down</a:t>
-            </a:r>
-            <a:endParaRPr lang="en-US" sz="1350" dirty="0"/>
-          </a:p>
-          <a:p>
-            <a:pPr marL="177800" indent="-177800">
-              <a:spcAft>
-                <a:spcPts val="1200"/>
-              </a:spcAft>
-              <a:buSzPct val="100000"/>
-              <a:buChar char="•"/>
-            </a:pPr>
-            <a:r>
-              <a:rPr lang="en-US" sz="1350" dirty="0">
-                <a:solidFill>
-                  <a:srgbClr val="C7D6EC"/>
-                </a:solidFill>
-                <a:latin typeface="Calibri" pitchFamily="34" charset="0"/>
-                <a:ea typeface="Calibri" pitchFamily="34" charset="-122"/>
-                <a:cs typeface="Calibri" pitchFamily="34" charset="-120"/>
-              </a:rPr>
-              <a:t>Nearest shelter and the safe route</a:t>
-            </a:r>
-            <a:endParaRPr lang="en-US" sz="1350" dirty="0"/>
-          </a:p>
-          <a:p>
-            <a:pPr marL="177800" indent="-177800">
-              <a:spcAft>
-                <a:spcPts val="1200"/>
-              </a:spcAft>
-              <a:buSzPct val="100000"/>
-              <a:buChar char="•"/>
-            </a:pPr>
-            <a:r>
-              <a:rPr lang="en-US" sz="1350" dirty="0">
-                <a:solidFill>
-                  <a:srgbClr val="C7D6EC"/>
-                </a:solidFill>
-                <a:latin typeface="Calibri" pitchFamily="34" charset="0"/>
-                <a:ea typeface="Calibri" pitchFamily="34" charset="-122"/>
-                <a:cs typeface="Calibri" pitchFamily="34" charset="-120"/>
-              </a:rPr>
-              <a:t>Official advisory + AI answers, in Odia</a:t>
-            </a:r>
-            <a:endParaRPr lang="en-US" sz="1350" dirty="0"/>
-          </a:p>
-        </p:txBody>
-      </p:sp>
-      <p:sp>
-        <p:nvSpPr>
-          <p:cNvPr id="10" name="Text 8"/>
-          <p:cNvSpPr txBox="1"/>
-          <p:nvPr/>
-        </p:nvSpPr>
-        <p:spPr>
-          <a:xfrm>
-            <a:off x="457200" y="5943600"/>
-            <a:ext cx="11247120" cy="365760"/>
-          </a:xfrm>
-          <a:prstGeom prst="rect">
-            <a:avLst/>
-          </a:prstGeom>
-          <a:noFill/>
-          <a:ln/>
-        </p:spPr>
-        <p:txBody>
-          <a:bodyPr wrap="square" lIns="0" tIns="0" rIns="0" bIns="0" rtlCol="0" anchor="ctr"/>
-          <a:lstStyle/>
-          <a:p>
-            <a:pPr algn="ctr" indent="0" marL="0">
-              <a:buNone/>
-            </a:pPr>
-            <a:r>
-              <a:rPr lang="en-US" sz="1250" i="1" dirty="0">
-                <a:solidFill>
-                  <a:srgbClr val="93A5C0"/>
-                </a:solidFill>
-                <a:latin typeface="Calibri" pitchFamily="34" charset="0"/>
-                <a:ea typeface="Calibri" pitchFamily="34" charset="-122"/>
-                <a:cs typeface="Calibri" pitchFamily="34" charset="-120"/>
-              </a:rPr>
-              <a:t>Same fused hazard-and-exposure data — served to the responder who plans, and the citizen who acts.</a:t>
+              <a:t>get clear, trilingual, offline-ready advisories for their exact ward.</a:t>
             </a:r>
             <a:endParaRPr lang="en-US" sz="1250" dirty="0"/>
           </a:p>
@@ -11303,7 +12125,46 @@
       </p:sp>
       <p:sp>
         <p:nvSpPr>
-          <p:cNvPr id="11" name="Text 9"/>
+          <p:cNvPr id="13" name="Text 10"/>
+          <p:cNvSpPr txBox="1"/>
+          <p:nvPr/>
+        </p:nvSpPr>
+        <p:spPr>
+          <a:xfrm>
+            <a:off x="457200" y="6163056"/>
+            <a:ext cx="11247120" cy="256032"/>
+          </a:xfrm>
+          <a:prstGeom prst="rect">
+            <a:avLst/>
+          </a:prstGeom>
+          <a:noFill/>
+          <a:ln/>
+        </p:spPr>
+        <p:txBody>
+          <a:bodyPr wrap="square" lIns="0" tIns="0" rIns="0" bIns="0" rtlCol="0" anchor="ctr"/>
+          <a:lstStyle/>
+          <a:p>
+            <a:pPr algn="l" indent="0" marL="0">
+              <a:buNone/>
+            </a:pPr>
+            <a:r>
+              <a:rPr lang="en-US" sz="850" i="1" dirty="0">
+                <a:solidFill>
+                  <a:srgbClr val="6B7F9E"/>
+                </a:solidFill>
+                <a:latin typeface="Calibri" pitchFamily="34" charset="0"/>
+                <a:ea typeface="Calibri" pitchFamily="34" charset="-122"/>
+                <a:cs typeface="Calibri" pitchFamily="34" charset="-120"/>
+              </a:rPr>
+              <a:t>Fatality figures are widely reported orders of magnitude: ~10,000 (1999) vs 89 (Fani, 2019).</a:t>
+            </a:r>
+            <a:endParaRPr lang="en-US" sz="850" dirty="0"/>
+          </a:p>
+        </p:txBody>
+      </p:sp>
+      <p:sp>
+        <p:nvSpPr>
+          <p:cNvPr id="14" name="Text 11"/>
           <p:cNvSpPr txBox="1"/>
           <p:nvPr/>
         </p:nvSpPr>
@@ -11356,7 +12217,7 @@
       </p:sp>
       <p:sp>
         <p:nvSpPr>
-          <p:cNvPr id="12" name="Text 10"/>
+          <p:cNvPr id="15" name="Text 12"/>
           <p:cNvSpPr txBox="1"/>
           <p:nvPr/>
         </p:nvSpPr>

</xml_diff>

<commit_message>
Replace em-dashes with commas in deck text for cleaner reading
Kept required hyphens in compound terms (sub-meter, Sentinel-1, Open-Meteo, etc.).

Co-Authored-By: Claude Opus 4.8 (1M context) <noreply@anthropic.com>
</commit_message>
<xml_diff>
--- a/demo/PRAHARI_Orbital_Console.pptx
+++ b/demo/PRAHARI_Orbital_Console.pptx
@@ -2467,7 +2467,7 @@
                 <a:ea typeface="Calibri" pitchFamily="34" charset="-122"/>
                 <a:cs typeface="Calibri" pitchFamily="34" charset="-120"/>
               </a:rPr>
-              <a:t>Turning satellite data into anticipatory action — from an orbital 3D globe to sub-meter streets, with a live Gemini AI advisor and Google Earth Engine hazard layers.</a:t>
+              <a:t>Turning satellite data into anticipatory action, from an orbital 3D globe to sub-meter streets, with a live Gemini AI advisor and Google Earth Engine hazard layers.</a:t>
             </a:r>
             <a:endParaRPr lang="en-US" sz="1600" dirty="0"/>
           </a:p>
@@ -2844,7 +2844,7 @@
                 <a:ea typeface="Calibri" pitchFamily="34" charset="-122"/>
                 <a:cs typeface="Calibri" pitchFamily="34" charset="-120"/>
               </a:rPr>
-              <a:t>Ask the AI advisor — in English</a:t>
+              <a:t>Ask the AI advisor, in English</a:t>
             </a:r>
             <a:endParaRPr lang="en-US" sz="1350" dirty="0"/>
           </a:p>
@@ -2953,7 +2953,7 @@
                 <a:ea typeface="Calibri" pitchFamily="34" charset="-122"/>
                 <a:cs typeface="Calibri" pitchFamily="34" charset="-120"/>
               </a:rPr>
-              <a:t>Today’s weather for their town — in Odia</a:t>
+              <a:t>Today’s weather for their town, in Odia</a:t>
             </a:r>
             <a:endParaRPr lang="en-US" sz="1350" dirty="0"/>
           </a:p>
@@ -3055,7 +3055,7 @@
                 <a:ea typeface="Calibri" pitchFamily="34" charset="-122"/>
                 <a:cs typeface="Calibri" pitchFamily="34" charset="-120"/>
               </a:rPr>
-              <a:t>Same fused hazard-and-exposure data — served to the responder who plans, and the citizen who acts.</a:t>
+              <a:t>Same fused hazard-and-exposure data, served to the responder who plans, and the citizen who acts.</a:t>
             </a:r>
             <a:endParaRPr lang="en-US" sz="1250" dirty="0"/>
           </a:p>
@@ -4273,7 +4273,7 @@
                 <a:ea typeface="Calibri" pitchFamily="34" charset="-122"/>
                 <a:cs typeface="Calibri" pitchFamily="34" charset="-120"/>
               </a:rPr>
-              <a:t>Onboard new districts by pointing the pipeline at fresh AOIs — Andhra, West Bengal, Tamil Nadu.</a:t>
+              <a:t>Onboard new districts by pointing the pipeline at fresh AOIs, Andhra, West Bengal, Tamil Nadu.</a:t>
             </a:r>
             <a:endParaRPr lang="en-US" sz="1250" dirty="0"/>
           </a:p>
@@ -5530,7 +5530,7 @@
                 <a:ea typeface="Calibri" pitchFamily="34" charset="-122"/>
                 <a:cs typeface="Calibri" pitchFamily="34" charset="-120"/>
               </a:rPr>
-              <a:t>Cyclone Fani, VIIRS / MODIS true-color, 3 May 2019 — NASA Worldview (public domain).</a:t>
+              <a:t>Cyclone Fani, VIIRS / MODIS true-color, 3 May 2019, NASA Worldview (public domain).</a:t>
             </a:r>
             <a:endParaRPr lang="en-US" sz="1150" dirty="0"/>
           </a:p>
@@ -6327,7 +6327,7 @@
                 <a:ea typeface="Calibri" pitchFamily="34" charset="-122"/>
                 <a:cs typeface="Calibri" pitchFamily="34" charset="-120"/>
               </a:rPr>
-              <a:t>Static basemaps stop at district level — you can’t see which road, shelter or rooftop actually floods.</a:t>
+              <a:t>Static basemaps stop at district level, you can’t see which road, shelter or rooftop actually floods.</a:t>
             </a:r>
             <a:endParaRPr lang="en-US" sz="1150" dirty="0"/>
           </a:p>
@@ -6800,7 +6800,7 @@
                 <a:ea typeface="Calibri" pitchFamily="34" charset="-122"/>
                 <a:cs typeface="Calibri" pitchFamily="34" charset="-120"/>
               </a:rPr>
-              <a:t>Seamless zoom from a 3D Earth in orbit to sub-meter street tiles — no blurriness, no context lost.</a:t>
+              <a:t>Seamless zoom from a 3D Earth in orbit to sub-meter street tiles, no blurriness, no context lost.</a:t>
             </a:r>
             <a:endParaRPr lang="en-US" sz="1250" dirty="0"/>
           </a:p>
@@ -7056,7 +7056,7 @@
                 <a:ea typeface="Calibri" pitchFamily="34" charset="-122"/>
                 <a:cs typeface="Calibri" pitchFamily="34" charset="-120"/>
               </a:rPr>
-              <a:t>Ask in plain language; get grounded, action-oriented answers and trilingual advisories — never invented numbers.</a:t>
+              <a:t>Ask in plain language; get grounded, action-oriented answers and trilingual advisories, never invented numbers.</a:t>
             </a:r>
             <a:endParaRPr lang="en-US" sz="1250" dirty="0"/>
           </a:p>
@@ -7428,7 +7428,7 @@
                 <a:ea typeface="Cambria" pitchFamily="34" charset="-122"/>
                 <a:cs typeface="Cambria" pitchFamily="34" charset="-120"/>
               </a:rPr>
-              <a:t>PRAHARI in action — orbit to rooftop</a:t>
+              <a:t>PRAHARI in action, orbit to rooftop</a:t>
             </a:r>
             <a:endParaRPr lang="en-US" sz="3400" dirty="0"/>
           </a:p>
@@ -7552,7 +7552,7 @@
         <p:spPr>
           <a:xfrm>
             <a:off x="6400800" y="3602736"/>
-            <a:ext cx="3010205" cy="310896"/>
+            <a:ext cx="2929738" cy="310896"/>
           </a:xfrm>
           <a:prstGeom prst="roundRect">
             <a:avLst>
@@ -7576,7 +7576,7 @@
         <p:spPr>
           <a:xfrm>
             <a:off x="6510528" y="3602736"/>
-            <a:ext cx="2735885" cy="310896"/>
+            <a:ext cx="2655418" cy="310896"/>
           </a:xfrm>
           <a:prstGeom prst="rect">
             <a:avLst/>
@@ -7600,7 +7600,7 @@
                 <a:ea typeface="Calibri" pitchFamily="34" charset="-122"/>
                 <a:cs typeface="Calibri" pitchFamily="34" charset="-120"/>
               </a:rPr>
-              <a:t>District view — wards by real risk</a:t>
+              <a:t>District view, wards by real risk</a:t>
             </a:r>
             <a:endParaRPr lang="en-US" sz="1100" dirty="0"/>
           </a:p>
@@ -7638,7 +7638,7 @@
         <p:spPr>
           <a:xfrm>
             <a:off x="566928" y="6071616"/>
-            <a:ext cx="3171139" cy="310896"/>
+            <a:ext cx="3090672" cy="310896"/>
           </a:xfrm>
           <a:prstGeom prst="roundRect">
             <a:avLst>
@@ -7662,7 +7662,7 @@
         <p:spPr>
           <a:xfrm>
             <a:off x="676656" y="6071616"/>
-            <a:ext cx="2896819" cy="310896"/>
+            <a:ext cx="2816352" cy="310896"/>
           </a:xfrm>
           <a:prstGeom prst="rect">
             <a:avLst/>
@@ -7686,7 +7686,7 @@
                 <a:ea typeface="Calibri" pitchFamily="34" charset="-122"/>
                 <a:cs typeface="Calibri" pitchFamily="34" charset="-120"/>
               </a:rPr>
-              <a:t>Sub-meter street — shelters &amp; routes</a:t>
+              <a:t>Sub-meter street, shelters &amp; routes</a:t>
             </a:r>
             <a:endParaRPr lang="en-US" sz="1100" dirty="0"/>
           </a:p>
@@ -7724,7 +7724,7 @@
         <p:spPr>
           <a:xfrm>
             <a:off x="6400800" y="6071616"/>
-            <a:ext cx="3010205" cy="310896"/>
+            <a:ext cx="2929738" cy="310896"/>
           </a:xfrm>
           <a:prstGeom prst="roundRect">
             <a:avLst>
@@ -7748,7 +7748,7 @@
         <p:spPr>
           <a:xfrm>
             <a:off x="6510528" y="6071616"/>
-            <a:ext cx="2735885" cy="310896"/>
+            <a:ext cx="2655418" cy="310896"/>
           </a:xfrm>
           <a:prstGeom prst="rect">
             <a:avLst/>
@@ -7772,7 +7772,7 @@
                 <a:ea typeface="Calibri" pitchFamily="34" charset="-122"/>
                 <a:cs typeface="Calibri" pitchFamily="34" charset="-120"/>
               </a:rPr>
-              <a:t>Gemini AI advisor — grounded, live</a:t>
+              <a:t>Gemini AI advisor, grounded, live</a:t>
             </a:r>
             <a:endParaRPr lang="en-US" sz="1100" dirty="0"/>
           </a:p>
@@ -8127,7 +8127,7 @@
                 <a:ea typeface="Calibri" pitchFamily="34" charset="-122"/>
                 <a:cs typeface="Calibri" pitchFamily="34" charset="-120"/>
               </a:rPr>
-              <a:t>Live Sentinel-1 SAR flood + Copernicus DEM surge overlays — genuine satellite analysis, not decorative imagery.</a:t>
+              <a:t>Live Sentinel-1 SAR flood + Copernicus DEM surge overlays, genuine satellite analysis, not decorative imagery.</a:t>
             </a:r>
             <a:endParaRPr lang="en-US" sz="1100" dirty="0"/>
           </a:p>
@@ -8277,7 +8277,7 @@
                 <a:ea typeface="Calibri" pitchFamily="34" charset="-122"/>
                 <a:cs typeface="Calibri" pitchFamily="34" charset="-120"/>
               </a:rPr>
-              <a:t>Gemini reads the live on-screen data and answers only from it — cites real ward IDs, scores and shelter status.</a:t>
+              <a:t>Gemini reads the live on-screen data and answers only from it, cites real ward IDs, scores and shelter status.</a:t>
             </a:r>
             <a:endParaRPr lang="en-US" sz="1100" dirty="0"/>
           </a:p>
@@ -8427,7 +8427,7 @@
                 <a:ea typeface="Calibri" pitchFamily="34" charset="-122"/>
                 <a:cs typeface="Calibri" pitchFamily="34" charset="-120"/>
               </a:rPr>
-              <a:t>One continuous view from a 3D globe down to individual rooftops — competitors pick a single scale.</a:t>
+              <a:t>One continuous view from a 3D globe down to individual rooftops, competitors pick a single scale.</a:t>
             </a:r>
             <a:endParaRPr lang="en-US" sz="1100" dirty="0"/>
           </a:p>
@@ -8727,7 +8727,7 @@
                 <a:ea typeface="Calibri" pitchFamily="34" charset="-122"/>
                 <a:cs typeface="Calibri" pitchFamily="34" charset="-120"/>
               </a:rPr>
-              <a:t>An officer works in English; a farmer gets the same intelligence in Odia — both from one data asset.</a:t>
+              <a:t>An officer works in English; a farmer gets the same intelligence in Odia, both from one data asset.</a:t>
             </a:r>
             <a:endParaRPr lang="en-US" sz="1100" dirty="0"/>
           </a:p>
@@ -8877,7 +8877,7 @@
                 <a:ea typeface="Calibri" pitchFamily="34" charset="-122"/>
                 <a:cs typeface="Calibri" pitchFamily="34" charset="-120"/>
               </a:rPr>
-              <a:t>Pure static site — deploys to any CDN or a field laptop, with offline-ready SMS advisories.</a:t>
+              <a:t>Pure static site, deploys to any CDN or a field laptop, with offline-ready SMS advisories.</a:t>
             </a:r>
             <a:endParaRPr lang="en-US" sz="1100" dirty="0"/>
           </a:p>
@@ -9082,7 +9082,7 @@
                 <a:ea typeface="Cambria" pitchFamily="34" charset="-122"/>
                 <a:cs typeface="Cambria" pitchFamily="34" charset="-120"/>
               </a:rPr>
-              <a:t>What the platform does — and the real data behind each</a:t>
+              <a:t>What the platform does, and the real data behind each</a:t>
             </a:r>
             <a:endParaRPr lang="en-US" sz="3400" dirty="0"/>
           </a:p>
@@ -9225,7 +9225,7 @@
                 <a:ea typeface="Calibri" pitchFamily="34" charset="-122"/>
                 <a:cs typeface="Calibri" pitchFamily="34" charset="-120"/>
               </a:rPr>
-              <a:t>Live Google Earth Engine overlay — Sentinel-1 SAR flood extent, Copernicus DEM surge exposure, WorldPop population.</a:t>
+              <a:t>Live Google Earth Engine overlay, Sentinel-1 SAR flood extent, Copernicus DEM surge exposure, WorldPop population.</a:t>
             </a:r>
             <a:endParaRPr lang="en-US" sz="1200" dirty="0"/>
           </a:p>
@@ -9511,7 +9511,7 @@
                 <a:ea typeface="Calibri" pitchFamily="34" charset="-122"/>
                 <a:cs typeface="Calibri" pitchFamily="34" charset="-120"/>
               </a:rPr>
-              <a:t>Gemini Flash — grounded on live data, streaming, drafts trilingual advisories; never invents numbers.</a:t>
+              <a:t>Gemini Flash, grounded on live data, streaming, drafts trilingual advisories; never invents numbers.</a:t>
             </a:r>
             <a:endParaRPr lang="en-US" sz="1200" dirty="0"/>
           </a:p>
@@ -9654,7 +9654,7 @@
                 <a:ea typeface="Calibri" pitchFamily="34" charset="-122"/>
                 <a:cs typeface="Calibri" pitchFamily="34" charset="-120"/>
               </a:rPr>
-              <a:t>Holland parametric surge model — 3.8 m peak-surge inundation zones, SAR-verified at 71% IoU.</a:t>
+              <a:t>Holland parametric surge model, 3.8 m peak-surge inundation zones, SAR-verified at 71% IoU.</a:t>
             </a:r>
             <a:endParaRPr lang="en-US" sz="1200" dirty="0"/>
           </a:p>
@@ -9940,7 +9940,7 @@
                 <a:ea typeface="Calibri" pitchFamily="34" charset="-122"/>
                 <a:cs typeface="Calibri" pitchFamily="34" charset="-120"/>
               </a:rPr>
-              <a:t>Cyclone shelters, power substations and arterial roads / evacuation corridors — each with live surge-impact status.</a:t>
+              <a:t>Cyclone shelters, power substations and arterial roads / evacuation corridors, each with live surge-impact status.</a:t>
             </a:r>
             <a:endParaRPr lang="en-US" sz="1200" dirty="0"/>
           </a:p>
@@ -10288,7 +10288,7 @@
                 <a:ea typeface="Cambria" pitchFamily="34" charset="-122"/>
                 <a:cs typeface="Cambria" pitchFamily="34" charset="-120"/>
               </a:rPr>
-              <a:t>Ask your data — Gemini answers, grounded</a:t>
+              <a:t>Ask your data, Gemini answers, grounded</a:t>
             </a:r>
             <a:endParaRPr lang="en-US" sz="3400" dirty="0"/>
           </a:p>
@@ -10389,7 +10389,7 @@
                 <a:ea typeface="Calibri" pitchFamily="34" charset="-122"/>
                 <a:cs typeface="Calibri" pitchFamily="34" charset="-120"/>
               </a:rPr>
-              <a:t>Client-side — no backend, no server round-trip. Your API key stays in your browser.</a:t>
+              <a:t>Client-side, no backend, no server round-trip. Your API key stays in your browser.</a:t>
             </a:r>
             <a:endParaRPr lang="en-US" sz="1200" dirty="0"/>
           </a:p>
@@ -10490,7 +10490,7 @@
                 <a:ea typeface="Calibri" pitchFamily="34" charset="-122"/>
                 <a:cs typeface="Calibri" pitchFamily="34" charset="-120"/>
               </a:rPr>
-              <a:t>Reads the wards, surge depths, shelters and routes on screen — and answers only from them.</a:t>
+              <a:t>Reads the wards, surge depths, shelters and routes on screen, and answers only from them.</a:t>
             </a:r>
             <a:endParaRPr lang="en-US" sz="1200" dirty="0"/>
           </a:p>
@@ -10692,7 +10692,7 @@
                 <a:ea typeface="Calibri" pitchFamily="34" charset="-122"/>
                 <a:cs typeface="Calibri" pitchFamily="34" charset="-120"/>
               </a:rPr>
-              <a:t>Minimal-thinking responses stream in — fast enough for a live operations room.</a:t>
+              <a:t>Minimal-thinking responses stream in, fast enough for a live operations room.</a:t>
             </a:r>
             <a:endParaRPr lang="en-US" sz="1200" dirty="0"/>
           </a:p>
@@ -10855,7 +10855,7 @@
                 <a:ea typeface="Calibri" pitchFamily="34" charset="-122"/>
                 <a:cs typeface="Calibri" pitchFamily="34" charset="-120"/>
               </a:rPr>
-              <a:t>Live answer — grounded in the real Puri ward data (English shown; also Odia / Hindi)</a:t>
+              <a:t>Live answer, grounded in the real Puri ward data (English shown; also Odia / Hindi)</a:t>
             </a:r>
             <a:endParaRPr lang="en-US" sz="1050" dirty="0"/>
           </a:p>
@@ -11798,7 +11798,7 @@
                 <a:ea typeface="Cambria" pitchFamily="34" charset="-122"/>
                 <a:cs typeface="Cambria" pitchFamily="34" charset="-120"/>
               </a:rPr>
-              <a:t>Early warning saves lives — the frontier is assets</a:t>
+              <a:t>Early warning saves lives, the frontier is assets</a:t>
             </a:r>
             <a:endParaRPr lang="en-US" sz="3400" dirty="0"/>
           </a:p>
@@ -11959,7 +11959,7 @@
                 <a:ea typeface="Calibri" pitchFamily="34" charset="-122"/>
                 <a:cs typeface="Calibri" pitchFamily="34" charset="-120"/>
               </a:rPr>
-              <a:t>see which shelters are reachable and which roads are severed — before deploying.</a:t>
+              <a:t>see which shelters are reachable and which roads are severed, before deploying.</a:t>
             </a:r>
             <a:endParaRPr lang="en-US" sz="1250" dirty="0"/>
           </a:p>

</xml_diff>

<commit_message>
Agent guardrails + clean output, map-click place names, GEE-credentials framing, natural-flow video
- AI advisor: structured system prompt with scope/injection/safety guardrails;
  plain-text output (strip markdown so no ** shows); off-topic questions declined
- Map click now reverse-geocodes to a place name (BigDataCloud), not just coords
- Frame GEE as built and activating with Earth Engine credentials, across deck,
  README and the video's closing card (matches the problem statement)
- Rebuild demo video with scene pacing tuned to narration for natural flow and
  the cleaned agent output; refresh deck AI-advisor screenshot

Co-Authored-By: Claude Opus 4.8 (1M context) <noreply@anthropic.com>
</commit_message>
<xml_diff>
--- a/demo/PRAHARI_Orbital_Console.pptx
+++ b/demo/PRAHARI_Orbital_Console.pptx
@@ -2467,7 +2467,7 @@
                 <a:ea typeface="Calibri" pitchFamily="34" charset="-122"/>
                 <a:cs typeface="Calibri" pitchFamily="34" charset="-120"/>
               </a:rPr>
-              <a:t>Turning satellite data into anticipatory action, from an orbital 3D globe to sub-meter streets, with a live Gemini AI advisor and Google Earth Engine hazard layers.</a:t>
+              <a:t>Turning satellite data into anticipatory action, from an orbital 3D globe to sub-meter streets, with a live Gemini AI advisor and plug-in Google Earth Engine hazard layers.</a:t>
             </a:r>
             <a:endParaRPr lang="en-US" sz="1600" dirty="0"/>
           </a:p>
@@ -3560,7 +3560,7 @@
                 <a:ea typeface="Calibri" pitchFamily="34" charset="-122"/>
                 <a:cs typeface="Calibri" pitchFamily="34" charset="-120"/>
               </a:rPr>
-              <a:t>Google Earth Engine (SAR, DEM, WorldPop)</a:t>
+              <a:t>Google Earth Engine (SAR, DEM, WorldPop), plug-in with credentials</a:t>
             </a:r>
             <a:endParaRPr lang="en-US" sz="1250" dirty="0"/>
           </a:p>
@@ -4103,7 +4103,7 @@
                 <a:ea typeface="Cambria" pitchFamily="34" charset="-122"/>
                 <a:cs typeface="Cambria" pitchFamily="34" charset="-120"/>
               </a:rPr>
-              <a:t>Live GEE tiles by default</a:t>
+              <a:t>GEE tiles, plug-in with credentials</a:t>
             </a:r>
             <a:endParaRPr lang="en-US" sz="1600" dirty="0"/>
           </a:p>
@@ -4145,7 +4145,7 @@
                 <a:ea typeface="Calibri" pitchFamily="34" charset="-122"/>
                 <a:cs typeface="Calibri" pitchFamily="34" charset="-120"/>
               </a:rPr>
-              <a:t>Ship the Cloud Run tile proxy so SAR flood &amp; DEM surge stream in without setup.</a:t>
+              <a:t>The Code Editor script and Cloud Run tile proxy are built; SAR flood &amp; DEM surge stream in once Earth Engine credentials are added.</a:t>
             </a:r>
             <a:endParaRPr lang="en-US" sz="1250" dirty="0"/>
           </a:p>
@@ -6928,7 +6928,7 @@
                 <a:ea typeface="Calibri" pitchFamily="34" charset="-122"/>
                 <a:cs typeface="Calibri" pitchFamily="34" charset="-120"/>
               </a:rPr>
-              <a:t>Real storm tracks, hydrodynamic surge &amp; flood zones, plus live Google Earth Engine SAR / DEM overlays.</a:t>
+              <a:t>Real storm tracks, hydrodynamic surge &amp; flood zones, plus Google Earth Engine SAR / DEM overlays that activate with Earth Engine credentials.</a:t>
             </a:r>
             <a:endParaRPr lang="en-US" sz="1250" dirty="0"/>
           </a:p>
@@ -8127,7 +8127,7 @@
                 <a:ea typeface="Calibri" pitchFamily="34" charset="-122"/>
                 <a:cs typeface="Calibri" pitchFamily="34" charset="-120"/>
               </a:rPr>
-              <a:t>Live Sentinel-1 SAR flood + Copernicus DEM surge overlays, genuine satellite analysis, not decorative imagery.</a:t>
+              <a:t>Sentinel-1 SAR flood + Copernicus DEM surge, built and ready to stream once Earth Engine credentials are added, not decorative imagery.</a:t>
             </a:r>
             <a:endParaRPr lang="en-US" sz="1100" dirty="0"/>
           </a:p>
@@ -9225,7 +9225,7 @@
                 <a:ea typeface="Calibri" pitchFamily="34" charset="-122"/>
                 <a:cs typeface="Calibri" pitchFamily="34" charset="-120"/>
               </a:rPr>
-              <a:t>Live Google Earth Engine overlay, Sentinel-1 SAR flood extent, Copernicus DEM surge exposure, WorldPop population.</a:t>
+              <a:t>Google Earth Engine overlay (Sentinel-1 SAR flood, Copernicus DEM surge, WorldPop), activated with Earth Engine credentials.</a:t>
             </a:r>
             <a:endParaRPr lang="en-US" sz="1200" dirty="0"/>
           </a:p>

</xml_diff>